<commit_message>
Update PPTX and PDF presentations with embedded screenshots, dedicated frontend and backend architecture slides
</commit_message>
<xml_diff>
--- a/Break-Even-Project-Presentation.pptx
+++ b/Break-Even-Project-Presentation.pptx
@@ -3147,8 +3147,8 @@
         </p:nvSpPr>
         <p:spPr>
           <a:xfrm>
-            <a:off x="1188720" y="1188720"/>
-            <a:ext cx="9784080" cy="2011680"/>
+            <a:off x="1097280" y="1097280"/>
+            <a:ext cx="5943600" cy="2011680"/>
           </a:xfrm>
           <a:prstGeom prst="rect">
             <a:avLst/>
@@ -3162,7 +3162,7 @@
           <a:lstStyle/>
           <a:p>
             <a:pPr>
-              <a:defRPr sz="1300" b="1">
+              <a:defRPr sz="1200" b="1">
                 <a:solidFill>
                   <a:srgbClr val="2563EB"/>
                 </a:solidFill>
@@ -3175,9 +3175,9 @@
           <a:p>
             <a:pPr>
               <a:spcBef>
-                <a:spcPts val="800"/>
-              </a:spcBef>
-              <a:defRPr sz="3200" b="1">
+                <a:spcPts val="600"/>
+              </a:spcBef>
+              <a:defRPr sz="2800" b="1">
                 <a:solidFill>
                   <a:srgbClr val="0F172A"/>
                 </a:solidFill>
@@ -3190,16 +3190,16 @@
           <a:p>
             <a:pPr>
               <a:spcBef>
-                <a:spcPts val="600"/>
-              </a:spcBef>
-              <a:defRPr sz="1500">
+                <a:spcPts val="400"/>
+              </a:spcBef>
+              <a:defRPr sz="1300">
                 <a:solidFill>
                   <a:srgbClr val="64748B"/>
                 </a:solidFill>
               </a:defRPr>
             </a:pPr>
             <a:r>
-              <a:t>A Full-Stack Financial Decision Support System with Real-Time SVG Visualizations &amp; What-If Simulations</a:t>
+              <a:t>Full-Stack Financial Modeling Web App with Real-Time SVG Charts &amp; Multi-Runtime Backend</a:t>
             </a:r>
           </a:p>
         </p:txBody>
@@ -3212,8 +3212,8 @@
         </p:nvSpPr>
         <p:spPr>
           <a:xfrm>
-            <a:off x="1188720" y="3474720"/>
-            <a:ext cx="4754880" cy="2103120"/>
+            <a:off x="1097280" y="3291840"/>
+            <a:ext cx="5303520" cy="2468880"/>
           </a:xfrm>
           <a:prstGeom prst="roundRect">
             <a:avLst/>
@@ -3242,196 +3242,121 @@
           </a:fontRef>
         </p:style>
         <p:txBody>
-          <a:bodyPr rtlCol="0" anchor="ctr" wrap="square" lIns="274320" tIns="228600"/>
+          <a:bodyPr rtlCol="0" anchor="ctr" wrap="square" lIns="228600" tIns="182880"/>
           <a:lstStyle/>
           <a:p>
             <a:pPr algn="ctr">
-              <a:defRPr sz="1000" b="1">
+              <a:defRPr sz="1100" b="1">
                 <a:solidFill>
                   <a:srgbClr val="2563EB"/>
                 </a:solidFill>
               </a:defRPr>
             </a:pPr>
             <a:r>
-              <a:t>PROJECT METADATA</a:t>
-            </a:r>
-          </a:p>
-          <a:p>
-            <a:pPr>
-              <a:spcBef>
-                <a:spcPts val="400"/>
-              </a:spcBef>
-              <a:defRPr sz="1100">
-                <a:solidFill>
-                  <a:srgbClr val="0F172A"/>
-                </a:solidFill>
-              </a:defRPr>
-            </a:pPr>
-            <a:r>
-              <a:t>Domain: FinTech / Financial Engineering &amp; Web Systems</a:t>
-            </a:r>
-          </a:p>
-          <a:p>
-            <a:pPr>
-              <a:spcBef>
-                <a:spcPts val="400"/>
-              </a:spcBef>
-              <a:defRPr sz="1100">
-                <a:solidFill>
-                  <a:srgbClr val="0F172A"/>
-                </a:solidFill>
-              </a:defRPr>
-            </a:pPr>
-            <a:r>
-              <a:t>Developer: arjun2007arush2011-max</a:t>
-            </a:r>
-          </a:p>
-          <a:p>
-            <a:pPr>
-              <a:spcBef>
-                <a:spcPts val="400"/>
-              </a:spcBef>
-              <a:defRPr sz="1100">
-                <a:solidFill>
-                  <a:srgbClr val="0F172A"/>
-                </a:solidFill>
-              </a:defRPr>
-            </a:pPr>
-            <a:r>
-              <a:t>Architecture: Client-Side Zero-Dependency + REST Backend</a:t>
-            </a:r>
-          </a:p>
-          <a:p>
-            <a:pPr>
-              <a:spcBef>
-                <a:spcPts val="400"/>
-              </a:spcBef>
-              <a:defRPr sz="1100">
-                <a:solidFill>
-                  <a:srgbClr val="0F172A"/>
-                </a:solidFill>
-              </a:defRPr>
-            </a:pPr>
-            <a:r>
-              <a:t>Storage: Dual-Mode (SQLite3 Database &amp; LocalStorage)</a:t>
-            </a:r>
-          </a:p>
-        </p:txBody>
-      </p:sp>
-      <p:sp>
-        <p:nvSpPr>
-          <p:cNvPr id="5" name="Rounded Rectangle 4"/>
-          <p:cNvSpPr/>
+              <a:t>PROJECT SPECIFICATIONS</a:t>
+            </a:r>
+          </a:p>
+          <a:p>
+            <a:pPr>
+              <a:spcBef>
+                <a:spcPts val="300"/>
+              </a:spcBef>
+              <a:defRPr sz="1000">
+                <a:solidFill>
+                  <a:srgbClr val="0F172A"/>
+                </a:solidFill>
+              </a:defRPr>
+            </a:pPr>
+            <a:r>
+              <a:t>Student / Developer: arjun2007arush2011-max</a:t>
+            </a:r>
+          </a:p>
+          <a:p>
+            <a:pPr>
+              <a:spcBef>
+                <a:spcPts val="300"/>
+              </a:spcBef>
+              <a:defRPr sz="1000">
+                <a:solidFill>
+                  <a:srgbClr val="0F172A"/>
+                </a:solidFill>
+              </a:defRPr>
+            </a:pPr>
+            <a:r>
+              <a:t>Live Web Application: https://arjun2007arush2011-max.github.io/break_even_point/</a:t>
+            </a:r>
+          </a:p>
+          <a:p>
+            <a:pPr>
+              <a:spcBef>
+                <a:spcPts val="300"/>
+              </a:spcBef>
+              <a:defRPr sz="1000">
+                <a:solidFill>
+                  <a:srgbClr val="0F172A"/>
+                </a:solidFill>
+              </a:defRPr>
+            </a:pPr>
+            <a:r>
+              <a:t>GitHub Repository: https://github.com/arjun2007arush2011-max/break_even_point</a:t>
+            </a:r>
+          </a:p>
+          <a:p>
+            <a:pPr>
+              <a:spcBef>
+                <a:spcPts val="300"/>
+              </a:spcBef>
+              <a:defRPr sz="1000">
+                <a:solidFill>
+                  <a:srgbClr val="0F172A"/>
+                </a:solidFill>
+              </a:defRPr>
+            </a:pPr>
+            <a:r>
+              <a:t>Domain: FinTech &amp; Decision Support Systems</a:t>
+            </a:r>
+          </a:p>
+          <a:p>
+            <a:pPr>
+              <a:spcBef>
+                <a:spcPts val="300"/>
+              </a:spcBef>
+              <a:defRPr sz="1000">
+                <a:solidFill>
+                  <a:srgbClr val="0F172A"/>
+                </a:solidFill>
+              </a:defRPr>
+            </a:pPr>
+            <a:r>
+              <a:t>Architecture: Client-Side Zero-Dependency + REST Backends</a:t>
+            </a:r>
+          </a:p>
+        </p:txBody>
+      </p:sp>
+      <p:pic>
+        <p:nvPicPr>
+          <p:cNvPr id="5" name="Picture 4" descr="screenshot_dashboard.png"/>
+          <p:cNvPicPr>
+            <a:picLocks noChangeAspect="1"/>
+          </p:cNvPicPr>
           <p:nvPr/>
-        </p:nvSpPr>
+        </p:nvPicPr>
+        <p:blipFill>
+          <a:blip r:embed="rId2"/>
+          <a:stretch>
+            <a:fillRect/>
+          </a:stretch>
+        </p:blipFill>
         <p:spPr>
           <a:xfrm>
-            <a:off x="6217920" y="3474720"/>
-            <a:ext cx="4754880" cy="2103120"/>
+            <a:off x="6675120" y="1280160"/>
+            <a:ext cx="4389120" cy="4389120"/>
           </a:xfrm>
-          <a:prstGeom prst="roundRect">
+          <a:prstGeom prst="rect">
             <a:avLst/>
           </a:prstGeom>
-          <a:solidFill>
-            <a:srgbClr val="FFFFFF"/>
-          </a:solidFill>
-          <a:ln w="19050">
-            <a:solidFill>
-              <a:srgbClr val="E2E8F0"/>
-            </a:solidFill>
-          </a:ln>
         </p:spPr>
-        <p:style>
-          <a:lnRef idx="1">
-            <a:schemeClr val="accent1"/>
-          </a:lnRef>
-          <a:fillRef idx="3">
-            <a:schemeClr val="accent1"/>
-          </a:fillRef>
-          <a:effectRef idx="2">
-            <a:schemeClr val="accent1"/>
-          </a:effectRef>
-          <a:fontRef idx="minor">
-            <a:schemeClr val="lt1"/>
-          </a:fontRef>
-        </p:style>
-        <p:txBody>
-          <a:bodyPr rtlCol="0" anchor="ctr" wrap="square" lIns="274320" tIns="228600"/>
-          <a:lstStyle/>
-          <a:p>
-            <a:pPr algn="ctr">
-              <a:defRPr sz="1000" b="1">
-                <a:solidFill>
-                  <a:srgbClr val="059669"/>
-                </a:solidFill>
-              </a:defRPr>
-            </a:pPr>
-            <a:r>
-              <a:t>DEPLOYMENT &amp; ACCESS LINKS</a:t>
-            </a:r>
-          </a:p>
-          <a:p>
-            <a:pPr>
-              <a:spcBef>
-                <a:spcPts val="400"/>
-              </a:spcBef>
-              <a:defRPr sz="1100">
-                <a:solidFill>
-                  <a:srgbClr val="0F172A"/>
-                </a:solidFill>
-              </a:defRPr>
-            </a:pPr>
-            <a:r>
-              <a:t>Live Web App: https://arjun2007arush2011-max.github.io/break_even_point/</a:t>
-            </a:r>
-          </a:p>
-          <a:p>
-            <a:pPr>
-              <a:spcBef>
-                <a:spcPts val="400"/>
-              </a:spcBef>
-              <a:defRPr sz="1100">
-                <a:solidFill>
-                  <a:srgbClr val="0F172A"/>
-                </a:solidFill>
-              </a:defRPr>
-            </a:pPr>
-            <a:r>
-              <a:t>GitHub Repo: https://github.com/arjun2007arush2011-max/break_even_point</a:t>
-            </a:r>
-          </a:p>
-          <a:p>
-            <a:pPr>
-              <a:spcBef>
-                <a:spcPts val="400"/>
-              </a:spcBef>
-              <a:defRPr sz="1100">
-                <a:solidFill>
-                  <a:srgbClr val="0F172A"/>
-                </a:solidFill>
-              </a:defRPr>
-            </a:pPr>
-            <a:r>
-              <a:t>Backends: Python 3, Ruby WEBrick, Node.js Native HTTP</a:t>
-            </a:r>
-          </a:p>
-          <a:p>
-            <a:pPr>
-              <a:spcBef>
-                <a:spcPts val="400"/>
-              </a:spcBef>
-              <a:defRPr sz="1100">
-                <a:solidFill>
-                  <a:srgbClr val="0F172A"/>
-                </a:solidFill>
-              </a:defRPr>
-            </a:pPr>
-            <a:r>
-              <a:t>Status: Live &amp; Globally Deployed via GitHub Pages</a:t>
-            </a:r>
-          </a:p>
-        </p:txBody>
-      </p:sp>
+      </p:pic>
     </p:spTree>
   </p:cSld>
   <p:clrMapOvr>
@@ -3558,7 +3483,7 @@
           </a:fontRef>
         </p:style>
         <p:txBody>
-          <a:bodyPr rtlCol="0" anchor="ctr" wrap="square" lIns="320040" tIns="320040"/>
+          <a:bodyPr rtlCol="0" anchor="ctr" wrap="square" lIns="320040" tIns="274320"/>
           <a:lstStyle/>
           <a:p>
             <a:pPr algn="ctr">
@@ -3577,74 +3502,59 @@
               <a:spcBef>
                 <a:spcPts val="800"/>
               </a:spcBef>
-              <a:defRPr sz="1250">
-                <a:solidFill>
-                  <a:srgbClr val="0F172A"/>
-                </a:solidFill>
-              </a:defRPr>
-            </a:pPr>
-            <a:r>
-              <a:t>Over 65% of small business and startup failures stem from premature cost miscalculations and a lack of real-time visibility into operational break-even points.</a:t>
-            </a:r>
-          </a:p>
-          <a:p>
-            <a:pPr>
-              <a:spcBef>
-                <a:spcPts val="600"/>
-              </a:spcBef>
-              <a:defRPr sz="1100">
-                <a:solidFill>
-                  <a:srgbClr val="64748B"/>
-                </a:solidFill>
-              </a:defRPr>
-            </a:pPr>
-            <a:r>
-              <a:t>• Static Spreadsheets are Prone to Errors: Traditional Excel sheets lack dynamic visual feedback and are cumbersome to update on mobile devices.</a:t>
-            </a:r>
-          </a:p>
-          <a:p>
-            <a:pPr>
-              <a:spcBef>
-                <a:spcPts val="600"/>
-              </a:spcBef>
-              <a:defRPr sz="1100">
-                <a:solidFill>
-                  <a:srgbClr val="64748B"/>
-                </a:solidFill>
-              </a:defRPr>
-            </a:pPr>
-            <a:r>
-              <a:t>• Unrealistic Pricing Decisions: Entrepreneurs frequently underprice products without understanding how variable costs eat into contribution margins.</a:t>
-            </a:r>
-          </a:p>
-          <a:p>
-            <a:pPr>
-              <a:spcBef>
-                <a:spcPts val="600"/>
-              </a:spcBef>
-              <a:defRPr sz="1100">
-                <a:solidFill>
-                  <a:srgbClr val="64748B"/>
-                </a:solidFill>
-              </a:defRPr>
-            </a:pPr>
-            <a:r>
-              <a:t>• No What-If Sensitivity Testing: Business owners cannot easily simulate how a 10% inflation spike in variable costs or rent shifts required sales volume.</a:t>
-            </a:r>
-          </a:p>
-          <a:p>
-            <a:pPr>
-              <a:spcBef>
-                <a:spcPts val="600"/>
-              </a:spcBef>
-              <a:defRPr sz="1100">
-                <a:solidFill>
-                  <a:srgbClr val="64748B"/>
-                </a:solidFill>
-              </a:defRPr>
-            </a:pPr>
-            <a:r>
-              <a:t>• Heavy Dependency Bloat: Existing online tools require heavy, tracking-laden frameworks, external CDNs, or monthly subscriptions.</a:t>
+              <a:defRPr sz="1050">
+                <a:solidFill>
+                  <a:srgbClr val="0F172A"/>
+                </a:solidFill>
+              </a:defRPr>
+            </a:pPr>
+            <a:r>
+              <a:t>• High Startup Mortality: Over 65% of small business failures stem from inaccurate cost estimation and a failure to identify break-even volume early.</a:t>
+            </a:r>
+          </a:p>
+          <a:p>
+            <a:pPr>
+              <a:spcBef>
+                <a:spcPts val="800"/>
+              </a:spcBef>
+              <a:defRPr sz="1050">
+                <a:solidFill>
+                  <a:srgbClr val="0F172A"/>
+                </a:solidFill>
+              </a:defRPr>
+            </a:pPr>
+            <a:r>
+              <a:t>• Spreadsheet Fragility: Static Excel files lack interactive real-time visual curves and are error-prone on mobile or collaborative settings.</a:t>
+            </a:r>
+          </a:p>
+          <a:p>
+            <a:pPr>
+              <a:spcBef>
+                <a:spcPts val="800"/>
+              </a:spcBef>
+              <a:defRPr sz="1050">
+                <a:solidFill>
+                  <a:srgbClr val="0F172A"/>
+                </a:solidFill>
+              </a:defRPr>
+            </a:pPr>
+            <a:r>
+              <a:t>• Blind Pricing Strategies: Entrepreneurs frequently set prices without analyzing per-unit variable costs, selling products at an unseen structural loss.</a:t>
+            </a:r>
+          </a:p>
+          <a:p>
+            <a:pPr>
+              <a:spcBef>
+                <a:spcPts val="800"/>
+              </a:spcBef>
+              <a:defRPr sz="1050">
+                <a:solidFill>
+                  <a:srgbClr val="0F172A"/>
+                </a:solidFill>
+              </a:defRPr>
+            </a:pPr>
+            <a:r>
+              <a:t>• Lack of Sensitivity Analysis: Traditional tools fail to simulate what happens when supplier variable costs rise by 15% or rent increases by 20%.</a:t>
             </a:r>
           </a:p>
         </p:txBody>
@@ -3687,7 +3597,7 @@
           </a:fontRef>
         </p:style>
         <p:txBody>
-          <a:bodyPr rtlCol="0" anchor="ctr" wrap="square" lIns="320040" tIns="320040"/>
+          <a:bodyPr rtlCol="0" anchor="ctr" wrap="square" lIns="320040" tIns="274320"/>
           <a:lstStyle/>
           <a:p>
             <a:pPr algn="ctr">
@@ -3698,7 +3608,7 @@
               </a:defRPr>
             </a:pPr>
             <a:r>
-              <a:t>KEY PROJECT OBJECTIVES</a:t>
+              <a:t>PROJECT OBJECTIVES</a:t>
             </a:r>
           </a:p>
           <a:p>
@@ -3706,14 +3616,14 @@
               <a:spcBef>
                 <a:spcPts val="800"/>
               </a:spcBef>
-              <a:defRPr sz="1100">
-                <a:solidFill>
-                  <a:srgbClr val="0F172A"/>
-                </a:solidFill>
-              </a:defRPr>
-            </a:pPr>
-            <a:r>
-              <a:t>✔ Zero-Dependency Architecture: Build a completely self-contained solution running natively without third-party JS libraries or CDN dependencies.</a:t>
+              <a:defRPr sz="1050">
+                <a:solidFill>
+                  <a:srgbClr val="0F172A"/>
+                </a:solidFill>
+              </a:defRPr>
+            </a:pPr>
+            <a:r>
+              <a:t>✔ Zero-Dependency Engineering: Deliver a self-contained, lightweight financial simulator operating without third-party frameworks or CDNs.</a:t>
             </a:r>
           </a:p>
           <a:p>
@@ -3721,14 +3631,14 @@
               <a:spcBef>
                 <a:spcPts val="800"/>
               </a:spcBef>
-              <a:defRPr sz="1100">
-                <a:solidFill>
-                  <a:srgbClr val="0F172A"/>
-                </a:solidFill>
-              </a:defRPr>
-            </a:pPr>
-            <a:r>
-              <a:t>✔ Interactive SVG Graphics: Generate custom, scalable vector charts depicting Total Revenue, Total Cost, Fixed Cost lines, and shaded profit/loss zones.</a:t>
+              <a:defRPr sz="1050">
+                <a:solidFill>
+                  <a:srgbClr val="0F172A"/>
+                </a:solidFill>
+              </a:defRPr>
+            </a:pPr>
+            <a:r>
+              <a:t>✔ Dynamic SVG Visualization: Render real-time cost curves, break-even intersection callouts, and shaded loss/profit zones.</a:t>
             </a:r>
           </a:p>
           <a:p>
@@ -3736,14 +3646,14 @@
               <a:spcBef>
                 <a:spcPts val="800"/>
               </a:spcBef>
-              <a:defRPr sz="1100">
-                <a:solidFill>
-                  <a:srgbClr val="0F172A"/>
-                </a:solidFill>
-              </a:defRPr>
-            </a:pPr>
-            <a:r>
-              <a:t>✔ Real-Time What-If Sensitivity: Provide instantaneous sliders (-50% to +50%) and sensitivity matrices to stress-test cost and price variables.</a:t>
+              <a:defRPr sz="1050">
+                <a:solidFill>
+                  <a:srgbClr val="0F172A"/>
+                </a:solidFill>
+              </a:defRPr>
+            </a:pPr>
+            <a:r>
+              <a:t>✔ Real-Time What-If Simulations: Provide instant slider testing (-50% to +50%) and sensitivity tables to evaluate cost risks.</a:t>
             </a:r>
           </a:p>
           <a:p>
@@ -3751,14 +3661,14 @@
               <a:spcBef>
                 <a:spcPts val="800"/>
               </a:spcBef>
-              <a:defRPr sz="1100">
-                <a:solidFill>
-                  <a:srgbClr val="0F172A"/>
-                </a:solidFill>
-              </a:defRPr>
-            </a:pPr>
-            <a:r>
-              <a:t>✔ Multi-Tier REST Integration: Implement backend APIs in Python, Ruby, and Node.js with persistent SQLite3 storage alongside graceful offline mode.</a:t>
+              <a:defRPr sz="1050">
+                <a:solidFill>
+                  <a:srgbClr val="0F172A"/>
+                </a:solidFill>
+              </a:defRPr>
+            </a:pPr>
+            <a:r>
+              <a:t>✔ Multi-Tier REST Integration: Implement backend APIs across Python, Ruby, and Node.js with SQLite3 database persistence.</a:t>
             </a:r>
           </a:p>
           <a:p>
@@ -3766,14 +3676,14 @@
               <a:spcBef>
                 <a:spcPts val="800"/>
               </a:spcBef>
-              <a:defRPr sz="1100">
-                <a:solidFill>
-                  <a:srgbClr val="0F172A"/>
-                </a:solidFill>
-              </a:defRPr>
-            </a:pPr>
-            <a:r>
-              <a:t>✔ Executive Print Reporting: Provide clean, letterheaded executive feasibility printouts for stakeholders and financial presentations.</a:t>
+              <a:defRPr sz="1050">
+                <a:solidFill>
+                  <a:srgbClr val="0F172A"/>
+                </a:solidFill>
+              </a:defRPr>
+            </a:pPr>
+            <a:r>
+              <a:t>✔ Executive Feasibility Reporting: Support one-click printable reports formatted with professional letterheads and KPI matrices.</a:t>
             </a:r>
           </a:p>
         </p:txBody>
@@ -3826,7 +3736,7 @@
               </a:defRPr>
             </a:pPr>
             <a:r>
-              <a:t>TECHNICAL DESIGN</a:t>
+              <a:t>FRONTEND TIER</a:t>
             </a:r>
           </a:p>
         </p:txBody>
@@ -3861,1507 +3771,7 @@
               </a:defRPr>
             </a:pPr>
             <a:r>
-              <a:t>System Architecture &amp; Technology Stack</a:t>
-            </a:r>
-          </a:p>
-        </p:txBody>
-      </p:sp>
-      <p:sp>
-        <p:nvSpPr>
-          <p:cNvPr id="4" name="Rounded Rectangle 3"/>
-          <p:cNvSpPr/>
-          <p:nvPr/>
-        </p:nvSpPr>
-        <p:spPr>
-          <a:xfrm>
-            <a:off x="731520" y="1463040"/>
-            <a:ext cx="3383280" cy="4663440"/>
-          </a:xfrm>
-          <a:prstGeom prst="roundRect">
-            <a:avLst/>
-          </a:prstGeom>
-          <a:solidFill>
-            <a:srgbClr val="FFFFFF"/>
-          </a:solidFill>
-          <a:ln w="19050">
-            <a:solidFill>
-              <a:srgbClr val="E2E8F0"/>
-            </a:solidFill>
-          </a:ln>
-        </p:spPr>
-        <p:style>
-          <a:lnRef idx="1">
-            <a:schemeClr val="accent1"/>
-          </a:lnRef>
-          <a:fillRef idx="3">
-            <a:schemeClr val="accent1"/>
-          </a:fillRef>
-          <a:effectRef idx="2">
-            <a:schemeClr val="accent1"/>
-          </a:effectRef>
-          <a:fontRef idx="minor">
-            <a:schemeClr val="lt1"/>
-          </a:fontRef>
-        </p:style>
-        <p:txBody>
-          <a:bodyPr rtlCol="0" anchor="ctr" wrap="square" lIns="228600" tIns="274320"/>
-          <a:lstStyle/>
-          <a:p>
-            <a:pPr algn="ctr">
-              <a:defRPr sz="1200" b="1">
-                <a:solidFill>
-                  <a:srgbClr val="2563EB"/>
-                </a:solidFill>
-              </a:defRPr>
-            </a:pPr>
-            <a:r>
-              <a:t>FRONTEND PRESENTATION</a:t>
-            </a:r>
-          </a:p>
-          <a:p>
-            <a:pPr>
-              <a:spcBef>
-                <a:spcPts val="800"/>
-              </a:spcBef>
-              <a:defRPr sz="1050">
-                <a:solidFill>
-                  <a:srgbClr val="0F172A"/>
-                </a:solidFill>
-              </a:defRPr>
-            </a:pPr>
-            <a:r>
-              <a:t>• Vanilla ES5 JavaScript for 100% universal browser compatibility (no transpilation required).</a:t>
-            </a:r>
-          </a:p>
-          <a:p>
-            <a:pPr>
-              <a:spcBef>
-                <a:spcPts val="800"/>
-              </a:spcBef>
-              <a:defRPr sz="1050">
-                <a:solidFill>
-                  <a:srgbClr val="0F172A"/>
-                </a:solidFill>
-              </a:defRPr>
-            </a:pPr>
-            <a:r>
-              <a:t>• Responsive Two-Column Grid layout transitioning smoothly to single-column on mobile viewports.</a:t>
-            </a:r>
-          </a:p>
-          <a:p>
-            <a:pPr>
-              <a:spcBef>
-                <a:spcPts val="800"/>
-              </a:spcBef>
-              <a:defRPr sz="1050">
-                <a:solidFill>
-                  <a:srgbClr val="0F172A"/>
-                </a:solidFill>
-              </a:defRPr>
-            </a:pPr>
-            <a:r>
-              <a:t>• CSS Custom Properties (Variables) supporting instant Dark / Light theme toggling.</a:t>
-            </a:r>
-          </a:p>
-          <a:p>
-            <a:pPr>
-              <a:spcBef>
-                <a:spcPts val="800"/>
-              </a:spcBef>
-              <a:defRPr sz="1050">
-                <a:solidFill>
-                  <a:srgbClr val="0F172A"/>
-                </a:solidFill>
-              </a:defRPr>
-            </a:pPr>
-            <a:r>
-              <a:t>• Accessible semantic markup with ARIA roles and validation tooltips.</a:t>
-            </a:r>
-          </a:p>
-        </p:txBody>
-      </p:sp>
-      <p:sp>
-        <p:nvSpPr>
-          <p:cNvPr id="5" name="Rounded Rectangle 4"/>
-          <p:cNvSpPr/>
-          <p:nvPr/>
-        </p:nvSpPr>
-        <p:spPr>
-          <a:xfrm>
-            <a:off x="4389120" y="1463040"/>
-            <a:ext cx="3383280" cy="4663440"/>
-          </a:xfrm>
-          <a:prstGeom prst="roundRect">
-            <a:avLst/>
-          </a:prstGeom>
-          <a:solidFill>
-            <a:srgbClr val="FFFFFF"/>
-          </a:solidFill>
-          <a:ln w="19050">
-            <a:solidFill>
-              <a:srgbClr val="E2E8F0"/>
-            </a:solidFill>
-          </a:ln>
-        </p:spPr>
-        <p:style>
-          <a:lnRef idx="1">
-            <a:schemeClr val="accent1"/>
-          </a:lnRef>
-          <a:fillRef idx="3">
-            <a:schemeClr val="accent1"/>
-          </a:fillRef>
-          <a:effectRef idx="2">
-            <a:schemeClr val="accent1"/>
-          </a:effectRef>
-          <a:fontRef idx="minor">
-            <a:schemeClr val="lt1"/>
-          </a:fontRef>
-        </p:style>
-        <p:txBody>
-          <a:bodyPr rtlCol="0" anchor="ctr" wrap="square" lIns="228600" tIns="274320"/>
-          <a:lstStyle/>
-          <a:p>
-            <a:pPr algn="ctr">
-              <a:defRPr sz="1200" b="1">
-                <a:solidFill>
-                  <a:srgbClr val="7C3AED"/>
-                </a:solidFill>
-              </a:defRPr>
-            </a:pPr>
-            <a:r>
-              <a:t>VISUALIZATION &amp; ENGINE</a:t>
-            </a:r>
-          </a:p>
-          <a:p>
-            <a:pPr>
-              <a:spcBef>
-                <a:spcPts val="800"/>
-              </a:spcBef>
-              <a:defRPr sz="1050">
-                <a:solidFill>
-                  <a:srgbClr val="0F172A"/>
-                </a:solidFill>
-              </a:defRPr>
-            </a:pPr>
-            <a:r>
-              <a:t>• Custom Inline SVG Engine: Mathematical coordinate projection without Chart.js or D3.js.</a:t>
-            </a:r>
-          </a:p>
-          <a:p>
-            <a:pPr>
-              <a:spcBef>
-                <a:spcPts val="800"/>
-              </a:spcBef>
-              <a:defRPr sz="1050">
-                <a:solidFill>
-                  <a:srgbClr val="0F172A"/>
-                </a:solidFill>
-              </a:defRPr>
-            </a:pPr>
-            <a:r>
-              <a:t>• Interactive Crosshair &amp; Hover Tooltip tracking volume, revenue, costs, and profit in real time.</a:t>
-            </a:r>
-          </a:p>
-          <a:p>
-            <a:pPr>
-              <a:spcBef>
-                <a:spcPts val="800"/>
-              </a:spcBef>
-              <a:defRPr sz="1050">
-                <a:solidFill>
-                  <a:srgbClr val="0F172A"/>
-                </a:solidFill>
-              </a:defRPr>
-            </a:pPr>
-            <a:r>
-              <a:t>• Pure Mathematical Model: model(F, P, V, Q, T) isolating calculation logic from DOM manipulation.</a:t>
-            </a:r>
-          </a:p>
-          <a:p>
-            <a:pPr>
-              <a:spcBef>
-                <a:spcPts val="800"/>
-              </a:spcBef>
-              <a:defRPr sz="1050">
-                <a:solidFill>
-                  <a:srgbClr val="0F172A"/>
-                </a:solidFill>
-              </a:defRPr>
-            </a:pPr>
-            <a:r>
-              <a:t>• Client-Side SHA-256 Hashing using Web Crypto API (crypto.subtle) with pure JS fallback.</a:t>
-            </a:r>
-          </a:p>
-        </p:txBody>
-      </p:sp>
-      <p:sp>
-        <p:nvSpPr>
-          <p:cNvPr id="6" name="Rounded Rectangle 5"/>
-          <p:cNvSpPr/>
-          <p:nvPr/>
-        </p:nvSpPr>
-        <p:spPr>
-          <a:xfrm>
-            <a:off x="8046720" y="1463040"/>
-            <a:ext cx="3383280" cy="4663440"/>
-          </a:xfrm>
-          <a:prstGeom prst="roundRect">
-            <a:avLst/>
-          </a:prstGeom>
-          <a:solidFill>
-            <a:srgbClr val="FFFFFF"/>
-          </a:solidFill>
-          <a:ln w="19050">
-            <a:solidFill>
-              <a:srgbClr val="E2E8F0"/>
-            </a:solidFill>
-          </a:ln>
-        </p:spPr>
-        <p:style>
-          <a:lnRef idx="1">
-            <a:schemeClr val="accent1"/>
-          </a:lnRef>
-          <a:fillRef idx="3">
-            <a:schemeClr val="accent1"/>
-          </a:fillRef>
-          <a:effectRef idx="2">
-            <a:schemeClr val="accent1"/>
-          </a:effectRef>
-          <a:fontRef idx="minor">
-            <a:schemeClr val="lt1"/>
-          </a:fontRef>
-        </p:style>
-        <p:txBody>
-          <a:bodyPr rtlCol="0" anchor="ctr" wrap="square" lIns="228600" tIns="274320"/>
-          <a:lstStyle/>
-          <a:p>
-            <a:pPr algn="ctr">
-              <a:defRPr sz="1200" b="1">
-                <a:solidFill>
-                  <a:srgbClr val="059669"/>
-                </a:solidFill>
-              </a:defRPr>
-            </a:pPr>
-            <a:r>
-              <a:t>BACKEND &amp; PERSISTENCE</a:t>
-            </a:r>
-          </a:p>
-          <a:p>
-            <a:pPr>
-              <a:spcBef>
-                <a:spcPts val="800"/>
-              </a:spcBef>
-              <a:defRPr sz="1050">
-                <a:solidFill>
-                  <a:srgbClr val="0F172A"/>
-                </a:solidFill>
-              </a:defRPr>
-            </a:pPr>
-            <a:r>
-              <a:t>• Triple-Runtime REST APIs: Implemented in Ruby (WEBrick), Python 3 (http.server), and Node.js.</a:t>
-            </a:r>
-          </a:p>
-          <a:p>
-            <a:pPr>
-              <a:spcBef>
-                <a:spcPts val="800"/>
-              </a:spcBef>
-              <a:defRPr sz="1050">
-                <a:solidFill>
-                  <a:srgbClr val="0F172A"/>
-                </a:solidFill>
-              </a:defRPr>
-            </a:pPr>
-            <a:r>
-              <a:t>• SQLite3 Relational Storage: Users, Business Profiles, and Cost Driver input tables.</a:t>
-            </a:r>
-          </a:p>
-          <a:p>
-            <a:pPr>
-              <a:spcBef>
-                <a:spcPts val="800"/>
-              </a:spcBef>
-              <a:defRPr sz="1050">
-                <a:solidFill>
-                  <a:srgbClr val="0F172A"/>
-                </a:solidFill>
-              </a:defRPr>
-            </a:pPr>
-            <a:r>
-              <a:t>• Debounced Input Synchronization: Smooth server syncing during rapid slider adjustments.</a:t>
-            </a:r>
-          </a:p>
-          <a:p>
-            <a:pPr>
-              <a:spcBef>
-                <a:spcPts val="800"/>
-              </a:spcBef>
-              <a:defRPr sz="1050">
-                <a:solidFill>
-                  <a:srgbClr val="0F172A"/>
-                </a:solidFill>
-              </a:defRPr>
-            </a:pPr>
-            <a:r>
-              <a:t>• Graceful Offline Fallback: Auto-detects server connection status; falls back to localStorage.</a:t>
-            </a:r>
-          </a:p>
-        </p:txBody>
-      </p:sp>
-    </p:spTree>
-  </p:cSld>
-  <p:clrMapOvr>
-    <a:masterClrMapping/>
-  </p:clrMapOvr>
-</p:sld>
-</file>
-
-<file path=ppt/slides/slide4.xml><?xml version="1.0" encoding="utf-8"?>
-<p:sld xmlns:a="http://schemas.openxmlformats.org/drawingml/2006/main" xmlns:p="http://schemas.openxmlformats.org/presentationml/2006/main" xmlns:r="http://schemas.openxmlformats.org/officeDocument/2006/relationships">
-  <p:cSld>
-    <p:spTree>
-      <p:nvGrpSpPr>
-        <p:cNvPr id="1" name=""/>
-        <p:cNvGrpSpPr/>
-        <p:nvPr/>
-      </p:nvGrpSpPr>
-      <p:grpSpPr/>
-      <p:sp>
-        <p:nvSpPr>
-          <p:cNvPr id="2" name="TextBox 1"/>
-          <p:cNvSpPr txBox="1"/>
-          <p:nvPr/>
-        </p:nvSpPr>
-        <p:spPr>
-          <a:xfrm>
-            <a:off x="731520" y="365760"/>
-            <a:ext cx="10698480" cy="320040"/>
-          </a:xfrm>
-          <a:prstGeom prst="rect">
-            <a:avLst/>
-          </a:prstGeom>
-          <a:noFill/>
-        </p:spPr>
-        <p:txBody>
-          <a:bodyPr wrap="square">
-            <a:spAutoFit/>
-          </a:bodyPr>
-          <a:lstStyle/>
-          <a:p>
-            <a:pPr>
-              <a:defRPr sz="1100" b="1">
-                <a:solidFill>
-                  <a:srgbClr val="2563EB"/>
-                </a:solidFill>
-              </a:defRPr>
-            </a:pPr>
-            <a:r>
-              <a:t>CORE ALGORITHMS</a:t>
-            </a:r>
-          </a:p>
-        </p:txBody>
-      </p:sp>
-      <p:sp>
-        <p:nvSpPr>
-          <p:cNvPr id="3" name="TextBox 2"/>
-          <p:cNvSpPr txBox="1"/>
-          <p:nvPr/>
-        </p:nvSpPr>
-        <p:spPr>
-          <a:xfrm>
-            <a:off x="731520" y="640080"/>
-            <a:ext cx="10698480" cy="594360"/>
-          </a:xfrm>
-          <a:prstGeom prst="rect">
-            <a:avLst/>
-          </a:prstGeom>
-          <a:noFill/>
-        </p:spPr>
-        <p:txBody>
-          <a:bodyPr wrap="square">
-            <a:spAutoFit/>
-          </a:bodyPr>
-          <a:lstStyle/>
-          <a:p>
-            <a:pPr>
-              <a:defRPr sz="2400" b="1">
-                <a:solidFill>
-                  <a:srgbClr val="0F172A"/>
-                </a:solidFill>
-              </a:defRPr>
-            </a:pPr>
-            <a:r>
-              <a:t>Mathematical Formulation &amp; Financial Model</a:t>
-            </a:r>
-          </a:p>
-        </p:txBody>
-      </p:sp>
-      <p:sp>
-        <p:nvSpPr>
-          <p:cNvPr id="4" name="Rounded Rectangle 3"/>
-          <p:cNvSpPr/>
-          <p:nvPr/>
-        </p:nvSpPr>
-        <p:spPr>
-          <a:xfrm>
-            <a:off x="731520" y="1463040"/>
-            <a:ext cx="5486400" cy="4663440"/>
-          </a:xfrm>
-          <a:prstGeom prst="roundRect">
-            <a:avLst/>
-          </a:prstGeom>
-          <a:solidFill>
-            <a:srgbClr val="FFFFFF"/>
-          </a:solidFill>
-          <a:ln w="19050">
-            <a:solidFill>
-              <a:srgbClr val="E2E8F0"/>
-            </a:solidFill>
-          </a:ln>
-        </p:spPr>
-        <p:style>
-          <a:lnRef idx="1">
-            <a:schemeClr val="accent1"/>
-          </a:lnRef>
-          <a:fillRef idx="3">
-            <a:schemeClr val="accent1"/>
-          </a:fillRef>
-          <a:effectRef idx="2">
-            <a:schemeClr val="accent1"/>
-          </a:effectRef>
-          <a:fontRef idx="minor">
-            <a:schemeClr val="lt1"/>
-          </a:fontRef>
-        </p:style>
-        <p:txBody>
-          <a:bodyPr rtlCol="0" anchor="ctr" wrap="square" lIns="320040" tIns="274320"/>
-          <a:lstStyle/>
-          <a:p>
-            <a:pPr algn="ctr">
-              <a:defRPr sz="1200" b="1">
-                <a:solidFill>
-                  <a:srgbClr val="2563EB"/>
-                </a:solidFill>
-              </a:defRPr>
-            </a:pPr>
-            <a:r>
-              <a:t>MANAGERIAL ACCOUNTING FORMULAS</a:t>
-            </a:r>
-          </a:p>
-          <a:p>
-            <a:pPr>
-              <a:spcBef>
-                <a:spcPts val="500"/>
-              </a:spcBef>
-              <a:defRPr sz="1050" b="1">
-                <a:solidFill>
-                  <a:srgbClr val="0F172A"/>
-                </a:solidFill>
-              </a:defRPr>
-            </a:pPr>
-            <a:r>
-              <a:t>Contribution Margin (CM): CM = Selling Price (P) - Variable Cost (V)</a:t>
-            </a:r>
-          </a:p>
-          <a:p>
-            <a:pPr>
-              <a:spcBef>
-                <a:spcPts val="100"/>
-              </a:spcBef>
-              <a:defRPr sz="950">
-                <a:solidFill>
-                  <a:srgbClr val="64748B"/>
-                </a:solidFill>
-              </a:defRPr>
-            </a:pPr>
-            <a:r>
-              <a:t>  └ Per-unit revenue remaining to cover fixed overhead.</a:t>
-            </a:r>
-          </a:p>
-          <a:p>
-            <a:pPr>
-              <a:spcBef>
-                <a:spcPts val="500"/>
-              </a:spcBef>
-              <a:defRPr sz="1050" b="1">
-                <a:solidFill>
-                  <a:srgbClr val="0F172A"/>
-                </a:solidFill>
-              </a:defRPr>
-            </a:pPr>
-            <a:r>
-              <a:t>Contribution Margin Ratio: CM% = (P - V) / P</a:t>
-            </a:r>
-          </a:p>
-          <a:p>
-            <a:pPr>
-              <a:spcBef>
-                <a:spcPts val="100"/>
-              </a:spcBef>
-              <a:defRPr sz="950">
-                <a:solidFill>
-                  <a:srgbClr val="64748B"/>
-                </a:solidFill>
-              </a:defRPr>
-            </a:pPr>
-            <a:r>
-              <a:t>  └ Percentage of each revenue dollar available to cover fixed costs.</a:t>
-            </a:r>
-          </a:p>
-          <a:p>
-            <a:pPr>
-              <a:spcBef>
-                <a:spcPts val="500"/>
-              </a:spcBef>
-              <a:defRPr sz="1050" b="1">
-                <a:solidFill>
-                  <a:srgbClr val="0F172A"/>
-                </a:solidFill>
-              </a:defRPr>
-            </a:pPr>
-            <a:r>
-              <a:t>Break-Even Volume (Units): Q_BE = Fixed Costs (F) / (P - V)</a:t>
-            </a:r>
-          </a:p>
-          <a:p>
-            <a:pPr>
-              <a:spcBef>
-                <a:spcPts val="100"/>
-              </a:spcBef>
-              <a:defRPr sz="950">
-                <a:solidFill>
-                  <a:srgbClr val="64748B"/>
-                </a:solidFill>
-              </a:defRPr>
-            </a:pPr>
-            <a:r>
-              <a:t>  └ Sales units required to yield exactly $0 net operating profit.</a:t>
-            </a:r>
-          </a:p>
-          <a:p>
-            <a:pPr>
-              <a:spcBef>
-                <a:spcPts val="500"/>
-              </a:spcBef>
-              <a:defRPr sz="1050" b="1">
-                <a:solidFill>
-                  <a:srgbClr val="0F172A"/>
-                </a:solidFill>
-              </a:defRPr>
-            </a:pPr>
-            <a:r>
-              <a:t>Break-Even Gross Revenue: R_BE = Q_BE × P = F / CM%</a:t>
-            </a:r>
-          </a:p>
-          <a:p>
-            <a:pPr>
-              <a:spcBef>
-                <a:spcPts val="100"/>
-              </a:spcBef>
-              <a:defRPr sz="950">
-                <a:solidFill>
-                  <a:srgbClr val="64748B"/>
-                </a:solidFill>
-              </a:defRPr>
-            </a:pPr>
-            <a:r>
-              <a:t>  └ Total dollar sales volume needed to reach break-even.</a:t>
-            </a:r>
-          </a:p>
-          <a:p>
-            <a:pPr>
-              <a:spcBef>
-                <a:spcPts val="500"/>
-              </a:spcBef>
-              <a:defRPr sz="1050" b="1">
-                <a:solidFill>
-                  <a:srgbClr val="0F172A"/>
-                </a:solidFill>
-              </a:defRPr>
-            </a:pPr>
-            <a:r>
-              <a:t>Projected Net Operating Profit: Profit = Q × (P - V) - F</a:t>
-            </a:r>
-          </a:p>
-          <a:p>
-            <a:pPr>
-              <a:spcBef>
-                <a:spcPts val="100"/>
-              </a:spcBef>
-              <a:defRPr sz="950">
-                <a:solidFill>
-                  <a:srgbClr val="64748B"/>
-                </a:solidFill>
-              </a:defRPr>
-            </a:pPr>
-            <a:r>
-              <a:t>  └ Net operating income at projected sales volume Q.</a:t>
-            </a:r>
-          </a:p>
-          <a:p>
-            <a:pPr>
-              <a:spcBef>
-                <a:spcPts val="500"/>
-              </a:spcBef>
-              <a:defRPr sz="1050" b="1">
-                <a:solidFill>
-                  <a:srgbClr val="0F172A"/>
-                </a:solidFill>
-              </a:defRPr>
-            </a:pPr>
-            <a:r>
-              <a:t>Margin of Safety (MOS): MOS = (Q - Q_BE) / Q × 100%</a:t>
-            </a:r>
-          </a:p>
-          <a:p>
-            <a:pPr>
-              <a:spcBef>
-                <a:spcPts val="100"/>
-              </a:spcBef>
-              <a:defRPr sz="950">
-                <a:solidFill>
-                  <a:srgbClr val="64748B"/>
-                </a:solidFill>
-              </a:defRPr>
-            </a:pPr>
-            <a:r>
-              <a:t>  └ Buffer percentage by which sales can fall before entering losses.</a:t>
-            </a:r>
-          </a:p>
-          <a:p>
-            <a:pPr>
-              <a:spcBef>
-                <a:spcPts val="500"/>
-              </a:spcBef>
-              <a:defRPr sz="1050" b="1">
-                <a:solidFill>
-                  <a:srgbClr val="0F172A"/>
-                </a:solidFill>
-              </a:defRPr>
-            </a:pPr>
-            <a:r>
-              <a:t>Operating Leverage (DOL): DOL = (Q × CM) / Profit</a:t>
-            </a:r>
-          </a:p>
-          <a:p>
-            <a:pPr>
-              <a:spcBef>
-                <a:spcPts val="100"/>
-              </a:spcBef>
-              <a:defRPr sz="950">
-                <a:solidFill>
-                  <a:srgbClr val="64748B"/>
-                </a:solidFill>
-              </a:defRPr>
-            </a:pPr>
-            <a:r>
-              <a:t>  └ Measures multiplier effect: % change in profit for 1% change in sales.</a:t>
-            </a:r>
-          </a:p>
-        </p:txBody>
-      </p:sp>
-      <p:sp>
-        <p:nvSpPr>
-          <p:cNvPr id="5" name="Rounded Rectangle 4"/>
-          <p:cNvSpPr/>
-          <p:nvPr/>
-        </p:nvSpPr>
-        <p:spPr>
-          <a:xfrm>
-            <a:off x="6583680" y="1463040"/>
-            <a:ext cx="4846320" cy="4663440"/>
-          </a:xfrm>
-          <a:prstGeom prst="roundRect">
-            <a:avLst/>
-          </a:prstGeom>
-          <a:solidFill>
-            <a:srgbClr val="FFFFFF"/>
-          </a:solidFill>
-          <a:ln w="19050">
-            <a:solidFill>
-              <a:srgbClr val="E2E8F0"/>
-            </a:solidFill>
-          </a:ln>
-        </p:spPr>
-        <p:style>
-          <a:lnRef idx="1">
-            <a:schemeClr val="accent1"/>
-          </a:lnRef>
-          <a:fillRef idx="3">
-            <a:schemeClr val="accent1"/>
-          </a:fillRef>
-          <a:effectRef idx="2">
-            <a:schemeClr val="accent1"/>
-          </a:effectRef>
-          <a:fontRef idx="minor">
-            <a:schemeClr val="lt1"/>
-          </a:fontRef>
-        </p:style>
-        <p:txBody>
-          <a:bodyPr rtlCol="0" anchor="ctr" wrap="square" lIns="320040" tIns="274320"/>
-          <a:lstStyle/>
-          <a:p>
-            <a:pPr algn="ctr">
-              <a:defRPr sz="1200" b="1">
-                <a:solidFill>
-                  <a:srgbClr val="059669"/>
-                </a:solidFill>
-              </a:defRPr>
-            </a:pPr>
-            <a:r>
-              <a:t>ENGINE ROBUSTNESS &amp; VALIDATION GUARDS</a:t>
-            </a:r>
-          </a:p>
-          <a:p>
-            <a:pPr>
-              <a:spcBef>
-                <a:spcPts val="800"/>
-              </a:spcBef>
-              <a:defRPr sz="1100" b="1">
-                <a:solidFill>
-                  <a:srgbClr val="0F172A"/>
-                </a:solidFill>
-              </a:defRPr>
-            </a:pPr>
-            <a:r>
-              <a:t>Strict Viability Check (P ≤ V):</a:t>
-            </a:r>
-          </a:p>
-          <a:p>
-            <a:pPr>
-              <a:spcBef>
-                <a:spcPts val="200"/>
-              </a:spcBef>
-              <a:defRPr sz="1000">
-                <a:solidFill>
-                  <a:srgbClr val="64748B"/>
-                </a:solidFill>
-              </a:defRPr>
-            </a:pPr>
-            <a:r>
-              <a:t>If Selling Price is less than or equal to Variable Cost, every unit sold generates a loss. The system raises an alert, flags BE as infinite/unattainable, and displays an entire loss polygon.</a:t>
-            </a:r>
-          </a:p>
-          <a:p>
-            <a:pPr>
-              <a:spcBef>
-                <a:spcPts val="800"/>
-              </a:spcBef>
-              <a:defRPr sz="1100" b="1">
-                <a:solidFill>
-                  <a:srgbClr val="0F172A"/>
-                </a:solidFill>
-              </a:defRPr>
-            </a:pPr>
-            <a:r>
-              <a:t>Deficit Early Warning (Q &lt; Q_BE):</a:t>
-            </a:r>
-          </a:p>
-          <a:p>
-            <a:pPr>
-              <a:spcBef>
-                <a:spcPts val="200"/>
-              </a:spcBef>
-              <a:defRPr sz="1000">
-                <a:solidFill>
-                  <a:srgbClr val="64748B"/>
-                </a:solidFill>
-              </a:defRPr>
-            </a:pPr>
-            <a:r>
-              <a:t>If projected sales fall short of break-even, the engine computes the exact shortfall (units and currency deficit) and displays an alert indicating operating loss.</a:t>
-            </a:r>
-          </a:p>
-          <a:p>
-            <a:pPr>
-              <a:spcBef>
-                <a:spcPts val="800"/>
-              </a:spcBef>
-              <a:defRPr sz="1100" b="1">
-                <a:solidFill>
-                  <a:srgbClr val="0F172A"/>
-                </a:solidFill>
-              </a:defRPr>
-            </a:pPr>
-            <a:r>
-              <a:t>Target Profit Calculation:</a:t>
-            </a:r>
-          </a:p>
-          <a:p>
-            <a:pPr>
-              <a:spcBef>
-                <a:spcPts val="200"/>
-              </a:spcBef>
-              <a:defRPr sz="1000">
-                <a:solidFill>
-                  <a:srgbClr val="64748B"/>
-                </a:solidFill>
-              </a:defRPr>
-            </a:pPr>
-            <a:r>
-              <a:t>Calculates Q_Target = (F + Target) / CM to determine the exact sales needed to satisfy the owner's desired take-home earnings.</a:t>
-            </a:r>
-          </a:p>
-          <a:p>
-            <a:pPr>
-              <a:spcBef>
-                <a:spcPts val="800"/>
-              </a:spcBef>
-              <a:defRPr sz="1100" b="1">
-                <a:solidFill>
-                  <a:srgbClr val="0F172A"/>
-                </a:solidFill>
-              </a:defRPr>
-            </a:pPr>
-            <a:r>
-              <a:t>Pure Function Architecture:</a:t>
-            </a:r>
-          </a:p>
-          <a:p>
-            <a:pPr>
-              <a:spcBef>
-                <a:spcPts val="200"/>
-              </a:spcBef>
-              <a:defRPr sz="1000">
-                <a:solidFill>
-                  <a:srgbClr val="64748B"/>
-                </a:solidFill>
-              </a:defRPr>
-            </a:pPr>
-            <a:r>
-              <a:t>model(F, P, V, Q, T) is completely deterministic and stateless. The same inputs guarantee the exact same outputs across unit tests, backend APIs, and UI.</a:t>
-            </a:r>
-          </a:p>
-        </p:txBody>
-      </p:sp>
-    </p:spTree>
-  </p:cSld>
-  <p:clrMapOvr>
-    <a:masterClrMapping/>
-  </p:clrMapOvr>
-</p:sld>
-</file>
-
-<file path=ppt/slides/slide5.xml><?xml version="1.0" encoding="utf-8"?>
-<p:sld xmlns:a="http://schemas.openxmlformats.org/drawingml/2006/main" xmlns:p="http://schemas.openxmlformats.org/presentationml/2006/main" xmlns:r="http://schemas.openxmlformats.org/officeDocument/2006/relationships">
-  <p:cSld>
-    <p:spTree>
-      <p:nvGrpSpPr>
-        <p:cNvPr id="1" name=""/>
-        <p:cNvGrpSpPr/>
-        <p:nvPr/>
-      </p:nvGrpSpPr>
-      <p:grpSpPr/>
-      <p:sp>
-        <p:nvSpPr>
-          <p:cNvPr id="2" name="TextBox 1"/>
-          <p:cNvSpPr txBox="1"/>
-          <p:nvPr/>
-        </p:nvSpPr>
-        <p:spPr>
-          <a:xfrm>
-            <a:off x="731520" y="365760"/>
-            <a:ext cx="10698480" cy="320040"/>
-          </a:xfrm>
-          <a:prstGeom prst="rect">
-            <a:avLst/>
-          </a:prstGeom>
-          <a:noFill/>
-        </p:spPr>
-        <p:txBody>
-          <a:bodyPr wrap="square">
-            <a:spAutoFit/>
-          </a:bodyPr>
-          <a:lstStyle/>
-          <a:p>
-            <a:pPr>
-              <a:defRPr sz="1100" b="1">
-                <a:solidFill>
-                  <a:srgbClr val="2563EB"/>
-                </a:solidFill>
-              </a:defRPr>
-            </a:pPr>
-            <a:r>
-              <a:t>PLATFORM CAPABILITIES</a:t>
-            </a:r>
-          </a:p>
-        </p:txBody>
-      </p:sp>
-      <p:sp>
-        <p:nvSpPr>
-          <p:cNvPr id="3" name="TextBox 2"/>
-          <p:cNvSpPr txBox="1"/>
-          <p:nvPr/>
-        </p:nvSpPr>
-        <p:spPr>
-          <a:xfrm>
-            <a:off x="731520" y="640080"/>
-            <a:ext cx="10698480" cy="594360"/>
-          </a:xfrm>
-          <a:prstGeom prst="rect">
-            <a:avLst/>
-          </a:prstGeom>
-          <a:noFill/>
-        </p:spPr>
-        <p:txBody>
-          <a:bodyPr wrap="square">
-            <a:spAutoFit/>
-          </a:bodyPr>
-          <a:lstStyle/>
-          <a:p>
-            <a:pPr>
-              <a:defRPr sz="2400" b="1">
-                <a:solidFill>
-                  <a:srgbClr val="0F172A"/>
-                </a:solidFill>
-              </a:defRPr>
-            </a:pPr>
-            <a:r>
-              <a:t>Key Features &amp; Interactive Capabilities</a:t>
-            </a:r>
-          </a:p>
-        </p:txBody>
-      </p:sp>
-      <p:sp>
-        <p:nvSpPr>
-          <p:cNvPr id="4" name="Rounded Rectangle 3"/>
-          <p:cNvSpPr/>
-          <p:nvPr/>
-        </p:nvSpPr>
-        <p:spPr>
-          <a:xfrm>
-            <a:off x="731520" y="1463040"/>
-            <a:ext cx="5120640" cy="2194560"/>
-          </a:xfrm>
-          <a:prstGeom prst="roundRect">
-            <a:avLst/>
-          </a:prstGeom>
-          <a:solidFill>
-            <a:srgbClr val="FFFFFF"/>
-          </a:solidFill>
-          <a:ln w="19050">
-            <a:solidFill>
-              <a:srgbClr val="E2E8F0"/>
-            </a:solidFill>
-          </a:ln>
-        </p:spPr>
-        <p:style>
-          <a:lnRef idx="1">
-            <a:schemeClr val="accent1"/>
-          </a:lnRef>
-          <a:fillRef idx="3">
-            <a:schemeClr val="accent1"/>
-          </a:fillRef>
-          <a:effectRef idx="2">
-            <a:schemeClr val="accent1"/>
-          </a:effectRef>
-          <a:fontRef idx="minor">
-            <a:schemeClr val="lt1"/>
-          </a:fontRef>
-        </p:style>
-        <p:txBody>
-          <a:bodyPr rtlCol="0" anchor="ctr" wrap="square" lIns="228600" tIns="182880"/>
-          <a:lstStyle/>
-          <a:p>
-            <a:pPr algn="ctr">
-              <a:defRPr sz="1150" b="1">
-                <a:solidFill>
-                  <a:srgbClr val="2563EB"/>
-                </a:solidFill>
-              </a:defRPr>
-            </a:pPr>
-            <a:r>
-              <a:t>📊 Inline Dynamic SVG Break-Even Chart</a:t>
-            </a:r>
-          </a:p>
-          <a:p>
-            <a:pPr>
-              <a:spcBef>
-                <a:spcPts val="300"/>
-              </a:spcBef>
-              <a:defRPr sz="950">
-                <a:solidFill>
-                  <a:srgbClr val="0F172A"/>
-                </a:solidFill>
-              </a:defRPr>
-            </a:pPr>
-            <a:r>
-              <a:t>• Draws Total Revenue, Total Cost, and horizontal Fixed Cost lines.</a:t>
-            </a:r>
-          </a:p>
-          <a:p>
-            <a:pPr>
-              <a:spcBef>
-                <a:spcPts val="300"/>
-              </a:spcBef>
-              <a:defRPr sz="950">
-                <a:solidFill>
-                  <a:srgbClr val="0F172A"/>
-                </a:solidFill>
-              </a:defRPr>
-            </a:pPr>
-            <a:r>
-              <a:t>• Fills green-tinted Profit Zone and red-tinted Loss Zone dynamically.</a:t>
-            </a:r>
-          </a:p>
-          <a:p>
-            <a:pPr>
-              <a:spcBef>
-                <a:spcPts val="300"/>
-              </a:spcBef>
-              <a:defRPr sz="950">
-                <a:solidFill>
-                  <a:srgbClr val="0F172A"/>
-                </a:solidFill>
-              </a:defRPr>
-            </a:pPr>
-            <a:r>
-              <a:t>• Pinpoints Break-Even point with pulsing halo and coordinates callout.</a:t>
-            </a:r>
-          </a:p>
-          <a:p>
-            <a:pPr>
-              <a:spcBef>
-                <a:spcPts val="300"/>
-              </a:spcBef>
-              <a:defRPr sz="950">
-                <a:solidFill>
-                  <a:srgbClr val="0F172A"/>
-                </a:solidFill>
-              </a:defRPr>
-            </a:pPr>
-            <a:r>
-              <a:t>• Interactive hover/touch crosshair reading exact figures at any volume.</a:t>
-            </a:r>
-          </a:p>
-        </p:txBody>
-      </p:sp>
-      <p:sp>
-        <p:nvSpPr>
-          <p:cNvPr id="5" name="Rounded Rectangle 4"/>
-          <p:cNvSpPr/>
-          <p:nvPr/>
-        </p:nvSpPr>
-        <p:spPr>
-          <a:xfrm>
-            <a:off x="6309360" y="1463040"/>
-            <a:ext cx="5120640" cy="2194560"/>
-          </a:xfrm>
-          <a:prstGeom prst="roundRect">
-            <a:avLst/>
-          </a:prstGeom>
-          <a:solidFill>
-            <a:srgbClr val="FFFFFF"/>
-          </a:solidFill>
-          <a:ln w="19050">
-            <a:solidFill>
-              <a:srgbClr val="E2E8F0"/>
-            </a:solidFill>
-          </a:ln>
-        </p:spPr>
-        <p:style>
-          <a:lnRef idx="1">
-            <a:schemeClr val="accent1"/>
-          </a:lnRef>
-          <a:fillRef idx="3">
-            <a:schemeClr val="accent1"/>
-          </a:fillRef>
-          <a:effectRef idx="2">
-            <a:schemeClr val="accent1"/>
-          </a:effectRef>
-          <a:fontRef idx="minor">
-            <a:schemeClr val="lt1"/>
-          </a:fontRef>
-        </p:style>
-        <p:txBody>
-          <a:bodyPr rtlCol="0" anchor="ctr" wrap="square" lIns="228600" tIns="182880"/>
-          <a:lstStyle/>
-          <a:p>
-            <a:pPr algn="ctr">
-              <a:defRPr sz="1150" b="1">
-                <a:solidFill>
-                  <a:srgbClr val="2563EB"/>
-                </a:solidFill>
-              </a:defRPr>
-            </a:pPr>
-            <a:r>
-              <a:t>🎛️ Real-Time What-If Sensitivity Sliders</a:t>
-            </a:r>
-          </a:p>
-          <a:p>
-            <a:pPr>
-              <a:spcBef>
-                <a:spcPts val="300"/>
-              </a:spcBef>
-              <a:defRPr sz="950">
-                <a:solidFill>
-                  <a:srgbClr val="0F172A"/>
-                </a:solidFill>
-              </a:defRPr>
-            </a:pPr>
-            <a:r>
-              <a:t>• Three dual-direction sliders (-50% to +50%) for Price, Var Cost, and Fixed Costs.</a:t>
-            </a:r>
-          </a:p>
-          <a:p>
-            <a:pPr>
-              <a:spcBef>
-                <a:spcPts val="300"/>
-              </a:spcBef>
-              <a:defRPr sz="950">
-                <a:solidFill>
-                  <a:srgbClr val="0F172A"/>
-                </a:solidFill>
-              </a:defRPr>
-            </a:pPr>
-            <a:r>
-              <a:t>• Live delta comparisons displaying percentage shift vs base case.</a:t>
-            </a:r>
-          </a:p>
-          <a:p>
-            <a:pPr>
-              <a:spcBef>
-                <a:spcPts val="300"/>
-              </a:spcBef>
-              <a:defRPr sz="950">
-                <a:solidFill>
-                  <a:srgbClr val="0F172A"/>
-                </a:solidFill>
-              </a:defRPr>
-            </a:pPr>
-            <a:r>
-              <a:t>• Color-coded metrics (green for favorable shifts, red for unfavorable).</a:t>
-            </a:r>
-          </a:p>
-          <a:p>
-            <a:pPr>
-              <a:spcBef>
-                <a:spcPts val="300"/>
-              </a:spcBef>
-              <a:defRPr sz="950">
-                <a:solidFill>
-                  <a:srgbClr val="0F172A"/>
-                </a:solidFill>
-              </a:defRPr>
-            </a:pPr>
-            <a:r>
-              <a:t>• One-click 'Reset Sliders' to restore baseline assumptions.</a:t>
-            </a:r>
-          </a:p>
-        </p:txBody>
-      </p:sp>
-      <p:sp>
-        <p:nvSpPr>
-          <p:cNvPr id="6" name="Rounded Rectangle 5"/>
-          <p:cNvSpPr/>
-          <p:nvPr/>
-        </p:nvSpPr>
-        <p:spPr>
-          <a:xfrm>
-            <a:off x="731520" y="3931920"/>
-            <a:ext cx="5120640" cy="2194560"/>
-          </a:xfrm>
-          <a:prstGeom prst="roundRect">
-            <a:avLst/>
-          </a:prstGeom>
-          <a:solidFill>
-            <a:srgbClr val="FFFFFF"/>
-          </a:solidFill>
-          <a:ln w="19050">
-            <a:solidFill>
-              <a:srgbClr val="E2E8F0"/>
-            </a:solidFill>
-          </a:ln>
-        </p:spPr>
-        <p:style>
-          <a:lnRef idx="1">
-            <a:schemeClr val="accent1"/>
-          </a:lnRef>
-          <a:fillRef idx="3">
-            <a:schemeClr val="accent1"/>
-          </a:fillRef>
-          <a:effectRef idx="2">
-            <a:schemeClr val="accent1"/>
-          </a:effectRef>
-          <a:fontRef idx="minor">
-            <a:schemeClr val="lt1"/>
-          </a:fontRef>
-        </p:style>
-        <p:txBody>
-          <a:bodyPr rtlCol="0" anchor="ctr" wrap="square" lIns="228600" tIns="182880"/>
-          <a:lstStyle/>
-          <a:p>
-            <a:pPr algn="ctr">
-              <a:defRPr sz="1150" b="1">
-                <a:solidFill>
-                  <a:srgbClr val="2563EB"/>
-                </a:solidFill>
-              </a:defRPr>
-            </a:pPr>
-            <a:r>
-              <a:t>📈 Stress-Testing Sensitivity &amp; Scenarios</a:t>
-            </a:r>
-          </a:p>
-          <a:p>
-            <a:pPr>
-              <a:spcBef>
-                <a:spcPts val="300"/>
-              </a:spcBef>
-              <a:defRPr sz="950">
-                <a:solidFill>
-                  <a:srgbClr val="0F172A"/>
-                </a:solidFill>
-              </a:defRPr>
-            </a:pPr>
-            <a:r>
-              <a:t>• Driver Matrix: Evaluates BE volume shifts at -20%, -10%, 0%, +10%, +20%.</a:t>
-            </a:r>
-          </a:p>
-          <a:p>
-            <a:pPr>
-              <a:spcBef>
-                <a:spcPts val="300"/>
-              </a:spcBef>
-              <a:defRPr sz="950">
-                <a:solidFill>
-                  <a:srgbClr val="0F172A"/>
-                </a:solidFill>
-              </a:defRPr>
-            </a:pPr>
-            <a:r>
-              <a:t>• Volume Scenarios: Pessimistic (-25%), Base, and Optimistic (+25%).</a:t>
-            </a:r>
-          </a:p>
-          <a:p>
-            <a:pPr>
-              <a:spcBef>
-                <a:spcPts val="300"/>
-              </a:spcBef>
-              <a:defRPr sz="950">
-                <a:solidFill>
-                  <a:srgbClr val="0F172A"/>
-                </a:solidFill>
-              </a:defRPr>
-            </a:pPr>
-            <a:r>
-              <a:t>• Highlights margin of safety buffer and dollar profits per scenario.</a:t>
-            </a:r>
-          </a:p>
-          <a:p>
-            <a:pPr>
-              <a:spcBef>
-                <a:spcPts val="300"/>
-              </a:spcBef>
-              <a:defRPr sz="950">
-                <a:solidFill>
-                  <a:srgbClr val="0F172A"/>
-                </a:solidFill>
-              </a:defRPr>
-            </a:pPr>
-            <a:r>
-              <a:t>• Flags structural loss conditions automatically.</a:t>
-            </a:r>
-          </a:p>
-        </p:txBody>
-      </p:sp>
-      <p:sp>
-        <p:nvSpPr>
-          <p:cNvPr id="7" name="Rounded Rectangle 6"/>
-          <p:cNvSpPr/>
-          <p:nvPr/>
-        </p:nvSpPr>
-        <p:spPr>
-          <a:xfrm>
-            <a:off x="6309360" y="3931920"/>
-            <a:ext cx="5120640" cy="2194560"/>
-          </a:xfrm>
-          <a:prstGeom prst="roundRect">
-            <a:avLst/>
-          </a:prstGeom>
-          <a:solidFill>
-            <a:srgbClr val="FFFFFF"/>
-          </a:solidFill>
-          <a:ln w="19050">
-            <a:solidFill>
-              <a:srgbClr val="E2E8F0"/>
-            </a:solidFill>
-          </a:ln>
-        </p:spPr>
-        <p:style>
-          <a:lnRef idx="1">
-            <a:schemeClr val="accent1"/>
-          </a:lnRef>
-          <a:fillRef idx="3">
-            <a:schemeClr val="accent1"/>
-          </a:fillRef>
-          <a:effectRef idx="2">
-            <a:schemeClr val="accent1"/>
-          </a:effectRef>
-          <a:fontRef idx="minor">
-            <a:schemeClr val="lt1"/>
-          </a:fontRef>
-        </p:style>
-        <p:txBody>
-          <a:bodyPr rtlCol="0" anchor="ctr" wrap="square" lIns="228600" tIns="182880"/>
-          <a:lstStyle/>
-          <a:p>
-            <a:pPr algn="ctr">
-              <a:defRPr sz="1150" b="1">
-                <a:solidFill>
-                  <a:srgbClr val="2563EB"/>
-                </a:solidFill>
-              </a:defRPr>
-            </a:pPr>
-            <a:r>
-              <a:t>💼 Enterprise Profile &amp; Executive Print</a:t>
-            </a:r>
-          </a:p>
-          <a:p>
-            <a:pPr>
-              <a:spcBef>
-                <a:spcPts val="300"/>
-              </a:spcBef>
-              <a:defRPr sz="950">
-                <a:solidFill>
-                  <a:srgbClr val="0F172A"/>
-                </a:solidFill>
-              </a:defRPr>
-            </a:pPr>
-            <a:r>
-              <a:t>• Business profile card with 10-digit phone and email validation.</a:t>
-            </a:r>
-          </a:p>
-          <a:p>
-            <a:pPr>
-              <a:spcBef>
-                <a:spcPts val="300"/>
-              </a:spcBef>
-              <a:defRPr sz="950">
-                <a:solidFill>
-                  <a:srgbClr val="0F172A"/>
-                </a:solidFill>
-              </a:defRPr>
-            </a:pPr>
-            <a:r>
-              <a:t>• Multi-currency support (USD $, EUR €, GBP £, INR ₹, JPY ¥, CAD, AUD).</a:t>
-            </a:r>
-          </a:p>
-          <a:p>
-            <a:pPr>
-              <a:spcBef>
-                <a:spcPts val="300"/>
-              </a:spcBef>
-              <a:defRPr sz="950">
-                <a:solidFill>
-                  <a:srgbClr val="0F172A"/>
-                </a:solidFill>
-              </a:defRPr>
-            </a:pPr>
-            <a:r>
-              <a:t>• Custom volume unit labels (units, cups, boxes, meals, hours).</a:t>
-            </a:r>
-          </a:p>
-          <a:p>
-            <a:pPr>
-              <a:spcBef>
-                <a:spcPts val="300"/>
-              </a:spcBef>
-              <a:defRPr sz="950">
-                <a:solidFill>
-                  <a:srgbClr val="0F172A"/>
-                </a:solidFill>
-              </a:defRPr>
-            </a:pPr>
-            <a:r>
-              <a:t>• Printable letterhead report hiding interactive controls for presentation.</a:t>
-            </a:r>
-          </a:p>
-        </p:txBody>
-      </p:sp>
-    </p:spTree>
-  </p:cSld>
-  <p:clrMapOvr>
-    <a:masterClrMapping/>
-  </p:clrMapOvr>
-</p:sld>
-</file>
-
-<file path=ppt/slides/slide6.xml><?xml version="1.0" encoding="utf-8"?>
-<p:sld xmlns:a="http://schemas.openxmlformats.org/drawingml/2006/main" xmlns:p="http://schemas.openxmlformats.org/presentationml/2006/main" xmlns:r="http://schemas.openxmlformats.org/officeDocument/2006/relationships">
-  <p:cSld>
-    <p:spTree>
-      <p:nvGrpSpPr>
-        <p:cNvPr id="1" name=""/>
-        <p:cNvGrpSpPr/>
-        <p:nvPr/>
-      </p:nvGrpSpPr>
-      <p:grpSpPr/>
-      <p:sp>
-        <p:nvSpPr>
-          <p:cNvPr id="2" name="TextBox 1"/>
-          <p:cNvSpPr txBox="1"/>
-          <p:nvPr/>
-        </p:nvSpPr>
-        <p:spPr>
-          <a:xfrm>
-            <a:off x="731520" y="365760"/>
-            <a:ext cx="10698480" cy="320040"/>
-          </a:xfrm>
-          <a:prstGeom prst="rect">
-            <a:avLst/>
-          </a:prstGeom>
-          <a:noFill/>
-        </p:spPr>
-        <p:txBody>
-          <a:bodyPr wrap="square">
-            <a:spAutoFit/>
-          </a:bodyPr>
-          <a:lstStyle/>
-          <a:p>
-            <a:pPr>
-              <a:defRPr sz="1100" b="1">
-                <a:solidFill>
-                  <a:srgbClr val="2563EB"/>
-                </a:solidFill>
-              </a:defRPr>
-            </a:pPr>
-            <a:r>
-              <a:t>CODE IMPLEMENTATION</a:t>
-            </a:r>
-          </a:p>
-        </p:txBody>
-      </p:sp>
-      <p:sp>
-        <p:nvSpPr>
-          <p:cNvPr id="3" name="TextBox 2"/>
-          <p:cNvSpPr txBox="1"/>
-          <p:nvPr/>
-        </p:nvSpPr>
-        <p:spPr>
-          <a:xfrm>
-            <a:off x="731520" y="640080"/>
-            <a:ext cx="10698480" cy="594360"/>
-          </a:xfrm>
-          <a:prstGeom prst="rect">
-            <a:avLst/>
-          </a:prstGeom>
-          <a:noFill/>
-        </p:spPr>
-        <p:txBody>
-          <a:bodyPr wrap="square">
-            <a:spAutoFit/>
-          </a:bodyPr>
-          <a:lstStyle/>
-          <a:p>
-            <a:pPr>
-              <a:defRPr sz="2400" b="1">
-                <a:solidFill>
-                  <a:srgbClr val="0F172A"/>
-                </a:solidFill>
-              </a:defRPr>
-            </a:pPr>
-            <a:r>
-              <a:t>Modular Architecture &amp; Code Structure</a:t>
+              <a:t>Frontend Architecture &amp; User Interface</a:t>
             </a:r>
           </a:p>
         </p:txBody>
@@ -5415,112 +3825,789 @@
               </a:defRPr>
             </a:pPr>
             <a:r>
-              <a:t>FRONTEND MODULAR NAMESPACES (ES5)</a:t>
-            </a:r>
-          </a:p>
-          <a:p>
-            <a:pPr>
-              <a:spcBef>
-                <a:spcPts val="400"/>
+              <a:t>FRONTEND DESIGN &amp; USER EXPERIENCE</a:t>
+            </a:r>
+          </a:p>
+          <a:p>
+            <a:pPr>
+              <a:spcBef>
+                <a:spcPts val="600"/>
+              </a:spcBef>
+              <a:defRPr sz="1050" b="1">
+                <a:solidFill>
+                  <a:srgbClr val="0F172A"/>
+                </a:solidFill>
+              </a:defRPr>
+            </a:pPr>
+            <a:r>
+              <a:t>Vanilla ES5 Architecture:</a:t>
+            </a:r>
+          </a:p>
+          <a:p>
+            <a:pPr>
+              <a:spcBef>
+                <a:spcPts val="100"/>
               </a:spcBef>
               <a:defRPr sz="950">
                 <a:solidFill>
-                  <a:srgbClr val="0F172A"/>
-                </a:solidFill>
-              </a:defRPr>
-            </a:pPr>
-            <a:r>
-              <a:t>model(F, P, V, Q, T): Pure calculation function returning break-even, profit, margin of safety, and DOL.</a:t>
-            </a:r>
-          </a:p>
-          <a:p>
-            <a:pPr>
-              <a:spcBef>
-                <a:spcPts val="400"/>
+                  <a:srgbClr val="64748B"/>
+                </a:solidFill>
+              </a:defRPr>
+            </a:pPr>
+            <a:r>
+              <a:t>  Strict ES5 standards ensuring 100% universal browser compatibility without Babel or bundling overhead.</a:t>
+            </a:r>
+          </a:p>
+          <a:p>
+            <a:pPr>
+              <a:spcBef>
+                <a:spcPts val="600"/>
+              </a:spcBef>
+              <a:defRPr sz="1050" b="1">
+                <a:solidFill>
+                  <a:srgbClr val="0F172A"/>
+                </a:solidFill>
+              </a:defRPr>
+            </a:pPr>
+            <a:r>
+              <a:t>Responsive Two-Column Layout:</a:t>
+            </a:r>
+          </a:p>
+          <a:p>
+            <a:pPr>
+              <a:spcBef>
+                <a:spcPts val="100"/>
               </a:spcBef>
               <a:defRPr sz="950">
                 <a:solidFill>
-                  <a:srgbClr val="0F172A"/>
-                </a:solidFill>
-              </a:defRPr>
-            </a:pPr>
-            <a:r>
-              <a:t>AuthModule: Manages Sign In / Sign Up, form validation, SHA-256 password hashing, and active session tokens.</a:t>
-            </a:r>
-          </a:p>
-          <a:p>
-            <a:pPr>
-              <a:spcBef>
-                <a:spcPts val="400"/>
+                  <a:srgbClr val="64748B"/>
+                </a:solidFill>
+              </a:defRPr>
+            </a:pPr>
+            <a:r>
+              <a:t>  Adapts automatically from a two-column desktop grid to an optimized single-column mobile view.</a:t>
+            </a:r>
+          </a:p>
+          <a:p>
+            <a:pPr>
+              <a:spcBef>
+                <a:spcPts val="600"/>
+              </a:spcBef>
+              <a:defRPr sz="1050" b="1">
+                <a:solidFill>
+                  <a:srgbClr val="0F172A"/>
+                </a:solidFill>
+              </a:defRPr>
+            </a:pPr>
+            <a:r>
+              <a:t>Dark &amp; Light Mode:</a:t>
+            </a:r>
+          </a:p>
+          <a:p>
+            <a:pPr>
+              <a:spcBef>
+                <a:spcPts val="100"/>
               </a:spcBef>
               <a:defRPr sz="950">
                 <a:solidFill>
-                  <a:srgbClr val="0F172A"/>
-                </a:solidFill>
-              </a:defRPr>
-            </a:pPr>
-            <a:r>
-              <a:t>ProfileModule: Handles business metadata, contact information, input validation, and print letterhead sync.</a:t>
-            </a:r>
-          </a:p>
-          <a:p>
-            <a:pPr>
-              <a:spcBef>
-                <a:spcPts val="400"/>
+                  <a:srgbClr val="64748B"/>
+                </a:solidFill>
+              </a:defRPr>
+            </a:pPr>
+            <a:r>
+              <a:t>  Managed via CSS custom properties with persistent preference saved in localStorage.</a:t>
+            </a:r>
+          </a:p>
+          <a:p>
+            <a:pPr>
+              <a:spcBef>
+                <a:spcPts val="600"/>
+              </a:spcBef>
+              <a:defRPr sz="1050" b="1">
+                <a:solidFill>
+                  <a:srgbClr val="0F172A"/>
+                </a:solidFill>
+              </a:defRPr>
+            </a:pPr>
+            <a:r>
+              <a:t>Client-Side SHA-256 Hashing:</a:t>
+            </a:r>
+          </a:p>
+          <a:p>
+            <a:pPr>
+              <a:spcBef>
+                <a:spcPts val="100"/>
               </a:spcBef>
               <a:defRPr sz="950">
                 <a:solidFill>
-                  <a:srgbClr val="0F172A"/>
-                </a:solidFill>
-              </a:defRPr>
-            </a:pPr>
-            <a:r>
-              <a:t>MetricsModule: Formats currency &amp; numbers, renders KPI cards, and updates conditional status alerts.</a:t>
-            </a:r>
-          </a:p>
-          <a:p>
-            <a:pPr>
-              <a:spcBef>
-                <a:spcPts val="400"/>
+                  <a:srgbClr val="64748B"/>
+                </a:solidFill>
+              </a:defRPr>
+            </a:pPr>
+            <a:r>
+              <a:t>  Passwords hashed via browser Web Crypto API (crypto.subtle) before storage with pure JS fallback.</a:t>
+            </a:r>
+          </a:p>
+          <a:p>
+            <a:pPr>
+              <a:spcBef>
+                <a:spcPts val="600"/>
+              </a:spcBef>
+              <a:defRPr sz="1050" b="1">
+                <a:solidFill>
+                  <a:srgbClr val="0F172A"/>
+                </a:solidFill>
+              </a:defRPr>
+            </a:pPr>
+            <a:r>
+              <a:t>Modular Namespaces:</a:t>
+            </a:r>
+          </a:p>
+          <a:p>
+            <a:pPr>
+              <a:spcBef>
+                <a:spcPts val="100"/>
               </a:spcBef>
               <a:defRPr sz="950">
                 <a:solidFill>
-                  <a:srgbClr val="0F172A"/>
-                </a:solidFill>
-              </a:defRPr>
-            </a:pPr>
-            <a:r>
-              <a:t>ChartModule: Computes dynamic SVG viewBox domain, renders paths, loss/profit polygons, and crosshair overlays.</a:t>
-            </a:r>
-          </a:p>
-          <a:p>
-            <a:pPr>
-              <a:spcBef>
-                <a:spcPts val="400"/>
+                  <a:srgbClr val="64748B"/>
+                </a:solidFill>
+              </a:defRPr>
+            </a:pPr>
+            <a:r>
+              <a:t>  Clear separation of concerns across AuthModule, ProfileModule, MetricsModule, ChartModule, and ApiClient.</a:t>
+            </a:r>
+          </a:p>
+        </p:txBody>
+      </p:sp>
+      <p:pic>
+        <p:nvPicPr>
+          <p:cNvPr id="5" name="Picture 4" descr="screenshot_login.png"/>
+          <p:cNvPicPr>
+            <a:picLocks noChangeAspect="1"/>
+          </p:cNvPicPr>
+          <p:nvPr/>
+        </p:nvPicPr>
+        <p:blipFill>
+          <a:blip r:embed="rId2"/>
+          <a:stretch>
+            <a:fillRect/>
+          </a:stretch>
+        </p:blipFill>
+        <p:spPr>
+          <a:xfrm>
+            <a:off x="6309360" y="1463040"/>
+            <a:ext cx="5120640" cy="4663440"/>
+          </a:xfrm>
+          <a:prstGeom prst="rect">
+            <a:avLst/>
+          </a:prstGeom>
+        </p:spPr>
+      </p:pic>
+    </p:spTree>
+  </p:cSld>
+  <p:clrMapOvr>
+    <a:masterClrMapping/>
+  </p:clrMapOvr>
+</p:sld>
+</file>
+
+<file path=ppt/slides/slide4.xml><?xml version="1.0" encoding="utf-8"?>
+<p:sld xmlns:a="http://schemas.openxmlformats.org/drawingml/2006/main" xmlns:p="http://schemas.openxmlformats.org/presentationml/2006/main" xmlns:r="http://schemas.openxmlformats.org/officeDocument/2006/relationships">
+  <p:cSld>
+    <p:spTree>
+      <p:nvGrpSpPr>
+        <p:cNvPr id="1" name=""/>
+        <p:cNvGrpSpPr/>
+        <p:nvPr/>
+      </p:nvGrpSpPr>
+      <p:grpSpPr/>
+      <p:sp>
+        <p:nvSpPr>
+          <p:cNvPr id="2" name="TextBox 1"/>
+          <p:cNvSpPr txBox="1"/>
+          <p:nvPr/>
+        </p:nvSpPr>
+        <p:spPr>
+          <a:xfrm>
+            <a:off x="731520" y="365760"/>
+            <a:ext cx="10698480" cy="320040"/>
+          </a:xfrm>
+          <a:prstGeom prst="rect">
+            <a:avLst/>
+          </a:prstGeom>
+          <a:noFill/>
+        </p:spPr>
+        <p:txBody>
+          <a:bodyPr wrap="square">
+            <a:spAutoFit/>
+          </a:bodyPr>
+          <a:lstStyle/>
+          <a:p>
+            <a:pPr>
+              <a:defRPr sz="1100" b="1">
+                <a:solidFill>
+                  <a:srgbClr val="2563EB"/>
+                </a:solidFill>
+              </a:defRPr>
+            </a:pPr>
+            <a:r>
+              <a:t>VISUALIZATION ENGINE</a:t>
+            </a:r>
+          </a:p>
+        </p:txBody>
+      </p:sp>
+      <p:sp>
+        <p:nvSpPr>
+          <p:cNvPr id="3" name="TextBox 2"/>
+          <p:cNvSpPr txBox="1"/>
+          <p:nvPr/>
+        </p:nvSpPr>
+        <p:spPr>
+          <a:xfrm>
+            <a:off x="731520" y="640080"/>
+            <a:ext cx="10698480" cy="594360"/>
+          </a:xfrm>
+          <a:prstGeom prst="rect">
+            <a:avLst/>
+          </a:prstGeom>
+          <a:noFill/>
+        </p:spPr>
+        <p:txBody>
+          <a:bodyPr wrap="square">
+            <a:spAutoFit/>
+          </a:bodyPr>
+          <a:lstStyle/>
+          <a:p>
+            <a:pPr>
+              <a:defRPr sz="2400" b="1">
+                <a:solidFill>
+                  <a:srgbClr val="0F172A"/>
+                </a:solidFill>
+              </a:defRPr>
+            </a:pPr>
+            <a:r>
+              <a:t>Interactive SVG Chart &amp; Visualization Engine</a:t>
+            </a:r>
+          </a:p>
+        </p:txBody>
+      </p:sp>
+      <p:pic>
+        <p:nvPicPr>
+          <p:cNvPr id="4" name="Picture 3" descr="screenshot_chart.png"/>
+          <p:cNvPicPr>
+            <a:picLocks noChangeAspect="1"/>
+          </p:cNvPicPr>
+          <p:nvPr/>
+        </p:nvPicPr>
+        <p:blipFill>
+          <a:blip r:embed="rId2"/>
+          <a:stretch>
+            <a:fillRect/>
+          </a:stretch>
+        </p:blipFill>
+        <p:spPr>
+          <a:xfrm>
+            <a:off x="731520" y="1463040"/>
+            <a:ext cx="5486400" cy="4663440"/>
+          </a:xfrm>
+          <a:prstGeom prst="rect">
+            <a:avLst/>
+          </a:prstGeom>
+        </p:spPr>
+      </p:pic>
+      <p:sp>
+        <p:nvSpPr>
+          <p:cNvPr id="5" name="Rounded Rectangle 4"/>
+          <p:cNvSpPr/>
+          <p:nvPr/>
+        </p:nvSpPr>
+        <p:spPr>
+          <a:xfrm>
+            <a:off x="6492240" y="1463040"/>
+            <a:ext cx="4937760" cy="4663440"/>
+          </a:xfrm>
+          <a:prstGeom prst="roundRect">
+            <a:avLst/>
+          </a:prstGeom>
+          <a:solidFill>
+            <a:srgbClr val="FFFFFF"/>
+          </a:solidFill>
+          <a:ln w="19050">
+            <a:solidFill>
+              <a:srgbClr val="E2E8F0"/>
+            </a:solidFill>
+          </a:ln>
+        </p:spPr>
+        <p:style>
+          <a:lnRef idx="1">
+            <a:schemeClr val="accent1"/>
+          </a:lnRef>
+          <a:fillRef idx="3">
+            <a:schemeClr val="accent1"/>
+          </a:fillRef>
+          <a:effectRef idx="2">
+            <a:schemeClr val="accent1"/>
+          </a:effectRef>
+          <a:fontRef idx="minor">
+            <a:schemeClr val="lt1"/>
+          </a:fontRef>
+        </p:style>
+        <p:txBody>
+          <a:bodyPr rtlCol="0" anchor="ctr" wrap="square" lIns="274320" tIns="274320"/>
+          <a:lstStyle/>
+          <a:p>
+            <a:pPr algn="ctr">
+              <a:defRPr sz="1200" b="1">
+                <a:solidFill>
+                  <a:srgbClr val="7C3AED"/>
+                </a:solidFill>
+              </a:defRPr>
+            </a:pPr>
+            <a:r>
+              <a:t>CUSTOM COORDINATE MAPPING ENGINE</a:t>
+            </a:r>
+          </a:p>
+          <a:p>
+            <a:pPr>
+              <a:spcBef>
+                <a:spcPts val="500"/>
+              </a:spcBef>
+              <a:defRPr sz="1050" b="1">
+                <a:solidFill>
+                  <a:srgbClr val="0F172A"/>
+                </a:solidFill>
+              </a:defRPr>
+            </a:pPr>
+            <a:r>
+              <a:t>• No Third-Party Charting Libraries:</a:t>
+            </a:r>
+          </a:p>
+          <a:p>
+            <a:pPr>
+              <a:spcBef>
+                <a:spcPts val="100"/>
               </a:spcBef>
               <a:defRPr sz="950">
                 <a:solidFill>
-                  <a:srgbClr val="0F172A"/>
-                </a:solidFill>
-              </a:defRPr>
-            </a:pPr>
-            <a:r>
-              <a:t>SensitivityModule: Computes sensitivity table variations across -20% to +20% for each cost driver.</a:t>
-            </a:r>
-          </a:p>
-          <a:p>
-            <a:pPr>
-              <a:spcBef>
-                <a:spcPts val="400"/>
+                  <a:srgbClr val="64748B"/>
+                </a:solidFill>
+              </a:defRPr>
+            </a:pPr>
+            <a:r>
+              <a:t>  All graphics generated dynamically via native inline SVG elements, avoiding heavy dependencies like Chart.js or D3.</a:t>
+            </a:r>
+          </a:p>
+          <a:p>
+            <a:pPr>
+              <a:spcBef>
+                <a:spcPts val="500"/>
+              </a:spcBef>
+              <a:defRPr sz="1050" b="1">
+                <a:solidFill>
+                  <a:srgbClr val="0F172A"/>
+                </a:solidFill>
+              </a:defRPr>
+            </a:pPr>
+            <a:r>
+              <a:t>• Dynamic Coordinate Projection:</a:t>
+            </a:r>
+          </a:p>
+          <a:p>
+            <a:pPr>
+              <a:spcBef>
+                <a:spcPts val="100"/>
               </a:spcBef>
               <a:defRPr sz="950">
                 <a:solidFill>
-                  <a:srgbClr val="0F172A"/>
-                </a:solidFill>
-              </a:defRPr>
-            </a:pPr>
-            <a:r>
-              <a:t>WhatIfModule: Calculates real-time variances and deltas vs baseline for interactive sliders.</a:t>
+                  <a:srgbClr val="64748B"/>
+                </a:solidFill>
+              </a:defRPr>
+            </a:pPr>
+            <a:r>
+              <a:t>  Translates financial values into SVG viewBox space using getX(q) and getY(val) with dynamic domain bounds.</a:t>
+            </a:r>
+          </a:p>
+          <a:p>
+            <a:pPr>
+              <a:spcBef>
+                <a:spcPts val="500"/>
+              </a:spcBef>
+              <a:defRPr sz="1050" b="1">
+                <a:solidFill>
+                  <a:srgbClr val="0F172A"/>
+                </a:solidFill>
+              </a:defRPr>
+            </a:pPr>
+            <a:r>
+              <a:t>• Visual Profit &amp; Loss Polygons:</a:t>
+            </a:r>
+          </a:p>
+          <a:p>
+            <a:pPr>
+              <a:spcBef>
+                <a:spcPts val="100"/>
+              </a:spcBef>
+              <a:defRPr sz="950">
+                <a:solidFill>
+                  <a:srgbClr val="64748B"/>
+                </a:solidFill>
+              </a:defRPr>
+            </a:pPr>
+            <a:r>
+              <a:t>  Shades the operating loss zone in red (0 to Break-Even) and profit zone in green (Break-Even to Max Volume).</a:t>
+            </a:r>
+          </a:p>
+          <a:p>
+            <a:pPr>
+              <a:spcBef>
+                <a:spcPts val="500"/>
+              </a:spcBef>
+              <a:defRPr sz="1050" b="1">
+                <a:solidFill>
+                  <a:srgbClr val="0F172A"/>
+                </a:solidFill>
+              </a:defRPr>
+            </a:pPr>
+            <a:r>
+              <a:t>• Break-Even Callout Point:</a:t>
+            </a:r>
+          </a:p>
+          <a:p>
+            <a:pPr>
+              <a:spcBef>
+                <a:spcPts val="100"/>
+              </a:spcBef>
+              <a:defRPr sz="950">
+                <a:solidFill>
+                  <a:srgbClr val="64748B"/>
+                </a:solidFill>
+              </a:defRPr>
+            </a:pPr>
+            <a:r>
+              <a:t>  Highlights the exact intersection point of Total Revenue and Total Cost with a pulsing halo and coordinate badge.</a:t>
+            </a:r>
+          </a:p>
+          <a:p>
+            <a:pPr>
+              <a:spcBef>
+                <a:spcPts val="500"/>
+              </a:spcBef>
+              <a:defRPr sz="1050" b="1">
+                <a:solidFill>
+                  <a:srgbClr val="0F172A"/>
+                </a:solidFill>
+              </a:defRPr>
+            </a:pPr>
+            <a:r>
+              <a:t>• Interactive Crosshair &amp; Tooltip:</a:t>
+            </a:r>
+          </a:p>
+          <a:p>
+            <a:pPr>
+              <a:spcBef>
+                <a:spcPts val="100"/>
+              </a:spcBef>
+              <a:defRPr sz="950">
+                <a:solidFill>
+                  <a:srgbClr val="64748B"/>
+                </a:solidFill>
+              </a:defRPr>
+            </a:pPr>
+            <a:r>
+              <a:t>  Hover/touch tracking computes volume, revenue, costs, and profit with 60fps responsiveness.</a:t>
+            </a:r>
+          </a:p>
+        </p:txBody>
+      </p:sp>
+    </p:spTree>
+  </p:cSld>
+  <p:clrMapOvr>
+    <a:masterClrMapping/>
+  </p:clrMapOvr>
+</p:sld>
+</file>
+
+<file path=ppt/slides/slide5.xml><?xml version="1.0" encoding="utf-8"?>
+<p:sld xmlns:a="http://schemas.openxmlformats.org/drawingml/2006/main" xmlns:p="http://schemas.openxmlformats.org/presentationml/2006/main" xmlns:r="http://schemas.openxmlformats.org/officeDocument/2006/relationships">
+  <p:cSld>
+    <p:spTree>
+      <p:nvGrpSpPr>
+        <p:cNvPr id="1" name=""/>
+        <p:cNvGrpSpPr/>
+        <p:nvPr/>
+      </p:nvGrpSpPr>
+      <p:grpSpPr/>
+      <p:sp>
+        <p:nvSpPr>
+          <p:cNvPr id="2" name="TextBox 1"/>
+          <p:cNvSpPr txBox="1"/>
+          <p:nvPr/>
+        </p:nvSpPr>
+        <p:spPr>
+          <a:xfrm>
+            <a:off x="731520" y="365760"/>
+            <a:ext cx="10698480" cy="320040"/>
+          </a:xfrm>
+          <a:prstGeom prst="rect">
+            <a:avLst/>
+          </a:prstGeom>
+          <a:noFill/>
+        </p:spPr>
+        <p:txBody>
+          <a:bodyPr wrap="square">
+            <a:spAutoFit/>
+          </a:bodyPr>
+          <a:lstStyle/>
+          <a:p>
+            <a:pPr>
+              <a:defRPr sz="1100" b="1">
+                <a:solidFill>
+                  <a:srgbClr val="2563EB"/>
+                </a:solidFill>
+              </a:defRPr>
+            </a:pPr>
+            <a:r>
+              <a:t>BACKEND &amp; DATABASE</a:t>
+            </a:r>
+          </a:p>
+        </p:txBody>
+      </p:sp>
+      <p:sp>
+        <p:nvSpPr>
+          <p:cNvPr id="3" name="TextBox 2"/>
+          <p:cNvSpPr txBox="1"/>
+          <p:nvPr/>
+        </p:nvSpPr>
+        <p:spPr>
+          <a:xfrm>
+            <a:off x="731520" y="640080"/>
+            <a:ext cx="10698480" cy="594360"/>
+          </a:xfrm>
+          <a:prstGeom prst="rect">
+            <a:avLst/>
+          </a:prstGeom>
+          <a:noFill/>
+        </p:spPr>
+        <p:txBody>
+          <a:bodyPr wrap="square">
+            <a:spAutoFit/>
+          </a:bodyPr>
+          <a:lstStyle/>
+          <a:p>
+            <a:pPr>
+              <a:defRPr sz="2400" b="1">
+                <a:solidFill>
+                  <a:srgbClr val="0F172A"/>
+                </a:solidFill>
+              </a:defRPr>
+            </a:pPr>
+            <a:r>
+              <a:t>Backend Architecture, REST APIs &amp; SQLite3</a:t>
+            </a:r>
+          </a:p>
+        </p:txBody>
+      </p:sp>
+      <p:sp>
+        <p:nvSpPr>
+          <p:cNvPr id="4" name="Rounded Rectangle 3"/>
+          <p:cNvSpPr/>
+          <p:nvPr/>
+        </p:nvSpPr>
+        <p:spPr>
+          <a:xfrm>
+            <a:off x="731520" y="1463040"/>
+            <a:ext cx="5120640" cy="4663440"/>
+          </a:xfrm>
+          <a:prstGeom prst="roundRect">
+            <a:avLst/>
+          </a:prstGeom>
+          <a:solidFill>
+            <a:srgbClr val="FFFFFF"/>
+          </a:solidFill>
+          <a:ln w="19050">
+            <a:solidFill>
+              <a:srgbClr val="E2E8F0"/>
+            </a:solidFill>
+          </a:ln>
+        </p:spPr>
+        <p:style>
+          <a:lnRef idx="1">
+            <a:schemeClr val="accent1"/>
+          </a:lnRef>
+          <a:fillRef idx="3">
+            <a:schemeClr val="accent1"/>
+          </a:fillRef>
+          <a:effectRef idx="2">
+            <a:schemeClr val="accent1"/>
+          </a:effectRef>
+          <a:fontRef idx="minor">
+            <a:schemeClr val="lt1"/>
+          </a:fontRef>
+        </p:style>
+        <p:txBody>
+          <a:bodyPr rtlCol="0" anchor="ctr" wrap="square" lIns="274320" tIns="274320"/>
+          <a:lstStyle/>
+          <a:p>
+            <a:pPr algn="ctr">
+              <a:defRPr sz="1200" b="1">
+                <a:solidFill>
+                  <a:srgbClr val="2563EB"/>
+                </a:solidFill>
+              </a:defRPr>
+            </a:pPr>
+            <a:r>
+              <a:t>TRIPLE-RUNTIME BACKEND SERVERS</a:t>
+            </a:r>
+          </a:p>
+          <a:p>
+            <a:pPr>
+              <a:spcBef>
+                <a:spcPts val="600"/>
+              </a:spcBef>
+              <a:defRPr sz="1050" b="1">
+                <a:solidFill>
+                  <a:srgbClr val="0F172A"/>
+                </a:solidFill>
+              </a:defRPr>
+            </a:pPr>
+            <a:r>
+              <a:t>Python 3 Server (server.py):</a:t>
+            </a:r>
+          </a:p>
+          <a:p>
+            <a:pPr>
+              <a:spcBef>
+                <a:spcPts val="100"/>
+              </a:spcBef>
+              <a:defRPr sz="950">
+                <a:solidFill>
+                  <a:srgbClr val="64748B"/>
+                </a:solidFill>
+              </a:defRPr>
+            </a:pPr>
+            <a:r>
+              <a:t>  Built with native http.server and sqlite3. Zero pip packages required.</a:t>
+            </a:r>
+          </a:p>
+          <a:p>
+            <a:pPr>
+              <a:spcBef>
+                <a:spcPts val="600"/>
+              </a:spcBef>
+              <a:defRPr sz="1050" b="1">
+                <a:solidFill>
+                  <a:srgbClr val="0F172A"/>
+                </a:solidFill>
+              </a:defRPr>
+            </a:pPr>
+            <a:r>
+              <a:t>Ruby Server (server.rb):</a:t>
+            </a:r>
+          </a:p>
+          <a:p>
+            <a:pPr>
+              <a:spcBef>
+                <a:spcPts val="100"/>
+              </a:spcBef>
+              <a:defRPr sz="950">
+                <a:solidFill>
+                  <a:srgbClr val="64748B"/>
+                </a:solidFill>
+              </a:defRPr>
+            </a:pPr>
+            <a:r>
+              <a:t>  Built with WEBrick and native sqlite3 gem. Zero bundler/gem installs needed.</a:t>
+            </a:r>
+          </a:p>
+          <a:p>
+            <a:pPr>
+              <a:spcBef>
+                <a:spcPts val="600"/>
+              </a:spcBef>
+              <a:defRPr sz="1050" b="1">
+                <a:solidFill>
+                  <a:srgbClr val="0F172A"/>
+                </a:solidFill>
+              </a:defRPr>
+            </a:pPr>
+            <a:r>
+              <a:t>Node.js Server (server.js):</a:t>
+            </a:r>
+          </a:p>
+          <a:p>
+            <a:pPr>
+              <a:spcBef>
+                <a:spcPts val="100"/>
+              </a:spcBef>
+              <a:defRPr sz="950">
+                <a:solidFill>
+                  <a:srgbClr val="64748B"/>
+                </a:solidFill>
+              </a:defRPr>
+            </a:pPr>
+            <a:r>
+              <a:t>  Built with standard http, crypto, and fs modules.</a:t>
+            </a:r>
+          </a:p>
+          <a:p>
+            <a:pPr>
+              <a:spcBef>
+                <a:spcPts val="600"/>
+              </a:spcBef>
+              <a:defRPr sz="1050" b="1">
+                <a:solidFill>
+                  <a:srgbClr val="0F172A"/>
+                </a:solidFill>
+              </a:defRPr>
+            </a:pPr>
+            <a:r>
+              <a:t>Universal Launcher (start.sh):</a:t>
+            </a:r>
+          </a:p>
+          <a:p>
+            <a:pPr>
+              <a:spcBef>
+                <a:spcPts val="100"/>
+              </a:spcBef>
+              <a:defRPr sz="950">
+                <a:solidFill>
+                  <a:srgbClr val="64748B"/>
+                </a:solidFill>
+              </a:defRPr>
+            </a:pPr>
+            <a:r>
+              <a:t>  Auto-detects which runtime is installed on the host and starts on port 8000.</a:t>
+            </a:r>
+          </a:p>
+          <a:p>
+            <a:pPr>
+              <a:spcBef>
+                <a:spcPts val="600"/>
+              </a:spcBef>
+              <a:defRPr sz="1050" b="1">
+                <a:solidFill>
+                  <a:srgbClr val="0F172A"/>
+                </a:solidFill>
+              </a:defRPr>
+            </a:pPr>
+            <a:r>
+              <a:t>Relational SQLite Database (breakeven.db):</a:t>
+            </a:r>
+          </a:p>
+          <a:p>
+            <a:pPr>
+              <a:spcBef>
+                <a:spcPts val="100"/>
+              </a:spcBef>
+              <a:defRPr sz="950">
+                <a:solidFill>
+                  <a:srgbClr val="64748B"/>
+                </a:solidFill>
+              </a:defRPr>
+            </a:pPr>
+            <a:r>
+              <a:t>  Structured schemas for Users (with SHA-256 tokens), Business Profiles, and Cost Inputs.</a:t>
             </a:r>
           </a:p>
         </p:txBody>
@@ -5569,147 +4656,132 @@
             <a:pPr algn="ctr">
               <a:defRPr sz="1200" b="1">
                 <a:solidFill>
+                  <a:srgbClr val="059669"/>
+                </a:solidFill>
+              </a:defRPr>
+            </a:pPr>
+            <a:r>
+              <a:t>REST API CONTRACT &amp; PERSISTENCE FLOW</a:t>
+            </a:r>
+          </a:p>
+          <a:p>
+            <a:pPr>
+              <a:spcBef>
+                <a:spcPts val="500"/>
+              </a:spcBef>
+              <a:defRPr sz="950">
+                <a:solidFill>
+                  <a:srgbClr val="0F172A"/>
+                </a:solidFill>
+              </a:defRPr>
+            </a:pPr>
+            <a:r>
+              <a:t>• POST /api/auth/signup: Registers user, hashes password, seeds default profile &amp; inputs.</a:t>
+            </a:r>
+          </a:p>
+          <a:p>
+            <a:pPr>
+              <a:spcBef>
+                <a:spcPts val="500"/>
+              </a:spcBef>
+              <a:defRPr sz="950">
+                <a:solidFill>
+                  <a:srgbClr val="0F172A"/>
+                </a:solidFill>
+              </a:defRPr>
+            </a:pPr>
+            <a:r>
+              <a:t>• POST /api/auth/login: Authenticates credentials and returns a 24-byte bearer token.</a:t>
+            </a:r>
+          </a:p>
+          <a:p>
+            <a:pPr>
+              <a:spcBef>
+                <a:spcPts val="500"/>
+              </a:spcBef>
+              <a:defRPr sz="950">
+                <a:solidFill>
+                  <a:srgbClr val="0F172A"/>
+                </a:solidFill>
+              </a:defRPr>
+            </a:pPr>
+            <a:r>
+              <a:t>• GET /api/auth/me: Validates session token and returns user profile &amp; inputs.</a:t>
+            </a:r>
+          </a:p>
+          <a:p>
+            <a:pPr>
+              <a:spcBef>
+                <a:spcPts val="500"/>
+              </a:spcBef>
+              <a:defRPr sz="950">
+                <a:solidFill>
+                  <a:srgbClr val="0F172A"/>
+                </a:solidFill>
+              </a:defRPr>
+            </a:pPr>
+            <a:r>
+              <a:t>• GET &amp; POST /api/profile: Retrieves and updates business metadata in SQLite3.</a:t>
+            </a:r>
+          </a:p>
+          <a:p>
+            <a:pPr>
+              <a:spcBef>
+                <a:spcPts val="500"/>
+              </a:spcBef>
+              <a:defRPr sz="950">
+                <a:solidFill>
+                  <a:srgbClr val="0F172A"/>
+                </a:solidFill>
+              </a:defRPr>
+            </a:pPr>
+            <a:r>
+              <a:t>• GET &amp; POST /api/inputs: Persists cost drivers with debounced client auto-saving.</a:t>
+            </a:r>
+          </a:p>
+          <a:p>
+            <a:pPr>
+              <a:spcBef>
+                <a:spcPts val="500"/>
+              </a:spcBef>
+              <a:defRPr sz="950">
+                <a:solidFill>
+                  <a:srgbClr val="0F172A"/>
+                </a:solidFill>
+              </a:defRPr>
+            </a:pPr>
+            <a:r>
+              <a:t>• POST /api/calculate: Server-side verification of mathematical break-even model.</a:t>
+            </a:r>
+          </a:p>
+          <a:p>
+            <a:pPr>
+              <a:spcBef>
+                <a:spcPts val="800"/>
+              </a:spcBef>
+              <a:defRPr sz="1050" b="1">
+                <a:solidFill>
                   <a:srgbClr val="7C3AED"/>
                 </a:solidFill>
               </a:defRPr>
             </a:pPr>
             <a:r>
-              <a:t>BACKEND ARCHITECTURE &amp; REST SPECIFICATION</a:t>
-            </a:r>
-          </a:p>
-          <a:p>
-            <a:pPr>
-              <a:spcBef>
-                <a:spcPts val="400"/>
-              </a:spcBef>
-              <a:defRPr sz="950">
-                <a:solidFill>
-                  <a:srgbClr val="0F172A"/>
-                </a:solidFill>
-              </a:defRPr>
-            </a:pPr>
-            <a:r>
-              <a:t>GET /api/health: Health probe &amp; database connectivity status.</a:t>
-            </a:r>
-          </a:p>
-          <a:p>
-            <a:pPr>
-              <a:spcBef>
-                <a:spcPts val="400"/>
-              </a:spcBef>
-              <a:defRPr sz="950">
-                <a:solidFill>
-                  <a:srgbClr val="0F172A"/>
-                </a:solidFill>
-              </a:defRPr>
-            </a:pPr>
-            <a:r>
-              <a:t>POST /api/auth/signup: Registers new account with SHA-256 hashed password.</a:t>
-            </a:r>
-          </a:p>
-          <a:p>
-            <a:pPr>
-              <a:spcBef>
-                <a:spcPts val="400"/>
-              </a:spcBef>
-              <a:defRPr sz="950">
-                <a:solidFill>
-                  <a:srgbClr val="0F172A"/>
-                </a:solidFill>
-              </a:defRPr>
-            </a:pPr>
-            <a:r>
-              <a:t>POST /api/auth/login: Authenticates user and returns 24-byte bearer token.</a:t>
-            </a:r>
-          </a:p>
-          <a:p>
-            <a:pPr>
-              <a:spcBef>
-                <a:spcPts val="400"/>
-              </a:spcBef>
-              <a:defRPr sz="950">
-                <a:solidFill>
-                  <a:srgbClr val="0F172A"/>
-                </a:solidFill>
-              </a:defRPr>
-            </a:pPr>
-            <a:r>
-              <a:t>GET /api/auth/me: Validates bearer session; fetches profile and cost inputs.</a:t>
-            </a:r>
-          </a:p>
-          <a:p>
-            <a:pPr>
-              <a:spcBef>
-                <a:spcPts val="400"/>
-              </a:spcBef>
-              <a:defRPr sz="950">
-                <a:solidFill>
-                  <a:srgbClr val="0F172A"/>
-                </a:solidFill>
-              </a:defRPr>
-            </a:pPr>
-            <a:r>
-              <a:t>GET &amp; POST /api/profile: Retrieves and updates business profile in SQLite3.</a:t>
-            </a:r>
-          </a:p>
-          <a:p>
-            <a:pPr>
-              <a:spcBef>
-                <a:spcPts val="400"/>
-              </a:spcBef>
-              <a:defRPr sz="950">
-                <a:solidFill>
-                  <a:srgbClr val="0F172A"/>
-                </a:solidFill>
-              </a:defRPr>
-            </a:pPr>
-            <a:r>
-              <a:t>GET &amp; POST /api/inputs: Retrieves and saves cost drivers (debounced autosave).</a:t>
-            </a:r>
-          </a:p>
-          <a:p>
-            <a:pPr>
-              <a:spcBef>
-                <a:spcPts val="400"/>
-              </a:spcBef>
-              <a:defRPr sz="950">
-                <a:solidFill>
-                  <a:srgbClr val="0F172A"/>
-                </a:solidFill>
-              </a:defRPr>
-            </a:pPr>
-            <a:r>
-              <a:t>POST /api/calculate: Server-side verification of mathematical model results.</a:t>
-            </a:r>
-          </a:p>
-          <a:p>
-            <a:pPr>
-              <a:spcBef>
-                <a:spcPts val="1200"/>
-              </a:spcBef>
-              <a:defRPr sz="1050" b="1">
-                <a:solidFill>
-                  <a:srgbClr val="059669"/>
-                </a:solidFill>
-              </a:defRPr>
-            </a:pPr>
-            <a:r>
-              <a:t>Dual-Engine Synchronization Logic:</a:t>
-            </a:r>
-          </a:p>
-          <a:p>
-            <a:pPr>
-              <a:spcBef>
-                <a:spcPts val="200"/>
-              </a:spcBef>
-              <a:defRPr sz="950">
+              <a:t>Dual-Engine Resilience Logic:</a:t>
+            </a:r>
+          </a:p>
+          <a:p>
+            <a:pPr>
+              <a:spcBef>
+                <a:spcPts val="100"/>
+              </a:spcBef>
+              <a:defRPr sz="900">
                 <a:solidFill>
                   <a:srgbClr val="64748B"/>
                 </a:solidFill>
               </a:defRPr>
             </a:pPr>
             <a:r>
-              <a:t>ApiClient detects server availability via /api/health. If available, all mutations write to SQLite3 with debounced HTTP calls. If offline or opened via file://, seamless fallback stores data in localStorage.</a:t>
+              <a:t>The ApiClient probes /api/health. If connected, data writes to SQLite3; if the server is offline or opened as file://, it gracefully falls back to localStorage.</a:t>
             </a:r>
           </a:p>
         </p:txBody>
@@ -5722,7 +4794,7 @@
 </p:sld>
 </file>
 
-<file path=ppt/slides/slide7.xml><?xml version="1.0" encoding="utf-8"?>
+<file path=ppt/slides/slide6.xml><?xml version="1.0" encoding="utf-8"?>
 <p:sld xmlns:a="http://schemas.openxmlformats.org/drawingml/2006/main" xmlns:p="http://schemas.openxmlformats.org/presentationml/2006/main" xmlns:r="http://schemas.openxmlformats.org/officeDocument/2006/relationships">
   <p:cSld>
     <p:spTree>
@@ -5762,7 +4834,7 @@
               </a:defRPr>
             </a:pPr>
             <a:r>
-              <a:t>CONCLUSION &amp; IMPACT</a:t>
+              <a:t>ANALYTICS ENGINE</a:t>
             </a:r>
           </a:p>
         </p:txBody>
@@ -5797,7 +4869,7 @@
               </a:defRPr>
             </a:pPr>
             <a:r>
-              <a:t>Results, Academic Evaluation &amp; Future Scope</a:t>
+              <a:t>Mathematical Model &amp; What-If Simulations</a:t>
             </a:r>
           </a:p>
         </p:txBody>
@@ -5840,7 +4912,7 @@
           </a:fontRef>
         </p:style>
         <p:txBody>
-          <a:bodyPr rtlCol="0" anchor="ctr" wrap="square" lIns="320040" tIns="274320"/>
+          <a:bodyPr rtlCol="0" anchor="ctr" wrap="square" lIns="274320" tIns="274320"/>
           <a:lstStyle/>
           <a:p>
             <a:pPr algn="ctr">
@@ -5851,82 +4923,127 @@
               </a:defRPr>
             </a:pPr>
             <a:r>
-              <a:t>PROJECT DELIVERABLES &amp; OUTCOMES</a:t>
-            </a:r>
-          </a:p>
-          <a:p>
-            <a:pPr>
-              <a:spcBef>
-                <a:spcPts val="700"/>
-              </a:spcBef>
-              <a:defRPr sz="1050">
-                <a:solidFill>
-                  <a:srgbClr val="0F172A"/>
-                </a:solidFill>
-              </a:defRPr>
-            </a:pPr>
-            <a:r>
-              <a:t>✔ 100% Zero-Dependency Standalone Platform: Operates instantly without package managers, external runtime installations, or build tools.</a:t>
-            </a:r>
-          </a:p>
-          <a:p>
-            <a:pPr>
-              <a:spcBef>
-                <a:spcPts val="700"/>
-              </a:spcBef>
-              <a:defRPr sz="1050">
-                <a:solidFill>
-                  <a:srgbClr val="0F172A"/>
-                </a:solidFill>
-              </a:defRPr>
-            </a:pPr>
-            <a:r>
-              <a:t>✔ Production-Grade Deployment: Live and globally accessible via GitHub Pages at https://arjun2007arush2011-max.github.io/break_even_point/</a:t>
-            </a:r>
-          </a:p>
-          <a:p>
-            <a:pPr>
-              <a:spcBef>
-                <a:spcPts val="700"/>
-              </a:spcBef>
-              <a:defRPr sz="1050">
-                <a:solidFill>
-                  <a:srgbClr val="0F172A"/>
-                </a:solidFill>
-              </a:defRPr>
-            </a:pPr>
-            <a:r>
-              <a:t>✔ Multi-Language Server Implementations: Clean, idiomatic backends provided in Ruby, Python 3, and Node.js using SQLite3 relational storage.</a:t>
-            </a:r>
-          </a:p>
-          <a:p>
-            <a:pPr>
-              <a:spcBef>
-                <a:spcPts val="700"/>
-              </a:spcBef>
-              <a:defRPr sz="1050">
-                <a:solidFill>
-                  <a:srgbClr val="0F172A"/>
-                </a:solidFill>
-              </a:defRPr>
-            </a:pPr>
-            <a:r>
-              <a:t>✔ Search-Engine Optimized: Complete SEO tags, OpenGraph previews, robots.txt, and sitemap.xml for indexing.</a:t>
-            </a:r>
-          </a:p>
-          <a:p>
-            <a:pPr>
-              <a:spcBef>
-                <a:spcPts val="700"/>
-              </a:spcBef>
-              <a:defRPr sz="1050">
-                <a:solidFill>
-                  <a:srgbClr val="0F172A"/>
-                </a:solidFill>
-              </a:defRPr>
-            </a:pPr>
-            <a:r>
-              <a:t>✔ Exceptional Performance: Instantaneous sub-millisecond calculation updates and smooth 60fps SVG chart recalculations.</a:t>
+              <a:t>FINANCIAL MODEL EQUATIONS</a:t>
+            </a:r>
+          </a:p>
+          <a:p>
+            <a:pPr>
+              <a:spcBef>
+                <a:spcPts val="400"/>
+              </a:spcBef>
+              <a:defRPr sz="950">
+                <a:solidFill>
+                  <a:srgbClr val="0F172A"/>
+                </a:solidFill>
+              </a:defRPr>
+            </a:pPr>
+            <a:r>
+              <a:t>Contribution Margin (CM): CM = Selling Price (P) - Variable Cost (V)</a:t>
+            </a:r>
+          </a:p>
+          <a:p>
+            <a:pPr>
+              <a:spcBef>
+                <a:spcPts val="400"/>
+              </a:spcBef>
+              <a:defRPr sz="950">
+                <a:solidFill>
+                  <a:srgbClr val="0F172A"/>
+                </a:solidFill>
+              </a:defRPr>
+            </a:pPr>
+            <a:r>
+              <a:t>Contribution Margin Ratio: CM% = (P - V) / P</a:t>
+            </a:r>
+          </a:p>
+          <a:p>
+            <a:pPr>
+              <a:spcBef>
+                <a:spcPts val="400"/>
+              </a:spcBef>
+              <a:defRPr sz="950">
+                <a:solidFill>
+                  <a:srgbClr val="0F172A"/>
+                </a:solidFill>
+              </a:defRPr>
+            </a:pPr>
+            <a:r>
+              <a:t>Break-Even Volume (Units): Q_BE = Fixed Costs (F) / (P - V)</a:t>
+            </a:r>
+          </a:p>
+          <a:p>
+            <a:pPr>
+              <a:spcBef>
+                <a:spcPts val="400"/>
+              </a:spcBef>
+              <a:defRPr sz="950">
+                <a:solidFill>
+                  <a:srgbClr val="0F172A"/>
+                </a:solidFill>
+              </a:defRPr>
+            </a:pPr>
+            <a:r>
+              <a:t>Break-Even Revenue: R_BE = Q_BE × P = F / CM%</a:t>
+            </a:r>
+          </a:p>
+          <a:p>
+            <a:pPr>
+              <a:spcBef>
+                <a:spcPts val="400"/>
+              </a:spcBef>
+              <a:defRPr sz="950">
+                <a:solidFill>
+                  <a:srgbClr val="0F172A"/>
+                </a:solidFill>
+              </a:defRPr>
+            </a:pPr>
+            <a:r>
+              <a:t>Net Operating Profit: Profit = Q × (P - V) - F</a:t>
+            </a:r>
+          </a:p>
+          <a:p>
+            <a:pPr>
+              <a:spcBef>
+                <a:spcPts val="400"/>
+              </a:spcBef>
+              <a:defRPr sz="950">
+                <a:solidFill>
+                  <a:srgbClr val="0F172A"/>
+                </a:solidFill>
+              </a:defRPr>
+            </a:pPr>
+            <a:r>
+              <a:t>Margin of Safety (MOS): MOS = (Q - Q_BE) / Q × 100%</a:t>
+            </a:r>
+          </a:p>
+          <a:p>
+            <a:pPr>
+              <a:spcBef>
+                <a:spcPts val="400"/>
+              </a:spcBef>
+              <a:defRPr sz="950">
+                <a:solidFill>
+                  <a:srgbClr val="0F172A"/>
+                </a:solidFill>
+              </a:defRPr>
+            </a:pPr>
+            <a:r>
+              <a:t>Degree of Operating Leverage: DOL = (Q × CM) / Profit</a:t>
+            </a:r>
+          </a:p>
+          <a:p>
+            <a:pPr>
+              <a:spcBef>
+                <a:spcPts val="400"/>
+              </a:spcBef>
+              <a:defRPr sz="950">
+                <a:solidFill>
+                  <a:srgbClr val="0F172A"/>
+                </a:solidFill>
+              </a:defRPr>
+            </a:pPr>
+            <a:r>
+              <a:t>Target Profit Units: Q_Target = (F + Target) / CM</a:t>
             </a:r>
           </a:p>
         </p:txBody>
@@ -5969,7 +5086,7 @@
           </a:fontRef>
         </p:style>
         <p:txBody>
-          <a:bodyPr rtlCol="0" anchor="ctr" wrap="square" lIns="320040" tIns="274320"/>
+          <a:bodyPr rtlCol="0" anchor="ctr" wrap="square" lIns="274320" tIns="274320"/>
           <a:lstStyle/>
           <a:p>
             <a:pPr algn="ctr">
@@ -5980,7 +5097,269 @@
               </a:defRPr>
             </a:pPr>
             <a:r>
-              <a:t>ACADEMIC IMPACT &amp; FUTURE ENHANCEMENTS</a:t>
+              <a:t>WHAT-IF SIMULATIONS &amp; STRESS MATRICES</a:t>
+            </a:r>
+          </a:p>
+          <a:p>
+            <a:pPr>
+              <a:spcBef>
+                <a:spcPts val="600"/>
+              </a:spcBef>
+              <a:defRPr sz="1050" b="1">
+                <a:solidFill>
+                  <a:srgbClr val="0F172A"/>
+                </a:solidFill>
+              </a:defRPr>
+            </a:pPr>
+            <a:r>
+              <a:t>Real-Time What-If Sliders:</a:t>
+            </a:r>
+          </a:p>
+          <a:p>
+            <a:pPr>
+              <a:spcBef>
+                <a:spcPts val="100"/>
+              </a:spcBef>
+              <a:defRPr sz="950">
+                <a:solidFill>
+                  <a:srgbClr val="64748B"/>
+                </a:solidFill>
+              </a:defRPr>
+            </a:pPr>
+            <a:r>
+              <a:t>  Dual-direction sliders (-50% to +50%) for Price, Var Cost, and Fixed Costs compute live variances versus baseline.</a:t>
+            </a:r>
+          </a:p>
+          <a:p>
+            <a:pPr>
+              <a:spcBef>
+                <a:spcPts val="600"/>
+              </a:spcBef>
+              <a:defRPr sz="1050" b="1">
+                <a:solidFill>
+                  <a:srgbClr val="0F172A"/>
+                </a:solidFill>
+              </a:defRPr>
+            </a:pPr>
+            <a:r>
+              <a:t>Sensitivity Matrix Table:</a:t>
+            </a:r>
+          </a:p>
+          <a:p>
+            <a:pPr>
+              <a:spcBef>
+                <a:spcPts val="100"/>
+              </a:spcBef>
+              <a:defRPr sz="950">
+                <a:solidFill>
+                  <a:srgbClr val="64748B"/>
+                </a:solidFill>
+              </a:defRPr>
+            </a:pPr>
+            <a:r>
+              <a:t>  Evaluates Required BE Units when each driver shifts by -20%, -10%, 0%, +10%, and +20%.</a:t>
+            </a:r>
+          </a:p>
+          <a:p>
+            <a:pPr>
+              <a:spcBef>
+                <a:spcPts val="600"/>
+              </a:spcBef>
+              <a:defRPr sz="1050" b="1">
+                <a:solidFill>
+                  <a:srgbClr val="0F172A"/>
+                </a:solidFill>
+              </a:defRPr>
+            </a:pPr>
+            <a:r>
+              <a:t>Volume Scenario Table:</a:t>
+            </a:r>
+          </a:p>
+          <a:p>
+            <a:pPr>
+              <a:spcBef>
+                <a:spcPts val="100"/>
+              </a:spcBef>
+              <a:defRPr sz="950">
+                <a:solidFill>
+                  <a:srgbClr val="64748B"/>
+                </a:solidFill>
+              </a:defRPr>
+            </a:pPr>
+            <a:r>
+              <a:t>  Projects outcomes under Pessimistic (-25% volume), Expected Base, and Optimistic (+25% volume) market conditions.</a:t>
+            </a:r>
+          </a:p>
+          <a:p>
+            <a:pPr>
+              <a:spcBef>
+                <a:spcPts val="600"/>
+              </a:spcBef>
+              <a:defRPr sz="1050" b="1">
+                <a:solidFill>
+                  <a:srgbClr val="0F172A"/>
+                </a:solidFill>
+              </a:defRPr>
+            </a:pPr>
+            <a:r>
+              <a:t>Automated Feasibility Guards:</a:t>
+            </a:r>
+          </a:p>
+          <a:p>
+            <a:pPr>
+              <a:spcBef>
+                <a:spcPts val="100"/>
+              </a:spcBef>
+              <a:defRPr sz="950">
+                <a:solidFill>
+                  <a:srgbClr val="64748B"/>
+                </a:solidFill>
+              </a:defRPr>
+            </a:pPr>
+            <a:r>
+              <a:t>  Immediately detects and warns if Price ≤ Variable Cost (structural loss condition) or if planned volume Q &lt; Q_BE.</a:t>
+            </a:r>
+          </a:p>
+        </p:txBody>
+      </p:sp>
+    </p:spTree>
+  </p:cSld>
+  <p:clrMapOvr>
+    <a:masterClrMapping/>
+  </p:clrMapOvr>
+</p:sld>
+</file>
+
+<file path=ppt/slides/slide7.xml><?xml version="1.0" encoding="utf-8"?>
+<p:sld xmlns:a="http://schemas.openxmlformats.org/drawingml/2006/main" xmlns:p="http://schemas.openxmlformats.org/presentationml/2006/main" xmlns:r="http://schemas.openxmlformats.org/officeDocument/2006/relationships">
+  <p:cSld>
+    <p:spTree>
+      <p:nvGrpSpPr>
+        <p:cNvPr id="1" name=""/>
+        <p:cNvGrpSpPr/>
+        <p:nvPr/>
+      </p:nvGrpSpPr>
+      <p:grpSpPr/>
+      <p:sp>
+        <p:nvSpPr>
+          <p:cNvPr id="2" name="TextBox 1"/>
+          <p:cNvSpPr txBox="1"/>
+          <p:nvPr/>
+        </p:nvSpPr>
+        <p:spPr>
+          <a:xfrm>
+            <a:off x="731520" y="365760"/>
+            <a:ext cx="10698480" cy="320040"/>
+          </a:xfrm>
+          <a:prstGeom prst="rect">
+            <a:avLst/>
+          </a:prstGeom>
+          <a:noFill/>
+        </p:spPr>
+        <p:txBody>
+          <a:bodyPr wrap="square">
+            <a:spAutoFit/>
+          </a:bodyPr>
+          <a:lstStyle/>
+          <a:p>
+            <a:pPr>
+              <a:defRPr sz="1100" b="1">
+                <a:solidFill>
+                  <a:srgbClr val="2563EB"/>
+                </a:solidFill>
+              </a:defRPr>
+            </a:pPr>
+            <a:r>
+              <a:t>CONCLUSION &amp; IMPACT</a:t>
+            </a:r>
+          </a:p>
+        </p:txBody>
+      </p:sp>
+      <p:sp>
+        <p:nvSpPr>
+          <p:cNvPr id="3" name="TextBox 2"/>
+          <p:cNvSpPr txBox="1"/>
+          <p:nvPr/>
+        </p:nvSpPr>
+        <p:spPr>
+          <a:xfrm>
+            <a:off x="731520" y="640080"/>
+            <a:ext cx="10698480" cy="594360"/>
+          </a:xfrm>
+          <a:prstGeom prst="rect">
+            <a:avLst/>
+          </a:prstGeom>
+          <a:noFill/>
+        </p:spPr>
+        <p:txBody>
+          <a:bodyPr wrap="square">
+            <a:spAutoFit/>
+          </a:bodyPr>
+          <a:lstStyle/>
+          <a:p>
+            <a:pPr>
+              <a:defRPr sz="2400" b="1">
+                <a:solidFill>
+                  <a:srgbClr val="0F172A"/>
+                </a:solidFill>
+              </a:defRPr>
+            </a:pPr>
+            <a:r>
+              <a:t>Project Results, Live Deployment &amp; Conclusion</a:t>
+            </a:r>
+          </a:p>
+        </p:txBody>
+      </p:sp>
+      <p:sp>
+        <p:nvSpPr>
+          <p:cNvPr id="4" name="Rounded Rectangle 3"/>
+          <p:cNvSpPr/>
+          <p:nvPr/>
+        </p:nvSpPr>
+        <p:spPr>
+          <a:xfrm>
+            <a:off x="731520" y="1463040"/>
+            <a:ext cx="5120640" cy="4663440"/>
+          </a:xfrm>
+          <a:prstGeom prst="roundRect">
+            <a:avLst/>
+          </a:prstGeom>
+          <a:solidFill>
+            <a:srgbClr val="FFFFFF"/>
+          </a:solidFill>
+          <a:ln w="19050">
+            <a:solidFill>
+              <a:srgbClr val="E2E8F0"/>
+            </a:solidFill>
+          </a:ln>
+        </p:spPr>
+        <p:style>
+          <a:lnRef idx="1">
+            <a:schemeClr val="accent1"/>
+          </a:lnRef>
+          <a:fillRef idx="3">
+            <a:schemeClr val="accent1"/>
+          </a:fillRef>
+          <a:effectRef idx="2">
+            <a:schemeClr val="accent1"/>
+          </a:effectRef>
+          <a:fontRef idx="minor">
+            <a:schemeClr val="lt1"/>
+          </a:fontRef>
+        </p:style>
+        <p:txBody>
+          <a:bodyPr rtlCol="0" anchor="ctr" wrap="square" lIns="274320" tIns="274320"/>
+          <a:lstStyle/>
+          <a:p>
+            <a:pPr algn="ctr">
+              <a:defRPr sz="1200" b="1">
+                <a:solidFill>
+                  <a:srgbClr val="2563EB"/>
+                </a:solidFill>
+              </a:defRPr>
+            </a:pPr>
+            <a:r>
+              <a:t>KEY DELIVERABLES &amp; OUTCOMES</a:t>
             </a:r>
           </a:p>
           <a:p>
@@ -5988,119 +5367,248 @@
               <a:spcBef>
                 <a:spcPts val="700"/>
               </a:spcBef>
-              <a:defRPr sz="1100" b="1">
-                <a:solidFill>
-                  <a:srgbClr val="0F172A"/>
-                </a:solidFill>
-              </a:defRPr>
-            </a:pPr>
-            <a:r>
-              <a:t>Cross-Disciplinary Rigor:</a:t>
-            </a:r>
-          </a:p>
-          <a:p>
-            <a:pPr>
-              <a:spcBef>
-                <a:spcPts val="200"/>
-              </a:spcBef>
-              <a:defRPr sz="1000">
+              <a:defRPr sz="1050">
+                <a:solidFill>
+                  <a:srgbClr val="0F172A"/>
+                </a:solidFill>
+              </a:defRPr>
+            </a:pPr>
+            <a:r>
+              <a:t>✔ Live Production Deployment: Successfully deployed and hosted globally on GitHub Pages at https://arjun2007arush2011-max.github.io/break_even_point/</a:t>
+            </a:r>
+          </a:p>
+          <a:p>
+            <a:pPr>
+              <a:spcBef>
+                <a:spcPts val="700"/>
+              </a:spcBef>
+              <a:defRPr sz="1050">
+                <a:solidFill>
+                  <a:srgbClr val="0F172A"/>
+                </a:solidFill>
+              </a:defRPr>
+            </a:pPr>
+            <a:r>
+              <a:t>✔ Zero Third-Party Dependencies: Operates entirely standalone in any browser with zero node_modules or CDN downloads.</a:t>
+            </a:r>
+          </a:p>
+          <a:p>
+            <a:pPr>
+              <a:spcBef>
+                <a:spcPts val="700"/>
+              </a:spcBef>
+              <a:defRPr sz="1050">
+                <a:solidFill>
+                  <a:srgbClr val="0F172A"/>
+                </a:solidFill>
+              </a:defRPr>
+            </a:pPr>
+            <a:r>
+              <a:t>✔ High Performance: Sub-millisecond mathematical recalculation with smooth 60fps SVG rendering.</a:t>
+            </a:r>
+          </a:p>
+          <a:p>
+            <a:pPr>
+              <a:spcBef>
+                <a:spcPts val="700"/>
+              </a:spcBef>
+              <a:defRPr sz="1050">
+                <a:solidFill>
+                  <a:srgbClr val="0F172A"/>
+                </a:solidFill>
+              </a:defRPr>
+            </a:pPr>
+            <a:r>
+              <a:t>✔ Clean Print Reports: Built-in @media print executive feasibility report for stakeholders and investors.</a:t>
+            </a:r>
+          </a:p>
+          <a:p>
+            <a:pPr>
+              <a:spcBef>
+                <a:spcPts val="700"/>
+              </a:spcBef>
+              <a:defRPr sz="1050">
+                <a:solidFill>
+                  <a:srgbClr val="0F172A"/>
+                </a:solidFill>
+              </a:defRPr>
+            </a:pPr>
+            <a:r>
+              <a:t>✔ Search-Engine Ready: Integrated with robots.txt, sitemap.xml, and OpenGraph metadata.</a:t>
+            </a:r>
+          </a:p>
+        </p:txBody>
+      </p:sp>
+      <p:sp>
+        <p:nvSpPr>
+          <p:cNvPr id="5" name="Rounded Rectangle 4"/>
+          <p:cNvSpPr/>
+          <p:nvPr/>
+        </p:nvSpPr>
+        <p:spPr>
+          <a:xfrm>
+            <a:off x="6309360" y="1463040"/>
+            <a:ext cx="5120640" cy="4663440"/>
+          </a:xfrm>
+          <a:prstGeom prst="roundRect">
+            <a:avLst/>
+          </a:prstGeom>
+          <a:solidFill>
+            <a:srgbClr val="FFFFFF"/>
+          </a:solidFill>
+          <a:ln w="19050">
+            <a:solidFill>
+              <a:srgbClr val="E2E8F0"/>
+            </a:solidFill>
+          </a:ln>
+        </p:spPr>
+        <p:style>
+          <a:lnRef idx="1">
+            <a:schemeClr val="accent1"/>
+          </a:lnRef>
+          <a:fillRef idx="3">
+            <a:schemeClr val="accent1"/>
+          </a:fillRef>
+          <a:effectRef idx="2">
+            <a:schemeClr val="accent1"/>
+          </a:effectRef>
+          <a:fontRef idx="minor">
+            <a:schemeClr val="lt1"/>
+          </a:fontRef>
+        </p:style>
+        <p:txBody>
+          <a:bodyPr rtlCol="0" anchor="ctr" wrap="square" lIns="274320" tIns="274320"/>
+          <a:lstStyle/>
+          <a:p>
+            <a:pPr algn="ctr">
+              <a:defRPr sz="1200" b="1">
+                <a:solidFill>
+                  <a:srgbClr val="059669"/>
+                </a:solidFill>
+              </a:defRPr>
+            </a:pPr>
+            <a:r>
+              <a:t>ACADEMIC IMPACT &amp; FUTURE SCOPE</a:t>
+            </a:r>
+          </a:p>
+          <a:p>
+            <a:pPr>
+              <a:spcBef>
+                <a:spcPts val="600"/>
+              </a:spcBef>
+              <a:defRPr sz="1050" b="1">
+                <a:solidFill>
+                  <a:srgbClr val="0F172A"/>
+                </a:solidFill>
+              </a:defRPr>
+            </a:pPr>
+            <a:r>
+              <a:t>Cross-Disciplinary Learning:</a:t>
+            </a:r>
+          </a:p>
+          <a:p>
+            <a:pPr>
+              <a:spcBef>
+                <a:spcPts val="100"/>
+              </a:spcBef>
+              <a:defRPr sz="950">
                 <a:solidFill>
                   <a:srgbClr val="64748B"/>
                 </a:solidFill>
               </a:defRPr>
             </a:pPr>
             <a:r>
-              <a:t>Integrates software engineering, managerial cost accounting, relational database design, and interactive computer graphics.</a:t>
-            </a:r>
-          </a:p>
-          <a:p>
-            <a:pPr>
-              <a:spcBef>
-                <a:spcPts val="700"/>
-              </a:spcBef>
-              <a:defRPr sz="1100" b="1">
-                <a:solidFill>
-                  <a:srgbClr val="0F172A"/>
-                </a:solidFill>
-              </a:defRPr>
-            </a:pPr>
-            <a:r>
-              <a:t>Multi-Product Sales Mix:</a:t>
-            </a:r>
-          </a:p>
-          <a:p>
-            <a:pPr>
-              <a:spcBef>
-                <a:spcPts val="200"/>
-              </a:spcBef>
-              <a:defRPr sz="1000">
+              <a:t>  Combines financial accounting, web engineering, database architecture, and computer graphics algorithms.</a:t>
+            </a:r>
+          </a:p>
+          <a:p>
+            <a:pPr>
+              <a:spcBef>
+                <a:spcPts val="600"/>
+              </a:spcBef>
+              <a:defRPr sz="1050" b="1">
+                <a:solidFill>
+                  <a:srgbClr val="0F172A"/>
+                </a:solidFill>
+              </a:defRPr>
+            </a:pPr>
+            <a:r>
+              <a:t>Multi-Product Inventory Mix:</a:t>
+            </a:r>
+          </a:p>
+          <a:p>
+            <a:pPr>
+              <a:spcBef>
+                <a:spcPts val="100"/>
+              </a:spcBef>
+              <a:defRPr sz="950">
                 <a:solidFill>
                   <a:srgbClr val="64748B"/>
                 </a:solidFill>
               </a:defRPr>
             </a:pPr>
             <a:r>
-              <a:t>Future expansion to compute weighted average contribution margin ratios for multi-product retail inventory.</a:t>
-            </a:r>
-          </a:p>
-          <a:p>
-            <a:pPr>
-              <a:spcBef>
-                <a:spcPts val="700"/>
-              </a:spcBef>
-              <a:defRPr sz="1100" b="1">
-                <a:solidFill>
-                  <a:srgbClr val="0F172A"/>
-                </a:solidFill>
-              </a:defRPr>
-            </a:pPr>
-            <a:r>
-              <a:t>Stochastic Monte Carlo Modeling:</a:t>
-            </a:r>
-          </a:p>
-          <a:p>
-            <a:pPr>
-              <a:spcBef>
-                <a:spcPts val="200"/>
-              </a:spcBef>
-              <a:defRPr sz="1000">
+              <a:t>  Future scope to support multi-item catalog weighting for complex retail operations.</a:t>
+            </a:r>
+          </a:p>
+          <a:p>
+            <a:pPr>
+              <a:spcBef>
+                <a:spcPts val="600"/>
+              </a:spcBef>
+              <a:defRPr sz="1050" b="1">
+                <a:solidFill>
+                  <a:srgbClr val="0F172A"/>
+                </a:solidFill>
+              </a:defRPr>
+            </a:pPr>
+            <a:r>
+              <a:t>Monte Carlo Stochastic Modeling:</a:t>
+            </a:r>
+          </a:p>
+          <a:p>
+            <a:pPr>
+              <a:spcBef>
+                <a:spcPts val="100"/>
+              </a:spcBef>
+              <a:defRPr sz="950">
                 <a:solidFill>
                   <a:srgbClr val="64748B"/>
                 </a:solidFill>
               </a:defRPr>
             </a:pPr>
             <a:r>
-              <a:t>Simulating random demand curves and price elasticity distributions for advanced risk assessment.</a:t>
-            </a:r>
-          </a:p>
-          <a:p>
-            <a:pPr>
-              <a:spcBef>
-                <a:spcPts val="700"/>
-              </a:spcBef>
-              <a:defRPr sz="1100" b="1">
-                <a:solidFill>
-                  <a:srgbClr val="0F172A"/>
-                </a:solidFill>
-              </a:defRPr>
-            </a:pPr>
-            <a:r>
-              <a:t>Automated PDF Financial Dossier:</a:t>
-            </a:r>
-          </a:p>
-          <a:p>
-            <a:pPr>
-              <a:spcBef>
-                <a:spcPts val="200"/>
-              </a:spcBef>
-              <a:defRPr sz="1000">
+              <a:t>  Adding probability distribution curves to model demand uncertainty.</a:t>
+            </a:r>
+          </a:p>
+          <a:p>
+            <a:pPr>
+              <a:spcBef>
+                <a:spcPts val="600"/>
+              </a:spcBef>
+              <a:defRPr sz="1050" b="1">
+                <a:solidFill>
+                  <a:srgbClr val="0F172A"/>
+                </a:solidFill>
+              </a:defRPr>
+            </a:pPr>
+            <a:r>
+              <a:t>Live Demonstration URL:</a:t>
+            </a:r>
+          </a:p>
+          <a:p>
+            <a:pPr>
+              <a:spcBef>
+                <a:spcPts val="100"/>
+              </a:spcBef>
+              <a:defRPr sz="950">
                 <a:solidFill>
                   <a:srgbClr val="64748B"/>
                 </a:solidFill>
               </a:defRPr>
             </a:pPr>
             <a:r>
-              <a:t>One-click export of formal executive investment pitches and PDF feasibility binders.</a:t>
+              <a:t>  https://arjun2007arush2011-max.github.io/break_even_point/</a:t>
             </a:r>
           </a:p>
         </p:txBody>

</xml_diff>

<commit_message>
Unify frontend and backend architecture into single slide in presentation deck
</commit_message>
<xml_diff>
--- a/Break-Even-Project-Presentation.pptx
+++ b/Break-Even-Project-Presentation.pptx
@@ -3736,7 +3736,7 @@
               </a:defRPr>
             </a:pPr>
             <a:r>
-              <a:t>FRONTEND TIER</a:t>
+              <a:t>SYSTEM ARCHITECTURE</a:t>
             </a:r>
           </a:p>
         </p:txBody>
@@ -3771,7 +3771,833 @@
               </a:defRPr>
             </a:pPr>
             <a:r>
-              <a:t>Frontend Architecture &amp; User Interface</a:t>
+              <a:t>Full-Stack System Architecture: Frontend &amp; Backend</a:t>
+            </a:r>
+          </a:p>
+        </p:txBody>
+      </p:sp>
+      <p:sp>
+        <p:nvSpPr>
+          <p:cNvPr id="4" name="Rounded Rectangle 3"/>
+          <p:cNvSpPr/>
+          <p:nvPr/>
+        </p:nvSpPr>
+        <p:spPr>
+          <a:xfrm>
+            <a:off x="731520" y="1371600"/>
+            <a:ext cx="5212080" cy="3611880"/>
+          </a:xfrm>
+          <a:prstGeom prst="roundRect">
+            <a:avLst/>
+          </a:prstGeom>
+          <a:solidFill>
+            <a:srgbClr val="FFFFFF"/>
+          </a:solidFill>
+          <a:ln w="19050">
+            <a:solidFill>
+              <a:srgbClr val="E2E8F0"/>
+            </a:solidFill>
+          </a:ln>
+        </p:spPr>
+        <p:style>
+          <a:lnRef idx="1">
+            <a:schemeClr val="accent1"/>
+          </a:lnRef>
+          <a:fillRef idx="3">
+            <a:schemeClr val="accent1"/>
+          </a:fillRef>
+          <a:effectRef idx="2">
+            <a:schemeClr val="accent1"/>
+          </a:effectRef>
+          <a:fontRef idx="minor">
+            <a:schemeClr val="lt1"/>
+          </a:fontRef>
+        </p:style>
+        <p:txBody>
+          <a:bodyPr rtlCol="0" anchor="ctr" wrap="square" lIns="228600" tIns="182880"/>
+          <a:lstStyle/>
+          <a:p>
+            <a:pPr algn="ctr">
+              <a:defRPr sz="1200" b="1">
+                <a:solidFill>
+                  <a:srgbClr val="2563EB"/>
+                </a:solidFill>
+              </a:defRPr>
+            </a:pPr>
+            <a:r>
+              <a:t>FRONTEND CLIENT TIER (Browser)</a:t>
+            </a:r>
+          </a:p>
+          <a:p>
+            <a:pPr>
+              <a:spcBef>
+                <a:spcPts val="300"/>
+              </a:spcBef>
+              <a:defRPr sz="950" b="1">
+                <a:solidFill>
+                  <a:srgbClr val="0F172A"/>
+                </a:solidFill>
+              </a:defRPr>
+            </a:pPr>
+            <a:r>
+              <a:t>• Vanilla ES5 Standards: </a:t>
+            </a:r>
+            <a:r>
+              <a:rPr b="0">
+                <a:solidFill>
+                  <a:srgbClr val="64748B"/>
+                </a:solidFill>
+              </a:rPr>
+              <a:t>Zero build pipelines, npm, or Babel. Operates natively in 100% of web browsers.</a:t>
+            </a:r>
+          </a:p>
+          <a:p>
+            <a:pPr>
+              <a:spcBef>
+                <a:spcPts val="300"/>
+              </a:spcBef>
+              <a:defRPr sz="950" b="1">
+                <a:solidFill>
+                  <a:srgbClr val="0F172A"/>
+                </a:solidFill>
+              </a:defRPr>
+            </a:pPr>
+            <a:r>
+              <a:t>• Responsive CSS Grid: </a:t>
+            </a:r>
+            <a:r>
+              <a:rPr b="0">
+                <a:solidFill>
+                  <a:srgbClr val="64748B"/>
+                </a:solidFill>
+              </a:rPr>
+              <a:t>Two-column analytical dashboard adapting smoothly to single-column mobile viewports.</a:t>
+            </a:r>
+          </a:p>
+          <a:p>
+            <a:pPr>
+              <a:spcBef>
+                <a:spcPts val="300"/>
+              </a:spcBef>
+              <a:defRPr sz="950" b="1">
+                <a:solidFill>
+                  <a:srgbClr val="0F172A"/>
+                </a:solidFill>
+              </a:defRPr>
+            </a:pPr>
+            <a:r>
+              <a:t>• Dark &amp; Light Mode Engine: </a:t>
+            </a:r>
+            <a:r>
+              <a:rPr b="0">
+                <a:solidFill>
+                  <a:srgbClr val="64748B"/>
+                </a:solidFill>
+              </a:rPr>
+              <a:t>CSS Custom Properties with persistent user theme saved in localStorage.</a:t>
+            </a:r>
+          </a:p>
+          <a:p>
+            <a:pPr>
+              <a:spcBef>
+                <a:spcPts val="300"/>
+              </a:spcBef>
+              <a:defRPr sz="950" b="1">
+                <a:solidFill>
+                  <a:srgbClr val="0F172A"/>
+                </a:solidFill>
+              </a:defRPr>
+            </a:pPr>
+            <a:r>
+              <a:t>• Client-Side Cryptography: </a:t>
+            </a:r>
+            <a:r>
+              <a:rPr b="0">
+                <a:solidFill>
+                  <a:srgbClr val="64748B"/>
+                </a:solidFill>
+              </a:rPr>
+              <a:t>Web Crypto API (crypto.subtle) SHA-256 password hashing with pure JS fallback.</a:t>
+            </a:r>
+          </a:p>
+          <a:p>
+            <a:pPr>
+              <a:spcBef>
+                <a:spcPts val="300"/>
+              </a:spcBef>
+              <a:defRPr sz="950" b="1">
+                <a:solidFill>
+                  <a:srgbClr val="0F172A"/>
+                </a:solidFill>
+              </a:defRPr>
+            </a:pPr>
+            <a:r>
+              <a:t>• Modular Namespaces: </a:t>
+            </a:r>
+            <a:r>
+              <a:rPr b="0">
+                <a:solidFill>
+                  <a:srgbClr val="64748B"/>
+                </a:solidFill>
+              </a:rPr>
+              <a:t>Separation of concerns: AuthModule, ProfileModule, MetricsModule, ChartModule, ApiClient.</a:t>
+            </a:r>
+          </a:p>
+        </p:txBody>
+      </p:sp>
+      <p:sp>
+        <p:nvSpPr>
+          <p:cNvPr id="5" name="Rounded Rectangle 4"/>
+          <p:cNvSpPr/>
+          <p:nvPr/>
+        </p:nvSpPr>
+        <p:spPr>
+          <a:xfrm>
+            <a:off x="6217920" y="1371600"/>
+            <a:ext cx="5212080" cy="3611880"/>
+          </a:xfrm>
+          <a:prstGeom prst="roundRect">
+            <a:avLst/>
+          </a:prstGeom>
+          <a:solidFill>
+            <a:srgbClr val="FFFFFF"/>
+          </a:solidFill>
+          <a:ln w="19050">
+            <a:solidFill>
+              <a:srgbClr val="E2E8F0"/>
+            </a:solidFill>
+          </a:ln>
+        </p:spPr>
+        <p:style>
+          <a:lnRef idx="1">
+            <a:schemeClr val="accent1"/>
+          </a:lnRef>
+          <a:fillRef idx="3">
+            <a:schemeClr val="accent1"/>
+          </a:fillRef>
+          <a:effectRef idx="2">
+            <a:schemeClr val="accent1"/>
+          </a:effectRef>
+          <a:fontRef idx="minor">
+            <a:schemeClr val="lt1"/>
+          </a:fontRef>
+        </p:style>
+        <p:txBody>
+          <a:bodyPr rtlCol="0" anchor="ctr" wrap="square" lIns="228600" tIns="182880"/>
+          <a:lstStyle/>
+          <a:p>
+            <a:pPr algn="ctr">
+              <a:defRPr sz="1200" b="1">
+                <a:solidFill>
+                  <a:srgbClr val="059669"/>
+                </a:solidFill>
+              </a:defRPr>
+            </a:pPr>
+            <a:r>
+              <a:t>BACKEND SERVER &amp; DATABASE TIER</a:t>
+            </a:r>
+          </a:p>
+          <a:p>
+            <a:pPr>
+              <a:spcBef>
+                <a:spcPts val="300"/>
+              </a:spcBef>
+              <a:defRPr sz="950" b="1">
+                <a:solidFill>
+                  <a:srgbClr val="0F172A"/>
+                </a:solidFill>
+              </a:defRPr>
+            </a:pPr>
+            <a:r>
+              <a:t>• Triple-Runtime Implementations: </a:t>
+            </a:r>
+            <a:r>
+              <a:rPr b="0">
+                <a:solidFill>
+                  <a:srgbClr val="64748B"/>
+                </a:solidFill>
+              </a:rPr>
+              <a:t>Native Python 3 (http.server), Ruby (WEBrick), and Node.js. Zero pip/npm dependencies.</a:t>
+            </a:r>
+          </a:p>
+          <a:p>
+            <a:pPr>
+              <a:spcBef>
+                <a:spcPts val="300"/>
+              </a:spcBef>
+              <a:defRPr sz="950" b="1">
+                <a:solidFill>
+                  <a:srgbClr val="0F172A"/>
+                </a:solidFill>
+              </a:defRPr>
+            </a:pPr>
+            <a:r>
+              <a:t>• Universal Launcher (start.sh): </a:t>
+            </a:r>
+            <a:r>
+              <a:rPr b="0">
+                <a:solidFill>
+                  <a:srgbClr val="64748B"/>
+                </a:solidFill>
+              </a:rPr>
+              <a:t>Intelligently auto-detects the host system's installed runtime and binds on port 8000.</a:t>
+            </a:r>
+          </a:p>
+          <a:p>
+            <a:pPr>
+              <a:spcBef>
+                <a:spcPts val="300"/>
+              </a:spcBef>
+              <a:defRPr sz="950" b="1">
+                <a:solidFill>
+                  <a:srgbClr val="0F172A"/>
+                </a:solidFill>
+              </a:defRPr>
+            </a:pPr>
+            <a:r>
+              <a:t>• Relational SQLite3 Database: </a:t>
+            </a:r>
+            <a:r>
+              <a:rPr b="0">
+                <a:solidFill>
+                  <a:srgbClr val="64748B"/>
+                </a:solidFill>
+              </a:rPr>
+              <a:t>Structured breakeven.db with normalized schemas for users, profiles, and inputs.</a:t>
+            </a:r>
+          </a:p>
+          <a:p>
+            <a:pPr>
+              <a:spcBef>
+                <a:spcPts val="300"/>
+              </a:spcBef>
+              <a:defRPr sz="950" b="1">
+                <a:solidFill>
+                  <a:srgbClr val="0F172A"/>
+                </a:solidFill>
+              </a:defRPr>
+            </a:pPr>
+            <a:r>
+              <a:t>• RESTful JSON API Contract: </a:t>
+            </a:r>
+            <a:r>
+              <a:rPr b="0">
+                <a:solidFill>
+                  <a:srgbClr val="64748B"/>
+                </a:solidFill>
+              </a:rPr>
+              <a:t>Endpoints for /api/auth/signup, /api/auth/login, /api/profile, /api/inputs, /api/calculate.</a:t>
+            </a:r>
+          </a:p>
+          <a:p>
+            <a:pPr>
+              <a:spcBef>
+                <a:spcPts val="300"/>
+              </a:spcBef>
+              <a:defRPr sz="950" b="1">
+                <a:solidFill>
+                  <a:srgbClr val="0F172A"/>
+                </a:solidFill>
+              </a:defRPr>
+            </a:pPr>
+            <a:r>
+              <a:t>• Server Mathematical Validation: </a:t>
+            </a:r>
+            <a:r>
+              <a:rPr b="0">
+                <a:solidFill>
+                  <a:srgbClr val="64748B"/>
+                </a:solidFill>
+              </a:rPr>
+              <a:t>Performs secondary verification of break-even formulas to enforce data integrity.</a:t>
+            </a:r>
+          </a:p>
+        </p:txBody>
+      </p:sp>
+      <p:sp>
+        <p:nvSpPr>
+          <p:cNvPr id="6" name="Rounded Rectangle 5"/>
+          <p:cNvSpPr/>
+          <p:nvPr/>
+        </p:nvSpPr>
+        <p:spPr>
+          <a:xfrm>
+            <a:off x="731520" y="5120640"/>
+            <a:ext cx="10698480" cy="1280160"/>
+          </a:xfrm>
+          <a:prstGeom prst="roundRect">
+            <a:avLst/>
+          </a:prstGeom>
+          <a:solidFill>
+            <a:srgbClr val="F8FAFC"/>
+          </a:solidFill>
+          <a:ln w="19050">
+            <a:solidFill>
+              <a:srgbClr val="7C3AED"/>
+            </a:solidFill>
+          </a:ln>
+        </p:spPr>
+        <p:style>
+          <a:lnRef idx="1">
+            <a:schemeClr val="accent1"/>
+          </a:lnRef>
+          <a:fillRef idx="3">
+            <a:schemeClr val="accent1"/>
+          </a:fillRef>
+          <a:effectRef idx="2">
+            <a:schemeClr val="accent1"/>
+          </a:effectRef>
+          <a:fontRef idx="minor">
+            <a:schemeClr val="lt1"/>
+          </a:fontRef>
+        </p:style>
+        <p:txBody>
+          <a:bodyPr rtlCol="0" anchor="ctr" wrap="square" lIns="274320" tIns="137160"/>
+          <a:lstStyle/>
+          <a:p>
+            <a:pPr algn="ctr">
+              <a:defRPr sz="1100" b="1">
+                <a:solidFill>
+                  <a:srgbClr val="7C3AED"/>
+                </a:solidFill>
+              </a:defRPr>
+            </a:pPr>
+            <a:r>
+              <a:t>REST API PROTOCOL &amp; RESILIENT DUAL-ENGINE SYNCHRONIZATION BRIDGE (Frontend ⟷ Backend)</a:t>
+            </a:r>
+          </a:p>
+          <a:p>
+            <a:pPr>
+              <a:spcBef>
+                <a:spcPts val="200"/>
+              </a:spcBef>
+              <a:defRPr sz="900">
+                <a:solidFill>
+                  <a:srgbClr val="0F172A"/>
+                </a:solidFill>
+              </a:defRPr>
+            </a:pPr>
+            <a:r>
+              <a:t>• Debounced REST Sync: Client debounces user input (300ms) and dispatches JSON payloads with Bearer auth headers (Authorization: Bearer &lt;token&gt;) to /api/inputs and /api/profile.</a:t>
+            </a:r>
+          </a:p>
+          <a:p>
+            <a:pPr>
+              <a:spcBef>
+                <a:spcPts val="200"/>
+              </a:spcBef>
+              <a:defRPr sz="900">
+                <a:solidFill>
+                  <a:srgbClr val="0F172A"/>
+                </a:solidFill>
+              </a:defRPr>
+            </a:pPr>
+            <a:r>
+              <a:t>• Resilient Dual Persistence: ApiClient probes /api/health. If server is active, data saves to SQLite3; if offline or hosted on GitHub Pages (file://), it gracefully falls back to localStorage with zero downtime.</a:t>
+            </a:r>
+          </a:p>
+        </p:txBody>
+      </p:sp>
+    </p:spTree>
+  </p:cSld>
+  <p:clrMapOvr>
+    <a:masterClrMapping/>
+  </p:clrMapOvr>
+</p:sld>
+</file>
+
+<file path=ppt/slides/slide4.xml><?xml version="1.0" encoding="utf-8"?>
+<p:sld xmlns:a="http://schemas.openxmlformats.org/drawingml/2006/main" xmlns:p="http://schemas.openxmlformats.org/presentationml/2006/main" xmlns:r="http://schemas.openxmlformats.org/officeDocument/2006/relationships">
+  <p:cSld>
+    <p:spTree>
+      <p:nvGrpSpPr>
+        <p:cNvPr id="1" name=""/>
+        <p:cNvGrpSpPr/>
+        <p:nvPr/>
+      </p:nvGrpSpPr>
+      <p:grpSpPr/>
+      <p:sp>
+        <p:nvSpPr>
+          <p:cNvPr id="2" name="TextBox 1"/>
+          <p:cNvSpPr txBox="1"/>
+          <p:nvPr/>
+        </p:nvSpPr>
+        <p:spPr>
+          <a:xfrm>
+            <a:off x="731520" y="365760"/>
+            <a:ext cx="10698480" cy="320040"/>
+          </a:xfrm>
+          <a:prstGeom prst="rect">
+            <a:avLst/>
+          </a:prstGeom>
+          <a:noFill/>
+        </p:spPr>
+        <p:txBody>
+          <a:bodyPr wrap="square">
+            <a:spAutoFit/>
+          </a:bodyPr>
+          <a:lstStyle/>
+          <a:p>
+            <a:pPr>
+              <a:defRPr sz="1100" b="1">
+                <a:solidFill>
+                  <a:srgbClr val="2563EB"/>
+                </a:solidFill>
+              </a:defRPr>
+            </a:pPr>
+            <a:r>
+              <a:t>VISUALIZATION ENGINE</a:t>
+            </a:r>
+          </a:p>
+        </p:txBody>
+      </p:sp>
+      <p:sp>
+        <p:nvSpPr>
+          <p:cNvPr id="3" name="TextBox 2"/>
+          <p:cNvSpPr txBox="1"/>
+          <p:nvPr/>
+        </p:nvSpPr>
+        <p:spPr>
+          <a:xfrm>
+            <a:off x="731520" y="640080"/>
+            <a:ext cx="10698480" cy="594360"/>
+          </a:xfrm>
+          <a:prstGeom prst="rect">
+            <a:avLst/>
+          </a:prstGeom>
+          <a:noFill/>
+        </p:spPr>
+        <p:txBody>
+          <a:bodyPr wrap="square">
+            <a:spAutoFit/>
+          </a:bodyPr>
+          <a:lstStyle/>
+          <a:p>
+            <a:pPr>
+              <a:defRPr sz="2400" b="1">
+                <a:solidFill>
+                  <a:srgbClr val="0F172A"/>
+                </a:solidFill>
+              </a:defRPr>
+            </a:pPr>
+            <a:r>
+              <a:t>Interactive SVG Chart &amp; Visualization Engine</a:t>
+            </a:r>
+          </a:p>
+        </p:txBody>
+      </p:sp>
+      <p:pic>
+        <p:nvPicPr>
+          <p:cNvPr id="4" name="Picture 3" descr="screenshot_chart.png"/>
+          <p:cNvPicPr>
+            <a:picLocks noChangeAspect="1"/>
+          </p:cNvPicPr>
+          <p:nvPr/>
+        </p:nvPicPr>
+        <p:blipFill>
+          <a:blip r:embed="rId2"/>
+          <a:stretch>
+            <a:fillRect/>
+          </a:stretch>
+        </p:blipFill>
+        <p:spPr>
+          <a:xfrm>
+            <a:off x="731520" y="1463040"/>
+            <a:ext cx="5486400" cy="4663440"/>
+          </a:xfrm>
+          <a:prstGeom prst="rect">
+            <a:avLst/>
+          </a:prstGeom>
+        </p:spPr>
+      </p:pic>
+      <p:sp>
+        <p:nvSpPr>
+          <p:cNvPr id="5" name="Rounded Rectangle 4"/>
+          <p:cNvSpPr/>
+          <p:nvPr/>
+        </p:nvSpPr>
+        <p:spPr>
+          <a:xfrm>
+            <a:off x="6492240" y="1463040"/>
+            <a:ext cx="4937760" cy="4663440"/>
+          </a:xfrm>
+          <a:prstGeom prst="roundRect">
+            <a:avLst/>
+          </a:prstGeom>
+          <a:solidFill>
+            <a:srgbClr val="FFFFFF"/>
+          </a:solidFill>
+          <a:ln w="19050">
+            <a:solidFill>
+              <a:srgbClr val="E2E8F0"/>
+            </a:solidFill>
+          </a:ln>
+        </p:spPr>
+        <p:style>
+          <a:lnRef idx="1">
+            <a:schemeClr val="accent1"/>
+          </a:lnRef>
+          <a:fillRef idx="3">
+            <a:schemeClr val="accent1"/>
+          </a:fillRef>
+          <a:effectRef idx="2">
+            <a:schemeClr val="accent1"/>
+          </a:effectRef>
+          <a:fontRef idx="minor">
+            <a:schemeClr val="lt1"/>
+          </a:fontRef>
+        </p:style>
+        <p:txBody>
+          <a:bodyPr rtlCol="0" anchor="ctr" wrap="square" lIns="274320" tIns="274320"/>
+          <a:lstStyle/>
+          <a:p>
+            <a:pPr algn="ctr">
+              <a:defRPr sz="1200" b="1">
+                <a:solidFill>
+                  <a:srgbClr val="7C3AED"/>
+                </a:solidFill>
+              </a:defRPr>
+            </a:pPr>
+            <a:r>
+              <a:t>CUSTOM COORDINATE MAPPING ENGINE</a:t>
+            </a:r>
+          </a:p>
+          <a:p>
+            <a:pPr>
+              <a:spcBef>
+                <a:spcPts val="500"/>
+              </a:spcBef>
+              <a:defRPr sz="1050" b="1">
+                <a:solidFill>
+                  <a:srgbClr val="0F172A"/>
+                </a:solidFill>
+              </a:defRPr>
+            </a:pPr>
+            <a:r>
+              <a:t>• No Third-Party Charting Libraries:</a:t>
+            </a:r>
+          </a:p>
+          <a:p>
+            <a:pPr>
+              <a:spcBef>
+                <a:spcPts val="100"/>
+              </a:spcBef>
+              <a:defRPr sz="950">
+                <a:solidFill>
+                  <a:srgbClr val="64748B"/>
+                </a:solidFill>
+              </a:defRPr>
+            </a:pPr>
+            <a:r>
+              <a:t>  All graphics generated dynamically via native inline SVG elements, avoiding heavy dependencies like Chart.js or D3.</a:t>
+            </a:r>
+          </a:p>
+          <a:p>
+            <a:pPr>
+              <a:spcBef>
+                <a:spcPts val="500"/>
+              </a:spcBef>
+              <a:defRPr sz="1050" b="1">
+                <a:solidFill>
+                  <a:srgbClr val="0F172A"/>
+                </a:solidFill>
+              </a:defRPr>
+            </a:pPr>
+            <a:r>
+              <a:t>• Dynamic Coordinate Projection:</a:t>
+            </a:r>
+          </a:p>
+          <a:p>
+            <a:pPr>
+              <a:spcBef>
+                <a:spcPts val="100"/>
+              </a:spcBef>
+              <a:defRPr sz="950">
+                <a:solidFill>
+                  <a:srgbClr val="64748B"/>
+                </a:solidFill>
+              </a:defRPr>
+            </a:pPr>
+            <a:r>
+              <a:t>  Translates financial values into SVG viewBox space using getX(q) and getY(val) with dynamic domain bounds.</a:t>
+            </a:r>
+          </a:p>
+          <a:p>
+            <a:pPr>
+              <a:spcBef>
+                <a:spcPts val="500"/>
+              </a:spcBef>
+              <a:defRPr sz="1050" b="1">
+                <a:solidFill>
+                  <a:srgbClr val="0F172A"/>
+                </a:solidFill>
+              </a:defRPr>
+            </a:pPr>
+            <a:r>
+              <a:t>• Visual Profit &amp; Loss Polygons:</a:t>
+            </a:r>
+          </a:p>
+          <a:p>
+            <a:pPr>
+              <a:spcBef>
+                <a:spcPts val="100"/>
+              </a:spcBef>
+              <a:defRPr sz="950">
+                <a:solidFill>
+                  <a:srgbClr val="64748B"/>
+                </a:solidFill>
+              </a:defRPr>
+            </a:pPr>
+            <a:r>
+              <a:t>  Shades the operating loss zone in red (0 to Break-Even) and profit zone in green (Break-Even to Max Volume).</a:t>
+            </a:r>
+          </a:p>
+          <a:p>
+            <a:pPr>
+              <a:spcBef>
+                <a:spcPts val="500"/>
+              </a:spcBef>
+              <a:defRPr sz="1050" b="1">
+                <a:solidFill>
+                  <a:srgbClr val="0F172A"/>
+                </a:solidFill>
+              </a:defRPr>
+            </a:pPr>
+            <a:r>
+              <a:t>• Break-Even Callout Point:</a:t>
+            </a:r>
+          </a:p>
+          <a:p>
+            <a:pPr>
+              <a:spcBef>
+                <a:spcPts val="100"/>
+              </a:spcBef>
+              <a:defRPr sz="950">
+                <a:solidFill>
+                  <a:srgbClr val="64748B"/>
+                </a:solidFill>
+              </a:defRPr>
+            </a:pPr>
+            <a:r>
+              <a:t>  Highlights the exact intersection point of Total Revenue and Total Cost with a pulsing halo and coordinate badge.</a:t>
+            </a:r>
+          </a:p>
+          <a:p>
+            <a:pPr>
+              <a:spcBef>
+                <a:spcPts val="500"/>
+              </a:spcBef>
+              <a:defRPr sz="1050" b="1">
+                <a:solidFill>
+                  <a:srgbClr val="0F172A"/>
+                </a:solidFill>
+              </a:defRPr>
+            </a:pPr>
+            <a:r>
+              <a:t>• Interactive Crosshair &amp; Tooltip:</a:t>
+            </a:r>
+          </a:p>
+          <a:p>
+            <a:pPr>
+              <a:spcBef>
+                <a:spcPts val="100"/>
+              </a:spcBef>
+              <a:defRPr sz="950">
+                <a:solidFill>
+                  <a:srgbClr val="64748B"/>
+                </a:solidFill>
+              </a:defRPr>
+            </a:pPr>
+            <a:r>
+              <a:t>  Hover/touch tracking computes volume, revenue, costs, and profit with 60fps responsiveness.</a:t>
+            </a:r>
+          </a:p>
+        </p:txBody>
+      </p:sp>
+    </p:spTree>
+  </p:cSld>
+  <p:clrMapOvr>
+    <a:masterClrMapping/>
+  </p:clrMapOvr>
+</p:sld>
+</file>
+
+<file path=ppt/slides/slide5.xml><?xml version="1.0" encoding="utf-8"?>
+<p:sld xmlns:a="http://schemas.openxmlformats.org/drawingml/2006/main" xmlns:p="http://schemas.openxmlformats.org/presentationml/2006/main" xmlns:r="http://schemas.openxmlformats.org/officeDocument/2006/relationships">
+  <p:cSld>
+    <p:spTree>
+      <p:nvGrpSpPr>
+        <p:cNvPr id="1" name=""/>
+        <p:cNvGrpSpPr/>
+        <p:nvPr/>
+      </p:nvGrpSpPr>
+      <p:grpSpPr/>
+      <p:sp>
+        <p:nvSpPr>
+          <p:cNvPr id="2" name="TextBox 1"/>
+          <p:cNvSpPr txBox="1"/>
+          <p:nvPr/>
+        </p:nvSpPr>
+        <p:spPr>
+          <a:xfrm>
+            <a:off x="731520" y="365760"/>
+            <a:ext cx="10698480" cy="320040"/>
+          </a:xfrm>
+          <a:prstGeom prst="rect">
+            <a:avLst/>
+          </a:prstGeom>
+          <a:noFill/>
+        </p:spPr>
+        <p:txBody>
+          <a:bodyPr wrap="square">
+            <a:spAutoFit/>
+          </a:bodyPr>
+          <a:lstStyle/>
+          <a:p>
+            <a:pPr>
+              <a:defRPr sz="1100" b="1">
+                <a:solidFill>
+                  <a:srgbClr val="2563EB"/>
+                </a:solidFill>
+              </a:defRPr>
+            </a:pPr>
+            <a:r>
+              <a:t>FINANCIAL MODEL &amp; ALGORITHMS</a:t>
+            </a:r>
+          </a:p>
+        </p:txBody>
+      </p:sp>
+      <p:sp>
+        <p:nvSpPr>
+          <p:cNvPr id="3" name="TextBox 2"/>
+          <p:cNvSpPr txBox="1"/>
+          <p:nvPr/>
+        </p:nvSpPr>
+        <p:spPr>
+          <a:xfrm>
+            <a:off x="731520" y="640080"/>
+            <a:ext cx="10698480" cy="594360"/>
+          </a:xfrm>
+          <a:prstGeom prst="rect">
+            <a:avLst/>
+          </a:prstGeom>
+          <a:noFill/>
+        </p:spPr>
+        <p:txBody>
+          <a:bodyPr wrap="square">
+            <a:spAutoFit/>
+          </a:bodyPr>
+          <a:lstStyle/>
+          <a:p>
+            <a:pPr>
+              <a:defRPr sz="2400" b="1">
+                <a:solidFill>
+                  <a:srgbClr val="0F172A"/>
+                </a:solidFill>
+              </a:defRPr>
+            </a:pPr>
+            <a:r>
+              <a:t>Mathematical Formulation &amp; Core Financial Algorithms</a:t>
             </a:r>
           </a:p>
         </p:txBody>
@@ -3825,307 +4651,141 @@
               </a:defRPr>
             </a:pPr>
             <a:r>
-              <a:t>FRONTEND DESIGN &amp; USER EXPERIENCE</a:t>
-            </a:r>
-          </a:p>
-          <a:p>
-            <a:pPr>
-              <a:spcBef>
-                <a:spcPts val="600"/>
-              </a:spcBef>
-              <a:defRPr sz="1050" b="1">
-                <a:solidFill>
-                  <a:srgbClr val="0F172A"/>
-                </a:solidFill>
-              </a:defRPr>
-            </a:pPr>
-            <a:r>
-              <a:t>Vanilla ES5 Architecture:</a:t>
-            </a:r>
-          </a:p>
-          <a:p>
-            <a:pPr>
-              <a:spcBef>
-                <a:spcPts val="100"/>
+              <a:t>CORE BREAK-EVEN EQUATIONS</a:t>
+            </a:r>
+          </a:p>
+          <a:p>
+            <a:pPr>
+              <a:spcBef>
+                <a:spcPts val="400"/>
               </a:spcBef>
               <a:defRPr sz="950">
                 <a:solidFill>
-                  <a:srgbClr val="64748B"/>
-                </a:solidFill>
-              </a:defRPr>
-            </a:pPr>
-            <a:r>
-              <a:t>  Strict ES5 standards ensuring 100% universal browser compatibility without Babel or bundling overhead.</a:t>
-            </a:r>
-          </a:p>
-          <a:p>
-            <a:pPr>
-              <a:spcBef>
-                <a:spcPts val="600"/>
-              </a:spcBef>
-              <a:defRPr sz="1050" b="1">
-                <a:solidFill>
-                  <a:srgbClr val="0F172A"/>
-                </a:solidFill>
-              </a:defRPr>
-            </a:pPr>
-            <a:r>
-              <a:t>Responsive Two-Column Layout:</a:t>
-            </a:r>
-          </a:p>
-          <a:p>
-            <a:pPr>
-              <a:spcBef>
-                <a:spcPts val="100"/>
+                  <a:srgbClr val="0F172A"/>
+                </a:solidFill>
+              </a:defRPr>
+            </a:pPr>
+            <a:r>
+              <a:t>Contribution Margin (CM): CM = Selling Price (P) - Variable Cost (V)</a:t>
+            </a:r>
+          </a:p>
+          <a:p>
+            <a:pPr>
+              <a:spcBef>
+                <a:spcPts val="400"/>
               </a:spcBef>
               <a:defRPr sz="950">
                 <a:solidFill>
-                  <a:srgbClr val="64748B"/>
-                </a:solidFill>
-              </a:defRPr>
-            </a:pPr>
-            <a:r>
-              <a:t>  Adapts automatically from a two-column desktop grid to an optimized single-column mobile view.</a:t>
-            </a:r>
-          </a:p>
-          <a:p>
-            <a:pPr>
-              <a:spcBef>
-                <a:spcPts val="600"/>
-              </a:spcBef>
-              <a:defRPr sz="1050" b="1">
-                <a:solidFill>
-                  <a:srgbClr val="0F172A"/>
-                </a:solidFill>
-              </a:defRPr>
-            </a:pPr>
-            <a:r>
-              <a:t>Dark &amp; Light Mode:</a:t>
-            </a:r>
-          </a:p>
-          <a:p>
-            <a:pPr>
-              <a:spcBef>
-                <a:spcPts val="100"/>
+                  <a:srgbClr val="0F172A"/>
+                </a:solidFill>
+              </a:defRPr>
+            </a:pPr>
+            <a:r>
+              <a:t>Contribution Margin Ratio: CM% = (P - V) / P</a:t>
+            </a:r>
+          </a:p>
+          <a:p>
+            <a:pPr>
+              <a:spcBef>
+                <a:spcPts val="400"/>
               </a:spcBef>
               <a:defRPr sz="950">
                 <a:solidFill>
-                  <a:srgbClr val="64748B"/>
-                </a:solidFill>
-              </a:defRPr>
-            </a:pPr>
-            <a:r>
-              <a:t>  Managed via CSS custom properties with persistent preference saved in localStorage.</a:t>
-            </a:r>
-          </a:p>
-          <a:p>
-            <a:pPr>
-              <a:spcBef>
-                <a:spcPts val="600"/>
-              </a:spcBef>
-              <a:defRPr sz="1050" b="1">
-                <a:solidFill>
-                  <a:srgbClr val="0F172A"/>
-                </a:solidFill>
-              </a:defRPr>
-            </a:pPr>
-            <a:r>
-              <a:t>Client-Side SHA-256 Hashing:</a:t>
-            </a:r>
-          </a:p>
-          <a:p>
-            <a:pPr>
-              <a:spcBef>
-                <a:spcPts val="100"/>
+                  <a:srgbClr val="0F172A"/>
+                </a:solidFill>
+              </a:defRPr>
+            </a:pPr>
+            <a:r>
+              <a:t>Break-Even Volume (Units): Q_BE = Fixed Costs (F) / (P - V)</a:t>
+            </a:r>
+          </a:p>
+          <a:p>
+            <a:pPr>
+              <a:spcBef>
+                <a:spcPts val="400"/>
               </a:spcBef>
               <a:defRPr sz="950">
                 <a:solidFill>
-                  <a:srgbClr val="64748B"/>
-                </a:solidFill>
-              </a:defRPr>
-            </a:pPr>
-            <a:r>
-              <a:t>  Passwords hashed via browser Web Crypto API (crypto.subtle) before storage with pure JS fallback.</a:t>
-            </a:r>
-          </a:p>
-          <a:p>
-            <a:pPr>
-              <a:spcBef>
-                <a:spcPts val="600"/>
-              </a:spcBef>
-              <a:defRPr sz="1050" b="1">
-                <a:solidFill>
-                  <a:srgbClr val="0F172A"/>
-                </a:solidFill>
-              </a:defRPr>
-            </a:pPr>
-            <a:r>
-              <a:t>Modular Namespaces:</a:t>
-            </a:r>
-          </a:p>
-          <a:p>
-            <a:pPr>
-              <a:spcBef>
-                <a:spcPts val="100"/>
+                  <a:srgbClr val="0F172A"/>
+                </a:solidFill>
+              </a:defRPr>
+            </a:pPr>
+            <a:r>
+              <a:t>Break-Even Sales Revenue: R_BE = Q_BE × P = F / CM%</a:t>
+            </a:r>
+          </a:p>
+          <a:p>
+            <a:pPr>
+              <a:spcBef>
+                <a:spcPts val="400"/>
               </a:spcBef>
               <a:defRPr sz="950">
                 <a:solidFill>
-                  <a:srgbClr val="64748B"/>
-                </a:solidFill>
-              </a:defRPr>
-            </a:pPr>
-            <a:r>
-              <a:t>  Clear separation of concerns across AuthModule, ProfileModule, MetricsModule, ChartModule, and ApiClient.</a:t>
-            </a:r>
-          </a:p>
-        </p:txBody>
-      </p:sp>
-      <p:pic>
-        <p:nvPicPr>
-          <p:cNvPr id="5" name="Picture 4" descr="screenshot_login.png"/>
-          <p:cNvPicPr>
-            <a:picLocks noChangeAspect="1"/>
-          </p:cNvPicPr>
+                  <a:srgbClr val="0F172A"/>
+                </a:solidFill>
+              </a:defRPr>
+            </a:pPr>
+            <a:r>
+              <a:t>Net Operating Profit: Profit = Q × (P - V) - F</a:t>
+            </a:r>
+          </a:p>
+          <a:p>
+            <a:pPr>
+              <a:spcBef>
+                <a:spcPts val="400"/>
+              </a:spcBef>
+              <a:defRPr sz="950">
+                <a:solidFill>
+                  <a:srgbClr val="0F172A"/>
+                </a:solidFill>
+              </a:defRPr>
+            </a:pPr>
+            <a:r>
+              <a:t>Margin of Safety (MOS): MOS = (Q - Q_BE) / Q × 100%</a:t>
+            </a:r>
+          </a:p>
+          <a:p>
+            <a:pPr>
+              <a:spcBef>
+                <a:spcPts val="400"/>
+              </a:spcBef>
+              <a:defRPr sz="950">
+                <a:solidFill>
+                  <a:srgbClr val="0F172A"/>
+                </a:solidFill>
+              </a:defRPr>
+            </a:pPr>
+            <a:r>
+              <a:t>Degree of Operating Leverage: DOL = (Q × CM) / Profit</a:t>
+            </a:r>
+          </a:p>
+          <a:p>
+            <a:pPr>
+              <a:spcBef>
+                <a:spcPts val="400"/>
+              </a:spcBef>
+              <a:defRPr sz="950">
+                <a:solidFill>
+                  <a:srgbClr val="0F172A"/>
+                </a:solidFill>
+              </a:defRPr>
+            </a:pPr>
+            <a:r>
+              <a:t>Target Profit Units: Q_Target = (F + Target) / CM</a:t>
+            </a:r>
+          </a:p>
+        </p:txBody>
+      </p:sp>
+      <p:sp>
+        <p:nvSpPr>
+          <p:cNvPr id="5" name="Rounded Rectangle 4"/>
+          <p:cNvSpPr/>
           <p:nvPr/>
-        </p:nvPicPr>
-        <p:blipFill>
-          <a:blip r:embed="rId2"/>
-          <a:stretch>
-            <a:fillRect/>
-          </a:stretch>
-        </p:blipFill>
+        </p:nvSpPr>
         <p:spPr>
           <a:xfrm>
             <a:off x="6309360" y="1463040"/>
             <a:ext cx="5120640" cy="4663440"/>
-          </a:xfrm>
-          <a:prstGeom prst="rect">
-            <a:avLst/>
-          </a:prstGeom>
-        </p:spPr>
-      </p:pic>
-    </p:spTree>
-  </p:cSld>
-  <p:clrMapOvr>
-    <a:masterClrMapping/>
-  </p:clrMapOvr>
-</p:sld>
-</file>
-
-<file path=ppt/slides/slide4.xml><?xml version="1.0" encoding="utf-8"?>
-<p:sld xmlns:a="http://schemas.openxmlformats.org/drawingml/2006/main" xmlns:p="http://schemas.openxmlformats.org/presentationml/2006/main" xmlns:r="http://schemas.openxmlformats.org/officeDocument/2006/relationships">
-  <p:cSld>
-    <p:spTree>
-      <p:nvGrpSpPr>
-        <p:cNvPr id="1" name=""/>
-        <p:cNvGrpSpPr/>
-        <p:nvPr/>
-      </p:nvGrpSpPr>
-      <p:grpSpPr/>
-      <p:sp>
-        <p:nvSpPr>
-          <p:cNvPr id="2" name="TextBox 1"/>
-          <p:cNvSpPr txBox="1"/>
-          <p:nvPr/>
-        </p:nvSpPr>
-        <p:spPr>
-          <a:xfrm>
-            <a:off x="731520" y="365760"/>
-            <a:ext cx="10698480" cy="320040"/>
-          </a:xfrm>
-          <a:prstGeom prst="rect">
-            <a:avLst/>
-          </a:prstGeom>
-          <a:noFill/>
-        </p:spPr>
-        <p:txBody>
-          <a:bodyPr wrap="square">
-            <a:spAutoFit/>
-          </a:bodyPr>
-          <a:lstStyle/>
-          <a:p>
-            <a:pPr>
-              <a:defRPr sz="1100" b="1">
-                <a:solidFill>
-                  <a:srgbClr val="2563EB"/>
-                </a:solidFill>
-              </a:defRPr>
-            </a:pPr>
-            <a:r>
-              <a:t>VISUALIZATION ENGINE</a:t>
-            </a:r>
-          </a:p>
-        </p:txBody>
-      </p:sp>
-      <p:sp>
-        <p:nvSpPr>
-          <p:cNvPr id="3" name="TextBox 2"/>
-          <p:cNvSpPr txBox="1"/>
-          <p:nvPr/>
-        </p:nvSpPr>
-        <p:spPr>
-          <a:xfrm>
-            <a:off x="731520" y="640080"/>
-            <a:ext cx="10698480" cy="594360"/>
-          </a:xfrm>
-          <a:prstGeom prst="rect">
-            <a:avLst/>
-          </a:prstGeom>
-          <a:noFill/>
-        </p:spPr>
-        <p:txBody>
-          <a:bodyPr wrap="square">
-            <a:spAutoFit/>
-          </a:bodyPr>
-          <a:lstStyle/>
-          <a:p>
-            <a:pPr>
-              <a:defRPr sz="2400" b="1">
-                <a:solidFill>
-                  <a:srgbClr val="0F172A"/>
-                </a:solidFill>
-              </a:defRPr>
-            </a:pPr>
-            <a:r>
-              <a:t>Interactive SVG Chart &amp; Visualization Engine</a:t>
-            </a:r>
-          </a:p>
-        </p:txBody>
-      </p:sp>
-      <p:pic>
-        <p:nvPicPr>
-          <p:cNvPr id="4" name="Picture 3" descr="screenshot_chart.png"/>
-          <p:cNvPicPr>
-            <a:picLocks noChangeAspect="1"/>
-          </p:cNvPicPr>
-          <p:nvPr/>
-        </p:nvPicPr>
-        <p:blipFill>
-          <a:blip r:embed="rId2"/>
-          <a:stretch>
-            <a:fillRect/>
-          </a:stretch>
-        </p:blipFill>
-        <p:spPr>
-          <a:xfrm>
-            <a:off x="731520" y="1463040"/>
-            <a:ext cx="5486400" cy="4663440"/>
-          </a:xfrm>
-          <a:prstGeom prst="rect">
-            <a:avLst/>
-          </a:prstGeom>
-        </p:spPr>
-      </p:pic>
-      <p:sp>
-        <p:nvSpPr>
-          <p:cNvPr id="5" name="Rounded Rectangle 4"/>
-          <p:cNvSpPr/>
-          <p:nvPr/>
-        </p:nvSpPr>
-        <p:spPr>
-          <a:xfrm>
-            <a:off x="6492240" y="1463040"/>
-            <a:ext cx="4937760" cy="4663440"/>
           </a:xfrm>
           <a:prstGeom prst="roundRect">
             <a:avLst/>
@@ -4160,18 +4820,18 @@
             <a:pPr algn="ctr">
               <a:defRPr sz="1200" b="1">
                 <a:solidFill>
-                  <a:srgbClr val="7C3AED"/>
-                </a:solidFill>
-              </a:defRPr>
-            </a:pPr>
-            <a:r>
-              <a:t>CUSTOM COORDINATE MAPPING ENGINE</a:t>
-            </a:r>
-          </a:p>
-          <a:p>
-            <a:pPr>
-              <a:spcBef>
-                <a:spcPts val="500"/>
+                  <a:srgbClr val="059669"/>
+                </a:solidFill>
+              </a:defRPr>
+            </a:pPr>
+            <a:r>
+              <a:t>ALGORITHMIC GUARDS &amp; INTEGRITY CHECKS</a:t>
+            </a:r>
+          </a:p>
+          <a:p>
+            <a:pPr>
+              <a:spcBef>
+                <a:spcPts val="600"/>
               </a:spcBef>
               <a:defRPr sz="1050" b="1">
                 <a:solidFill>
@@ -4180,7 +4840,7 @@
               </a:defRPr>
             </a:pPr>
             <a:r>
-              <a:t>• No Third-Party Charting Libraries:</a:t>
+              <a:t>✔ Structural Loss Detection (P ≤ V):</a:t>
             </a:r>
           </a:p>
           <a:p>
@@ -4195,13 +4855,13 @@
               </a:defRPr>
             </a:pPr>
             <a:r>
-              <a:t>  All graphics generated dynamically via native inline SVG elements, avoiding heavy dependencies like Chart.js or D3.</a:t>
-            </a:r>
-          </a:p>
-          <a:p>
-            <a:pPr>
-              <a:spcBef>
-                <a:spcPts val="500"/>
+              <a:t>  Instantly flags when price does not exceed variable costs. Prevents division-by-zero exceptions and alerts that every unit sold widens net deficit.</a:t>
+            </a:r>
+          </a:p>
+          <a:p>
+            <a:pPr>
+              <a:spcBef>
+                <a:spcPts val="600"/>
               </a:spcBef>
               <a:defRPr sz="1050" b="1">
                 <a:solidFill>
@@ -4210,7 +4870,7 @@
               </a:defRPr>
             </a:pPr>
             <a:r>
-              <a:t>• Dynamic Coordinate Projection:</a:t>
+              <a:t>✔ Sub-Break-Even Operating Alert:</a:t>
             </a:r>
           </a:p>
           <a:p>
@@ -4225,13 +4885,13 @@
               </a:defRPr>
             </a:pPr>
             <a:r>
-              <a:t>  Translates financial values into SVG viewBox space using getX(q) and getY(val) with dynamic domain bounds.</a:t>
-            </a:r>
-          </a:p>
-          <a:p>
-            <a:pPr>
-              <a:spcBef>
-                <a:spcPts val="500"/>
+              <a:t>  Dynamically signals danger when planned sales volume Q &lt; Q_BE, detailing the precise unit deficit required to achieve solvency.</a:t>
+            </a:r>
+          </a:p>
+          <a:p>
+            <a:pPr>
+              <a:spcBef>
+                <a:spcPts val="600"/>
               </a:spcBef>
               <a:defRPr sz="1050" b="1">
                 <a:solidFill>
@@ -4240,7 +4900,7 @@
               </a:defRPr>
             </a:pPr>
             <a:r>
-              <a:t>• Visual Profit &amp; Loss Polygons:</a:t>
+              <a:t>✔ Precision Floating-Point Normalization:</a:t>
             </a:r>
           </a:p>
           <a:p>
@@ -4255,13 +4915,13 @@
               </a:defRPr>
             </a:pPr>
             <a:r>
-              <a:t>  Shades the operating loss zone in red (0 to Break-Even) and profit zone in green (Break-Even to Max Volume).</a:t>
-            </a:r>
-          </a:p>
-          <a:p>
-            <a:pPr>
-              <a:spcBef>
-                <a:spcPts val="500"/>
+              <a:t>  Sanitizes user currency entries and eliminates IEEE 754 floating-point inaccuracies through explicit rounding rules.</a:t>
+            </a:r>
+          </a:p>
+          <a:p>
+            <a:pPr>
+              <a:spcBef>
+                <a:spcPts val="600"/>
               </a:spcBef>
               <a:defRPr sz="1050" b="1">
                 <a:solidFill>
@@ -4270,7 +4930,7 @@
               </a:defRPr>
             </a:pPr>
             <a:r>
-              <a:t>• Break-Even Callout Point:</a:t>
+              <a:t>✔ Client-Server Calculation Parity:</a:t>
             </a:r>
           </a:p>
           <a:p>
@@ -4285,37 +4945,7 @@
               </a:defRPr>
             </a:pPr>
             <a:r>
-              <a:t>  Highlights the exact intersection point of Total Revenue and Total Cost with a pulsing halo and coordinate badge.</a:t>
-            </a:r>
-          </a:p>
-          <a:p>
-            <a:pPr>
-              <a:spcBef>
-                <a:spcPts val="500"/>
-              </a:spcBef>
-              <a:defRPr sz="1050" b="1">
-                <a:solidFill>
-                  <a:srgbClr val="0F172A"/>
-                </a:solidFill>
-              </a:defRPr>
-            </a:pPr>
-            <a:r>
-              <a:t>• Interactive Crosshair &amp; Tooltip:</a:t>
-            </a:r>
-          </a:p>
-          <a:p>
-            <a:pPr>
-              <a:spcBef>
-                <a:spcPts val="100"/>
-              </a:spcBef>
-              <a:defRPr sz="950">
-                <a:solidFill>
-                  <a:srgbClr val="64748B"/>
-                </a:solidFill>
-              </a:defRPr>
-            </a:pPr>
-            <a:r>
-              <a:t>  Hover/touch tracking computes volume, revenue, costs, and profit with 60fps responsiveness.</a:t>
+              <a:t>  Validates client results against backend /api/calculate endpoints to guarantee consistent cross-platform mathematical output.</a:t>
             </a:r>
           </a:p>
         </p:txBody>
@@ -4328,7 +4958,7 @@
 </p:sld>
 </file>
 
-<file path=ppt/slides/slide5.xml><?xml version="1.0" encoding="utf-8"?>
+<file path=ppt/slides/slide6.xml><?xml version="1.0" encoding="utf-8"?>
 <p:sld xmlns:a="http://schemas.openxmlformats.org/drawingml/2006/main" xmlns:p="http://schemas.openxmlformats.org/presentationml/2006/main" xmlns:r="http://schemas.openxmlformats.org/officeDocument/2006/relationships">
   <p:cSld>
     <p:spTree>
@@ -4368,7 +4998,7 @@
               </a:defRPr>
             </a:pPr>
             <a:r>
-              <a:t>BACKEND &amp; DATABASE</a:t>
+              <a:t>SIMULATION &amp; SENSITIVITY</a:t>
             </a:r>
           </a:p>
         </p:txBody>
@@ -4403,7 +5033,7 @@
               </a:defRPr>
             </a:pPr>
             <a:r>
-              <a:t>Backend Architecture, REST APIs &amp; SQLite3</a:t>
+              <a:t>What-If Sensitivity Simulations &amp; Scenario Planning</a:t>
             </a:r>
           </a:p>
         </p:txBody>
@@ -4457,7 +5087,7 @@
               </a:defRPr>
             </a:pPr>
             <a:r>
-              <a:t>TRIPLE-RUNTIME BACKEND SERVERS</a:t>
+              <a:t>REAL-TIME WHAT-IF SLIDERS</a:t>
             </a:r>
           </a:p>
           <a:p>
@@ -4472,7 +5102,7 @@
               </a:defRPr>
             </a:pPr>
             <a:r>
-              <a:t>Python 3 Server (server.py):</a:t>
+              <a:t>Bidirectional Sliders (-50% to +50%):</a:t>
             </a:r>
           </a:p>
           <a:p>
@@ -4487,7 +5117,7 @@
               </a:defRPr>
             </a:pPr>
             <a:r>
-              <a:t>  Built with native http.server and sqlite3. Zero pip packages required.</a:t>
+              <a:t>  Instant continuous adjustment of Selling Price, Variable Cost, and Fixed Costs.</a:t>
             </a:r>
           </a:p>
           <a:p>
@@ -4502,7 +5132,7 @@
               </a:defRPr>
             </a:pPr>
             <a:r>
-              <a:t>Ruby Server (server.rb):</a:t>
+              <a:t>Live Delta &amp; Variance Badges:</a:t>
             </a:r>
           </a:p>
           <a:p>
@@ -4517,7 +5147,7 @@
               </a:defRPr>
             </a:pPr>
             <a:r>
-              <a:t>  Built with WEBrick and native sqlite3 gem. Zero bundler/gem installs needed.</a:t>
+              <a:t>  Computes real-time percentage shifts and absolute monetary changes against base parameters.</a:t>
             </a:r>
           </a:p>
           <a:p>
@@ -4532,7 +5162,7 @@
               </a:defRPr>
             </a:pPr>
             <a:r>
-              <a:t>Node.js Server (server.js):</a:t>
+              <a:t>Immediate Visual Curve Morphing:</a:t>
             </a:r>
           </a:p>
           <a:p>
@@ -4547,7 +5177,7 @@
               </a:defRPr>
             </a:pPr>
             <a:r>
-              <a:t>  Built with standard http, crypto, and fs modules.</a:t>
+              <a:t>  Recalculates the SVG graph at 60fps, visually shifting the intersection point along the volume axis.</a:t>
             </a:r>
           </a:p>
           <a:p>
@@ -4562,7 +5192,7 @@
               </a:defRPr>
             </a:pPr>
             <a:r>
-              <a:t>Universal Launcher (start.sh):</a:t>
+              <a:t>One-Click Baseline Restoration:</a:t>
             </a:r>
           </a:p>
           <a:p>
@@ -4577,37 +5207,7 @@
               </a:defRPr>
             </a:pPr>
             <a:r>
-              <a:t>  Auto-detects which runtime is installed on the host and starts on port 8000.</a:t>
-            </a:r>
-          </a:p>
-          <a:p>
-            <a:pPr>
-              <a:spcBef>
-                <a:spcPts val="600"/>
-              </a:spcBef>
-              <a:defRPr sz="1050" b="1">
-                <a:solidFill>
-                  <a:srgbClr val="0F172A"/>
-                </a:solidFill>
-              </a:defRPr>
-            </a:pPr>
-            <a:r>
-              <a:t>Relational SQLite Database (breakeven.db):</a:t>
-            </a:r>
-          </a:p>
-          <a:p>
-            <a:pPr>
-              <a:spcBef>
-                <a:spcPts val="100"/>
-              </a:spcBef>
-              <a:defRPr sz="950">
-                <a:solidFill>
-                  <a:srgbClr val="64748B"/>
-                </a:solidFill>
-              </a:defRPr>
-            </a:pPr>
-            <a:r>
-              <a:t>  Structured schemas for Users (with SHA-256 tokens), Business Profiles, and Cost Inputs.</a:t>
+              <a:t>  Resets all simulation parameters back to saved user baselines without page reloads.</a:t>
             </a:r>
           </a:p>
         </p:txBody>
@@ -4661,563 +5261,127 @@
               </a:defRPr>
             </a:pPr>
             <a:r>
-              <a:t>REST API CONTRACT &amp; PERSISTENCE FLOW</a:t>
-            </a:r>
-          </a:p>
-          <a:p>
-            <a:pPr>
-              <a:spcBef>
-                <a:spcPts val="500"/>
+              <a:t>STRESS TESTING &amp; REPORT GENERATION</a:t>
+            </a:r>
+          </a:p>
+          <a:p>
+            <a:pPr>
+              <a:spcBef>
+                <a:spcPts val="600"/>
+              </a:spcBef>
+              <a:defRPr sz="1050" b="1">
+                <a:solidFill>
+                  <a:srgbClr val="0F172A"/>
+                </a:solidFill>
+              </a:defRPr>
+            </a:pPr>
+            <a:r>
+              <a:t>5-Tier Sensitivity Matrix Table:</a:t>
+            </a:r>
+          </a:p>
+          <a:p>
+            <a:pPr>
+              <a:spcBef>
+                <a:spcPts val="100"/>
               </a:spcBef>
               <a:defRPr sz="950">
                 <a:solidFill>
-                  <a:srgbClr val="0F172A"/>
-                </a:solidFill>
-              </a:defRPr>
-            </a:pPr>
-            <a:r>
-              <a:t>• POST /api/auth/signup: Registers user, hashes password, seeds default profile &amp; inputs.</a:t>
-            </a:r>
-          </a:p>
-          <a:p>
-            <a:pPr>
-              <a:spcBef>
-                <a:spcPts val="500"/>
+                  <a:srgbClr val="64748B"/>
+                </a:solidFill>
+              </a:defRPr>
+            </a:pPr>
+            <a:r>
+              <a:t>  Evaluates Required BE Units when each driver shifts by -20%, -10%, 0%, +10%, and +20%.</a:t>
+            </a:r>
+          </a:p>
+          <a:p>
+            <a:pPr>
+              <a:spcBef>
+                <a:spcPts val="600"/>
+              </a:spcBef>
+              <a:defRPr sz="1050" b="1">
+                <a:solidFill>
+                  <a:srgbClr val="0F172A"/>
+                </a:solidFill>
+              </a:defRPr>
+            </a:pPr>
+            <a:r>
+              <a:t>Volume Scenario Forecasting:</a:t>
+            </a:r>
+          </a:p>
+          <a:p>
+            <a:pPr>
+              <a:spcBef>
+                <a:spcPts val="100"/>
               </a:spcBef>
               <a:defRPr sz="950">
                 <a:solidFill>
-                  <a:srgbClr val="0F172A"/>
-                </a:solidFill>
-              </a:defRPr>
-            </a:pPr>
-            <a:r>
-              <a:t>• POST /api/auth/login: Authenticates credentials and returns a 24-byte bearer token.</a:t>
-            </a:r>
-          </a:p>
-          <a:p>
-            <a:pPr>
-              <a:spcBef>
-                <a:spcPts val="500"/>
+                  <a:srgbClr val="64748B"/>
+                </a:solidFill>
+              </a:defRPr>
+            </a:pPr>
+            <a:r>
+              <a:t>  Projects outcomes under Pessimistic (-25% volume), Expected Base, and Optimistic (+25% volume) market conditions.</a:t>
+            </a:r>
+          </a:p>
+          <a:p>
+            <a:pPr>
+              <a:spcBef>
+                <a:spcPts val="600"/>
+              </a:spcBef>
+              <a:defRPr sz="1050" b="1">
+                <a:solidFill>
+                  <a:srgbClr val="0F172A"/>
+                </a:solidFill>
+              </a:defRPr>
+            </a:pPr>
+            <a:r>
+              <a:t>Executive Printable Report:</a:t>
+            </a:r>
+          </a:p>
+          <a:p>
+            <a:pPr>
+              <a:spcBef>
+                <a:spcPts val="100"/>
               </a:spcBef>
               <a:defRPr sz="950">
                 <a:solidFill>
-                  <a:srgbClr val="0F172A"/>
-                </a:solidFill>
-              </a:defRPr>
-            </a:pPr>
-            <a:r>
-              <a:t>• GET /api/auth/me: Validates session token and returns user profile &amp; inputs.</a:t>
-            </a:r>
-          </a:p>
-          <a:p>
-            <a:pPr>
-              <a:spcBef>
-                <a:spcPts val="500"/>
+                  <a:srgbClr val="64748B"/>
+                </a:solidFill>
+              </a:defRPr>
+            </a:pPr>
+            <a:r>
+              <a:t>  Dedicated @media print layout produces clean, investor-ready PDF summaries with corporate letterheads.</a:t>
+            </a:r>
+          </a:p>
+          <a:p>
+            <a:pPr>
+              <a:spcBef>
+                <a:spcPts val="600"/>
+              </a:spcBef>
+              <a:defRPr sz="1050" b="1">
+                <a:solidFill>
+                  <a:srgbClr val="0F172A"/>
+                </a:solidFill>
+              </a:defRPr>
+            </a:pPr>
+            <a:r>
+              <a:t>Decision Support Warnings:</a:t>
+            </a:r>
+          </a:p>
+          <a:p>
+            <a:pPr>
+              <a:spcBef>
+                <a:spcPts val="100"/>
               </a:spcBef>
               <a:defRPr sz="950">
                 <a:solidFill>
-                  <a:srgbClr val="0F172A"/>
-                </a:solidFill>
-              </a:defRPr>
-            </a:pPr>
-            <a:r>
-              <a:t>• GET &amp; POST /api/profile: Retrieves and updates business metadata in SQLite3.</a:t>
-            </a:r>
-          </a:p>
-          <a:p>
-            <a:pPr>
-              <a:spcBef>
-                <a:spcPts val="500"/>
-              </a:spcBef>
-              <a:defRPr sz="950">
-                <a:solidFill>
-                  <a:srgbClr val="0F172A"/>
-                </a:solidFill>
-              </a:defRPr>
-            </a:pPr>
-            <a:r>
-              <a:t>• GET &amp; POST /api/inputs: Persists cost drivers with debounced client auto-saving.</a:t>
-            </a:r>
-          </a:p>
-          <a:p>
-            <a:pPr>
-              <a:spcBef>
-                <a:spcPts val="500"/>
-              </a:spcBef>
-              <a:defRPr sz="950">
-                <a:solidFill>
-                  <a:srgbClr val="0F172A"/>
-                </a:solidFill>
-              </a:defRPr>
-            </a:pPr>
-            <a:r>
-              <a:t>• POST /api/calculate: Server-side verification of mathematical break-even model.</a:t>
-            </a:r>
-          </a:p>
-          <a:p>
-            <a:pPr>
-              <a:spcBef>
-                <a:spcPts val="800"/>
-              </a:spcBef>
-              <a:defRPr sz="1050" b="1">
-                <a:solidFill>
-                  <a:srgbClr val="7C3AED"/>
-                </a:solidFill>
-              </a:defRPr>
-            </a:pPr>
-            <a:r>
-              <a:t>Dual-Engine Resilience Logic:</a:t>
-            </a:r>
-          </a:p>
-          <a:p>
-            <a:pPr>
-              <a:spcBef>
-                <a:spcPts val="100"/>
-              </a:spcBef>
-              <a:defRPr sz="900">
-                <a:solidFill>
                   <a:srgbClr val="64748B"/>
                 </a:solidFill>
               </a:defRPr>
             </a:pPr>
             <a:r>
-              <a:t>The ApiClient probes /api/health. If connected, data writes to SQLite3; if the server is offline or opened as file://, it gracefully falls back to localStorage.</a:t>
-            </a:r>
-          </a:p>
-        </p:txBody>
-      </p:sp>
-    </p:spTree>
-  </p:cSld>
-  <p:clrMapOvr>
-    <a:masterClrMapping/>
-  </p:clrMapOvr>
-</p:sld>
-</file>
-
-<file path=ppt/slides/slide6.xml><?xml version="1.0" encoding="utf-8"?>
-<p:sld xmlns:a="http://schemas.openxmlformats.org/drawingml/2006/main" xmlns:p="http://schemas.openxmlformats.org/presentationml/2006/main" xmlns:r="http://schemas.openxmlformats.org/officeDocument/2006/relationships">
-  <p:cSld>
-    <p:spTree>
-      <p:nvGrpSpPr>
-        <p:cNvPr id="1" name=""/>
-        <p:cNvGrpSpPr/>
-        <p:nvPr/>
-      </p:nvGrpSpPr>
-      <p:grpSpPr/>
-      <p:sp>
-        <p:nvSpPr>
-          <p:cNvPr id="2" name="TextBox 1"/>
-          <p:cNvSpPr txBox="1"/>
-          <p:nvPr/>
-        </p:nvSpPr>
-        <p:spPr>
-          <a:xfrm>
-            <a:off x="731520" y="365760"/>
-            <a:ext cx="10698480" cy="320040"/>
-          </a:xfrm>
-          <a:prstGeom prst="rect">
-            <a:avLst/>
-          </a:prstGeom>
-          <a:noFill/>
-        </p:spPr>
-        <p:txBody>
-          <a:bodyPr wrap="square">
-            <a:spAutoFit/>
-          </a:bodyPr>
-          <a:lstStyle/>
-          <a:p>
-            <a:pPr>
-              <a:defRPr sz="1100" b="1">
-                <a:solidFill>
-                  <a:srgbClr val="2563EB"/>
-                </a:solidFill>
-              </a:defRPr>
-            </a:pPr>
-            <a:r>
-              <a:t>ANALYTICS ENGINE</a:t>
-            </a:r>
-          </a:p>
-        </p:txBody>
-      </p:sp>
-      <p:sp>
-        <p:nvSpPr>
-          <p:cNvPr id="3" name="TextBox 2"/>
-          <p:cNvSpPr txBox="1"/>
-          <p:nvPr/>
-        </p:nvSpPr>
-        <p:spPr>
-          <a:xfrm>
-            <a:off x="731520" y="640080"/>
-            <a:ext cx="10698480" cy="594360"/>
-          </a:xfrm>
-          <a:prstGeom prst="rect">
-            <a:avLst/>
-          </a:prstGeom>
-          <a:noFill/>
-        </p:spPr>
-        <p:txBody>
-          <a:bodyPr wrap="square">
-            <a:spAutoFit/>
-          </a:bodyPr>
-          <a:lstStyle/>
-          <a:p>
-            <a:pPr>
-              <a:defRPr sz="2400" b="1">
-                <a:solidFill>
-                  <a:srgbClr val="0F172A"/>
-                </a:solidFill>
-              </a:defRPr>
-            </a:pPr>
-            <a:r>
-              <a:t>Mathematical Model &amp; What-If Simulations</a:t>
-            </a:r>
-          </a:p>
-        </p:txBody>
-      </p:sp>
-      <p:sp>
-        <p:nvSpPr>
-          <p:cNvPr id="4" name="Rounded Rectangle 3"/>
-          <p:cNvSpPr/>
-          <p:nvPr/>
-        </p:nvSpPr>
-        <p:spPr>
-          <a:xfrm>
-            <a:off x="731520" y="1463040"/>
-            <a:ext cx="5120640" cy="4663440"/>
-          </a:xfrm>
-          <a:prstGeom prst="roundRect">
-            <a:avLst/>
-          </a:prstGeom>
-          <a:solidFill>
-            <a:srgbClr val="FFFFFF"/>
-          </a:solidFill>
-          <a:ln w="19050">
-            <a:solidFill>
-              <a:srgbClr val="E2E8F0"/>
-            </a:solidFill>
-          </a:ln>
-        </p:spPr>
-        <p:style>
-          <a:lnRef idx="1">
-            <a:schemeClr val="accent1"/>
-          </a:lnRef>
-          <a:fillRef idx="3">
-            <a:schemeClr val="accent1"/>
-          </a:fillRef>
-          <a:effectRef idx="2">
-            <a:schemeClr val="accent1"/>
-          </a:effectRef>
-          <a:fontRef idx="minor">
-            <a:schemeClr val="lt1"/>
-          </a:fontRef>
-        </p:style>
-        <p:txBody>
-          <a:bodyPr rtlCol="0" anchor="ctr" wrap="square" lIns="274320" tIns="274320"/>
-          <a:lstStyle/>
-          <a:p>
-            <a:pPr algn="ctr">
-              <a:defRPr sz="1200" b="1">
-                <a:solidFill>
-                  <a:srgbClr val="2563EB"/>
-                </a:solidFill>
-              </a:defRPr>
-            </a:pPr>
-            <a:r>
-              <a:t>FINANCIAL MODEL EQUATIONS</a:t>
-            </a:r>
-          </a:p>
-          <a:p>
-            <a:pPr>
-              <a:spcBef>
-                <a:spcPts val="400"/>
-              </a:spcBef>
-              <a:defRPr sz="950">
-                <a:solidFill>
-                  <a:srgbClr val="0F172A"/>
-                </a:solidFill>
-              </a:defRPr>
-            </a:pPr>
-            <a:r>
-              <a:t>Contribution Margin (CM): CM = Selling Price (P) - Variable Cost (V)</a:t>
-            </a:r>
-          </a:p>
-          <a:p>
-            <a:pPr>
-              <a:spcBef>
-                <a:spcPts val="400"/>
-              </a:spcBef>
-              <a:defRPr sz="950">
-                <a:solidFill>
-                  <a:srgbClr val="0F172A"/>
-                </a:solidFill>
-              </a:defRPr>
-            </a:pPr>
-            <a:r>
-              <a:t>Contribution Margin Ratio: CM% = (P - V) / P</a:t>
-            </a:r>
-          </a:p>
-          <a:p>
-            <a:pPr>
-              <a:spcBef>
-                <a:spcPts val="400"/>
-              </a:spcBef>
-              <a:defRPr sz="950">
-                <a:solidFill>
-                  <a:srgbClr val="0F172A"/>
-                </a:solidFill>
-              </a:defRPr>
-            </a:pPr>
-            <a:r>
-              <a:t>Break-Even Volume (Units): Q_BE = Fixed Costs (F) / (P - V)</a:t>
-            </a:r>
-          </a:p>
-          <a:p>
-            <a:pPr>
-              <a:spcBef>
-                <a:spcPts val="400"/>
-              </a:spcBef>
-              <a:defRPr sz="950">
-                <a:solidFill>
-                  <a:srgbClr val="0F172A"/>
-                </a:solidFill>
-              </a:defRPr>
-            </a:pPr>
-            <a:r>
-              <a:t>Break-Even Revenue: R_BE = Q_BE × P = F / CM%</a:t>
-            </a:r>
-          </a:p>
-          <a:p>
-            <a:pPr>
-              <a:spcBef>
-                <a:spcPts val="400"/>
-              </a:spcBef>
-              <a:defRPr sz="950">
-                <a:solidFill>
-                  <a:srgbClr val="0F172A"/>
-                </a:solidFill>
-              </a:defRPr>
-            </a:pPr>
-            <a:r>
-              <a:t>Net Operating Profit: Profit = Q × (P - V) - F</a:t>
-            </a:r>
-          </a:p>
-          <a:p>
-            <a:pPr>
-              <a:spcBef>
-                <a:spcPts val="400"/>
-              </a:spcBef>
-              <a:defRPr sz="950">
-                <a:solidFill>
-                  <a:srgbClr val="0F172A"/>
-                </a:solidFill>
-              </a:defRPr>
-            </a:pPr>
-            <a:r>
-              <a:t>Margin of Safety (MOS): MOS = (Q - Q_BE) / Q × 100%</a:t>
-            </a:r>
-          </a:p>
-          <a:p>
-            <a:pPr>
-              <a:spcBef>
-                <a:spcPts val="400"/>
-              </a:spcBef>
-              <a:defRPr sz="950">
-                <a:solidFill>
-                  <a:srgbClr val="0F172A"/>
-                </a:solidFill>
-              </a:defRPr>
-            </a:pPr>
-            <a:r>
-              <a:t>Degree of Operating Leverage: DOL = (Q × CM) / Profit</a:t>
-            </a:r>
-          </a:p>
-          <a:p>
-            <a:pPr>
-              <a:spcBef>
-                <a:spcPts val="400"/>
-              </a:spcBef>
-              <a:defRPr sz="950">
-                <a:solidFill>
-                  <a:srgbClr val="0F172A"/>
-                </a:solidFill>
-              </a:defRPr>
-            </a:pPr>
-            <a:r>
-              <a:t>Target Profit Units: Q_Target = (F + Target) / CM</a:t>
-            </a:r>
-          </a:p>
-        </p:txBody>
-      </p:sp>
-      <p:sp>
-        <p:nvSpPr>
-          <p:cNvPr id="5" name="Rounded Rectangle 4"/>
-          <p:cNvSpPr/>
-          <p:nvPr/>
-        </p:nvSpPr>
-        <p:spPr>
-          <a:xfrm>
-            <a:off x="6309360" y="1463040"/>
-            <a:ext cx="5120640" cy="4663440"/>
-          </a:xfrm>
-          <a:prstGeom prst="roundRect">
-            <a:avLst/>
-          </a:prstGeom>
-          <a:solidFill>
-            <a:srgbClr val="FFFFFF"/>
-          </a:solidFill>
-          <a:ln w="19050">
-            <a:solidFill>
-              <a:srgbClr val="E2E8F0"/>
-            </a:solidFill>
-          </a:ln>
-        </p:spPr>
-        <p:style>
-          <a:lnRef idx="1">
-            <a:schemeClr val="accent1"/>
-          </a:lnRef>
-          <a:fillRef idx="3">
-            <a:schemeClr val="accent1"/>
-          </a:fillRef>
-          <a:effectRef idx="2">
-            <a:schemeClr val="accent1"/>
-          </a:effectRef>
-          <a:fontRef idx="minor">
-            <a:schemeClr val="lt1"/>
-          </a:fontRef>
-        </p:style>
-        <p:txBody>
-          <a:bodyPr rtlCol="0" anchor="ctr" wrap="square" lIns="274320" tIns="274320"/>
-          <a:lstStyle/>
-          <a:p>
-            <a:pPr algn="ctr">
-              <a:defRPr sz="1200" b="1">
-                <a:solidFill>
-                  <a:srgbClr val="059669"/>
-                </a:solidFill>
-              </a:defRPr>
-            </a:pPr>
-            <a:r>
-              <a:t>WHAT-IF SIMULATIONS &amp; STRESS MATRICES</a:t>
-            </a:r>
-          </a:p>
-          <a:p>
-            <a:pPr>
-              <a:spcBef>
-                <a:spcPts val="600"/>
-              </a:spcBef>
-              <a:defRPr sz="1050" b="1">
-                <a:solidFill>
-                  <a:srgbClr val="0F172A"/>
-                </a:solidFill>
-              </a:defRPr>
-            </a:pPr>
-            <a:r>
-              <a:t>Real-Time What-If Sliders:</a:t>
-            </a:r>
-          </a:p>
-          <a:p>
-            <a:pPr>
-              <a:spcBef>
-                <a:spcPts val="100"/>
-              </a:spcBef>
-              <a:defRPr sz="950">
-                <a:solidFill>
-                  <a:srgbClr val="64748B"/>
-                </a:solidFill>
-              </a:defRPr>
-            </a:pPr>
-            <a:r>
-              <a:t>  Dual-direction sliders (-50% to +50%) for Price, Var Cost, and Fixed Costs compute live variances versus baseline.</a:t>
-            </a:r>
-          </a:p>
-          <a:p>
-            <a:pPr>
-              <a:spcBef>
-                <a:spcPts val="600"/>
-              </a:spcBef>
-              <a:defRPr sz="1050" b="1">
-                <a:solidFill>
-                  <a:srgbClr val="0F172A"/>
-                </a:solidFill>
-              </a:defRPr>
-            </a:pPr>
-            <a:r>
-              <a:t>Sensitivity Matrix Table:</a:t>
-            </a:r>
-          </a:p>
-          <a:p>
-            <a:pPr>
-              <a:spcBef>
-                <a:spcPts val="100"/>
-              </a:spcBef>
-              <a:defRPr sz="950">
-                <a:solidFill>
-                  <a:srgbClr val="64748B"/>
-                </a:solidFill>
-              </a:defRPr>
-            </a:pPr>
-            <a:r>
-              <a:t>  Evaluates Required BE Units when each driver shifts by -20%, -10%, 0%, +10%, and +20%.</a:t>
-            </a:r>
-          </a:p>
-          <a:p>
-            <a:pPr>
-              <a:spcBef>
-                <a:spcPts val="600"/>
-              </a:spcBef>
-              <a:defRPr sz="1050" b="1">
-                <a:solidFill>
-                  <a:srgbClr val="0F172A"/>
-                </a:solidFill>
-              </a:defRPr>
-            </a:pPr>
-            <a:r>
-              <a:t>Volume Scenario Table:</a:t>
-            </a:r>
-          </a:p>
-          <a:p>
-            <a:pPr>
-              <a:spcBef>
-                <a:spcPts val="100"/>
-              </a:spcBef>
-              <a:defRPr sz="950">
-                <a:solidFill>
-                  <a:srgbClr val="64748B"/>
-                </a:solidFill>
-              </a:defRPr>
-            </a:pPr>
-            <a:r>
-              <a:t>  Projects outcomes under Pessimistic (-25% volume), Expected Base, and Optimistic (+25% volume) market conditions.</a:t>
-            </a:r>
-          </a:p>
-          <a:p>
-            <a:pPr>
-              <a:spcBef>
-                <a:spcPts val="600"/>
-              </a:spcBef>
-              <a:defRPr sz="1050" b="1">
-                <a:solidFill>
-                  <a:srgbClr val="0F172A"/>
-                </a:solidFill>
-              </a:defRPr>
-            </a:pPr>
-            <a:r>
-              <a:t>Automated Feasibility Guards:</a:t>
-            </a:r>
-          </a:p>
-          <a:p>
-            <a:pPr>
-              <a:spcBef>
-                <a:spcPts val="100"/>
-              </a:spcBef>
-              <a:defRPr sz="950">
-                <a:solidFill>
-                  <a:srgbClr val="64748B"/>
-                </a:solidFill>
-              </a:defRPr>
-            </a:pPr>
-            <a:r>
-              <a:t>  Immediately detects and warns if Price ≤ Variable Cost (structural loss condition) or if planned volume Q &lt; Q_BE.</a:t>
+              <a:t>  Alerts decision-makers when fixed costs exceed safe coverage thresholds.</a:t>
             </a:r>
           </a:p>
         </p:txBody>

</xml_diff>

<commit_message>
Add high-resolution scannable QR codes for live deployment and embed into slides, web app, and README
</commit_message>
<xml_diff>
--- a/Break-Even-Project-Presentation.pptx
+++ b/Break-Even-Project-Presentation.pptx
@@ -3213,7 +3213,7 @@
         <p:spPr>
           <a:xfrm>
             <a:off x="1097280" y="3291840"/>
-            <a:ext cx="5303520" cy="2468880"/>
+            <a:ext cx="3931920" cy="2468880"/>
           </a:xfrm>
           <a:prstGeom prst="roundRect">
             <a:avLst/>
@@ -3242,11 +3242,11 @@
           </a:fontRef>
         </p:style>
         <p:txBody>
-          <a:bodyPr rtlCol="0" anchor="ctr" wrap="square" lIns="228600" tIns="182880"/>
+          <a:bodyPr rtlCol="0" anchor="ctr" wrap="square" lIns="182880" tIns="164592"/>
           <a:lstStyle/>
           <a:p>
             <a:pPr algn="ctr">
-              <a:defRPr sz="1100" b="1">
+              <a:defRPr sz="1050" b="1">
                 <a:solidFill>
                   <a:srgbClr val="2563EB"/>
                 </a:solidFill>
@@ -3259,83 +3259,167 @@
           <a:p>
             <a:pPr>
               <a:spcBef>
-                <a:spcPts val="300"/>
-              </a:spcBef>
-              <a:defRPr sz="1000">
-                <a:solidFill>
-                  <a:srgbClr val="0F172A"/>
-                </a:solidFill>
-              </a:defRPr>
-            </a:pPr>
-            <a:r>
-              <a:t>Student / Developer: arjun2007arush2011-max</a:t>
-            </a:r>
-          </a:p>
-          <a:p>
-            <a:pPr>
-              <a:spcBef>
-                <a:spcPts val="300"/>
-              </a:spcBef>
-              <a:defRPr sz="1000">
-                <a:solidFill>
-                  <a:srgbClr val="0F172A"/>
-                </a:solidFill>
-              </a:defRPr>
-            </a:pPr>
-            <a:r>
-              <a:t>Live Web Application: https://arjun2007arush2011-max.github.io/break_even_point/</a:t>
-            </a:r>
-          </a:p>
-          <a:p>
-            <a:pPr>
-              <a:spcBef>
-                <a:spcPts val="300"/>
-              </a:spcBef>
-              <a:defRPr sz="1000">
-                <a:solidFill>
-                  <a:srgbClr val="0F172A"/>
-                </a:solidFill>
-              </a:defRPr>
-            </a:pPr>
-            <a:r>
-              <a:t>GitHub Repository: https://github.com/arjun2007arush2011-max/break_even_point</a:t>
-            </a:r>
-          </a:p>
-          <a:p>
-            <a:pPr>
-              <a:spcBef>
-                <a:spcPts val="300"/>
-              </a:spcBef>
-              <a:defRPr sz="1000">
-                <a:solidFill>
-                  <a:srgbClr val="0F172A"/>
-                </a:solidFill>
-              </a:defRPr>
-            </a:pPr>
-            <a:r>
-              <a:t>Domain: FinTech &amp; Decision Support Systems</a:t>
-            </a:r>
-          </a:p>
-          <a:p>
-            <a:pPr>
-              <a:spcBef>
-                <a:spcPts val="300"/>
-              </a:spcBef>
-              <a:defRPr sz="1000">
-                <a:solidFill>
-                  <a:srgbClr val="0F172A"/>
-                </a:solidFill>
-              </a:defRPr>
-            </a:pPr>
-            <a:r>
-              <a:t>Architecture: Client-Side Zero-Dependency + REST Backends</a:t>
+                <a:spcPts val="250"/>
+              </a:spcBef>
+              <a:defRPr sz="900">
+                <a:solidFill>
+                  <a:srgbClr val="0F172A"/>
+                </a:solidFill>
+              </a:defRPr>
+            </a:pPr>
+            <a:r>
+              <a:t>Developer: arjun2007arush2011-max</a:t>
+            </a:r>
+          </a:p>
+          <a:p>
+            <a:pPr>
+              <a:spcBef>
+                <a:spcPts val="250"/>
+              </a:spcBef>
+              <a:defRPr sz="900">
+                <a:solidFill>
+                  <a:srgbClr val="0F172A"/>
+                </a:solidFill>
+              </a:defRPr>
+            </a:pPr>
+            <a:r>
+              <a:t>Domain: FinTech &amp; Decision Systems</a:t>
+            </a:r>
+          </a:p>
+          <a:p>
+            <a:pPr>
+              <a:spcBef>
+                <a:spcPts val="250"/>
+              </a:spcBef>
+              <a:defRPr sz="900">
+                <a:solidFill>
+                  <a:srgbClr val="0F172A"/>
+                </a:solidFill>
+              </a:defRPr>
+            </a:pPr>
+            <a:r>
+              <a:t>Architecture: Client Vanilla ES5 + REST</a:t>
+            </a:r>
+          </a:p>
+          <a:p>
+            <a:pPr>
+              <a:spcBef>
+                <a:spcPts val="250"/>
+              </a:spcBef>
+              <a:defRPr sz="900">
+                <a:solidFill>
+                  <a:srgbClr val="0F172A"/>
+                </a:solidFill>
+              </a:defRPr>
+            </a:pPr>
+            <a:r>
+              <a:t>Backends: Python 3 / Ruby / Node.js</a:t>
+            </a:r>
+          </a:p>
+          <a:p>
+            <a:pPr>
+              <a:spcBef>
+                <a:spcPts val="250"/>
+              </a:spcBef>
+              <a:defRPr sz="900">
+                <a:solidFill>
+                  <a:srgbClr val="0F172A"/>
+                </a:solidFill>
+              </a:defRPr>
+            </a:pPr>
+            <a:r>
+              <a:t>Database: SQLite3 + LocalStorage</a:t>
+            </a:r>
+          </a:p>
+          <a:p>
+            <a:pPr>
+              <a:spcBef>
+                <a:spcPts val="250"/>
+              </a:spcBef>
+              <a:defRPr sz="900">
+                <a:solidFill>
+                  <a:srgbClr val="0F172A"/>
+                </a:solidFill>
+              </a:defRPr>
+            </a:pPr>
+            <a:r>
+              <a:t>Live Web App: GitHub Pages Hosted</a:t>
+            </a:r>
+          </a:p>
+        </p:txBody>
+      </p:sp>
+      <p:sp>
+        <p:nvSpPr>
+          <p:cNvPr id="5" name="Rounded Rectangle 4"/>
+          <p:cNvSpPr/>
+          <p:nvPr/>
+        </p:nvSpPr>
+        <p:spPr>
+          <a:xfrm>
+            <a:off x="5166360" y="3291840"/>
+            <a:ext cx="1280160" cy="2468880"/>
+          </a:xfrm>
+          <a:prstGeom prst="roundRect">
+            <a:avLst/>
+          </a:prstGeom>
+          <a:solidFill>
+            <a:srgbClr val="FFFFFF"/>
+          </a:solidFill>
+          <a:ln w="19050">
+            <a:solidFill>
+              <a:srgbClr val="E2E8F0"/>
+            </a:solidFill>
+          </a:ln>
+        </p:spPr>
+        <p:style>
+          <a:lnRef idx="1">
+            <a:schemeClr val="accent1"/>
+          </a:lnRef>
+          <a:fillRef idx="3">
+            <a:schemeClr val="accent1"/>
+          </a:fillRef>
+          <a:effectRef idx="2">
+            <a:schemeClr val="accent1"/>
+          </a:effectRef>
+          <a:fontRef idx="minor">
+            <a:schemeClr val="lt1"/>
+          </a:fontRef>
+        </p:style>
+        <p:txBody>
+          <a:bodyPr rtlCol="0" anchor="ctr" wrap="square" lIns="73152" tIns="109728"/>
+          <a:lstStyle/>
+          <a:p>
+            <a:pPr algn="ctr">
+              <a:defRPr sz="900" b="1">
+                <a:solidFill>
+                  <a:srgbClr val="2563EB"/>
+                </a:solidFill>
+              </a:defRPr>
+            </a:pPr>
+            <a:r>
+              <a:t>SCAN LIVE</a:t>
+            </a:r>
+          </a:p>
+          <a:p>
+            <a:pPr algn="ctr">
+              <a:spcBef>
+                <a:spcPts val="9200"/>
+              </a:spcBef>
+              <a:defRPr sz="750">
+                <a:solidFill>
+                  <a:srgbClr val="64748B"/>
+                </a:solidFill>
+              </a:defRPr>
+            </a:pPr>
+            <a:r>
+              <a:t>Test on Phone</a:t>
             </a:r>
           </a:p>
         </p:txBody>
       </p:sp>
       <p:pic>
         <p:nvPicPr>
-          <p:cNvPr id="5" name="Picture 4" descr="screenshot_dashboard.png"/>
+          <p:cNvPr id="6" name="Picture 5" descr="qrcode_live.png"/>
           <p:cNvPicPr>
             <a:picLocks noChangeAspect="1"/>
           </p:cNvPicPr>
@@ -3343,6 +3427,30 @@
         </p:nvPicPr>
         <p:blipFill>
           <a:blip r:embed="rId2"/>
+          <a:stretch>
+            <a:fillRect/>
+          </a:stretch>
+        </p:blipFill>
+        <p:spPr>
+          <a:xfrm>
+            <a:off x="5257800" y="3611880"/>
+            <a:ext cx="1097280" cy="1097280"/>
+          </a:xfrm>
+          <a:prstGeom prst="rect">
+            <a:avLst/>
+          </a:prstGeom>
+        </p:spPr>
+      </p:pic>
+      <p:pic>
+        <p:nvPicPr>
+          <p:cNvPr id="7" name="Picture 6" descr="screenshot_dashboard.png"/>
+          <p:cNvPicPr>
+            <a:picLocks noChangeAspect="1"/>
+          </p:cNvPicPr>
+          <p:nvPr/>
+        </p:nvPicPr>
+        <p:blipFill>
+          <a:blip r:embed="rId3"/>
           <a:stretch>
             <a:fillRect/>
           </a:stretch>
@@ -5483,7 +5591,7 @@
         <p:spPr>
           <a:xfrm>
             <a:off x="731520" y="1463040"/>
-            <a:ext cx="5120640" cy="4663440"/>
+            <a:ext cx="4114800" cy="4663440"/>
           </a:xfrm>
           <a:prstGeom prst="roundRect">
             <a:avLst/>
@@ -5512,11 +5620,11 @@
           </a:fontRef>
         </p:style>
         <p:txBody>
-          <a:bodyPr rtlCol="0" anchor="ctr" wrap="square" lIns="274320" tIns="274320"/>
+          <a:bodyPr rtlCol="0" anchor="ctr" wrap="square" lIns="228600" tIns="228600"/>
           <a:lstStyle/>
           <a:p>
             <a:pPr algn="ctr">
-              <a:defRPr sz="1200" b="1">
+              <a:defRPr sz="1100" b="1">
                 <a:solidFill>
                   <a:srgbClr val="2563EB"/>
                 </a:solidFill>
@@ -5529,24 +5637,24 @@
           <a:p>
             <a:pPr>
               <a:spcBef>
-                <a:spcPts val="700"/>
-              </a:spcBef>
-              <a:defRPr sz="1050">
-                <a:solidFill>
-                  <a:srgbClr val="0F172A"/>
-                </a:solidFill>
-              </a:defRPr>
-            </a:pPr>
-            <a:r>
-              <a:t>✔ Live Production Deployment: Successfully deployed and hosted globally on GitHub Pages at https://arjun2007arush2011-max.github.io/break_even_point/</a:t>
-            </a:r>
-          </a:p>
-          <a:p>
-            <a:pPr>
-              <a:spcBef>
-                <a:spcPts val="700"/>
-              </a:spcBef>
-              <a:defRPr sz="1050">
+                <a:spcPts val="600"/>
+              </a:spcBef>
+              <a:defRPr sz="950">
+                <a:solidFill>
+                  <a:srgbClr val="0F172A"/>
+                </a:solidFill>
+              </a:defRPr>
+            </a:pPr>
+            <a:r>
+              <a:t>✔ Live Production Deployment: Successfully deployed globally on GitHub Pages at https://arjun2007arush2011-max.github.io/break_even_point/</a:t>
+            </a:r>
+          </a:p>
+          <a:p>
+            <a:pPr>
+              <a:spcBef>
+                <a:spcPts val="600"/>
+              </a:spcBef>
+              <a:defRPr sz="950">
                 <a:solidFill>
                   <a:srgbClr val="0F172A"/>
                 </a:solidFill>
@@ -5559,9 +5667,9 @@
           <a:p>
             <a:pPr>
               <a:spcBef>
-                <a:spcPts val="700"/>
-              </a:spcBef>
-              <a:defRPr sz="1050">
+                <a:spcPts val="600"/>
+              </a:spcBef>
+              <a:defRPr sz="950">
                 <a:solidFill>
                   <a:srgbClr val="0F172A"/>
                 </a:solidFill>
@@ -5574,9 +5682,9 @@
           <a:p>
             <a:pPr>
               <a:spcBef>
-                <a:spcPts val="700"/>
-              </a:spcBef>
-              <a:defRPr sz="1050">
+                <a:spcPts val="600"/>
+              </a:spcBef>
+              <a:defRPr sz="950">
                 <a:solidFill>
                   <a:srgbClr val="0F172A"/>
                 </a:solidFill>
@@ -5589,9 +5697,9 @@
           <a:p>
             <a:pPr>
               <a:spcBef>
-                <a:spcPts val="700"/>
-              </a:spcBef>
-              <a:defRPr sz="1050">
+                <a:spcPts val="600"/>
+              </a:spcBef>
+              <a:defRPr sz="950">
                 <a:solidFill>
                   <a:srgbClr val="0F172A"/>
                 </a:solidFill>
@@ -5611,8 +5719,8 @@
         </p:nvSpPr>
         <p:spPr>
           <a:xfrm>
-            <a:off x="6309360" y="1463040"/>
-            <a:ext cx="5120640" cy="4663440"/>
+            <a:off x="5029200" y="1463040"/>
+            <a:ext cx="4114800" cy="4663440"/>
           </a:xfrm>
           <a:prstGeom prst="roundRect">
             <a:avLst/>
@@ -5641,11 +5749,11 @@
           </a:fontRef>
         </p:style>
         <p:txBody>
-          <a:bodyPr rtlCol="0" anchor="ctr" wrap="square" lIns="274320" tIns="274320"/>
+          <a:bodyPr rtlCol="0" anchor="ctr" wrap="square" lIns="228600" tIns="228600"/>
           <a:lstStyle/>
           <a:p>
             <a:pPr algn="ctr">
-              <a:defRPr sz="1200" b="1">
+              <a:defRPr sz="1100" b="1">
                 <a:solidFill>
                   <a:srgbClr val="059669"/>
                 </a:solidFill>
@@ -5660,7 +5768,7 @@
               <a:spcBef>
                 <a:spcPts val="600"/>
               </a:spcBef>
-              <a:defRPr sz="1050" b="1">
+              <a:defRPr sz="950" b="1">
                 <a:solidFill>
                   <a:srgbClr val="0F172A"/>
                 </a:solidFill>
@@ -5675,7 +5783,7 @@
               <a:spcBef>
                 <a:spcPts val="100"/>
               </a:spcBef>
-              <a:defRPr sz="950">
+              <a:defRPr sz="850">
                 <a:solidFill>
                   <a:srgbClr val="64748B"/>
                 </a:solidFill>
@@ -5690,7 +5798,7 @@
               <a:spcBef>
                 <a:spcPts val="600"/>
               </a:spcBef>
-              <a:defRPr sz="1050" b="1">
+              <a:defRPr sz="950" b="1">
                 <a:solidFill>
                   <a:srgbClr val="0F172A"/>
                 </a:solidFill>
@@ -5705,7 +5813,7 @@
               <a:spcBef>
                 <a:spcPts val="100"/>
               </a:spcBef>
-              <a:defRPr sz="950">
+              <a:defRPr sz="850">
                 <a:solidFill>
                   <a:srgbClr val="64748B"/>
                 </a:solidFill>
@@ -5720,7 +5828,7 @@
               <a:spcBef>
                 <a:spcPts val="600"/>
               </a:spcBef>
-              <a:defRPr sz="1050" b="1">
+              <a:defRPr sz="950" b="1">
                 <a:solidFill>
                   <a:srgbClr val="0F172A"/>
                 </a:solidFill>
@@ -5735,7 +5843,7 @@
               <a:spcBef>
                 <a:spcPts val="100"/>
               </a:spcBef>
-              <a:defRPr sz="950">
+              <a:defRPr sz="850">
                 <a:solidFill>
                   <a:srgbClr val="64748B"/>
                 </a:solidFill>
@@ -5750,14 +5858,14 @@
               <a:spcBef>
                 <a:spcPts val="600"/>
               </a:spcBef>
-              <a:defRPr sz="1050" b="1">
-                <a:solidFill>
-                  <a:srgbClr val="0F172A"/>
-                </a:solidFill>
-              </a:defRPr>
-            </a:pPr>
-            <a:r>
-              <a:t>Live Demonstration URL:</a:t>
+              <a:defRPr sz="950" b="1">
+                <a:solidFill>
+                  <a:srgbClr val="0F172A"/>
+                </a:solidFill>
+              </a:defRPr>
+            </a:pPr>
+            <a:r>
+              <a:t>Open-Source Codebase:</a:t>
             </a:r>
           </a:p>
           <a:p>
@@ -5765,18 +5873,169 @@
               <a:spcBef>
                 <a:spcPts val="100"/>
               </a:spcBef>
-              <a:defRPr sz="950">
+              <a:defRPr sz="850">
                 <a:solidFill>
                   <a:srgbClr val="64748B"/>
                 </a:solidFill>
               </a:defRPr>
             </a:pPr>
             <a:r>
-              <a:t>  https://arjun2007arush2011-max.github.io/break_even_point/</a:t>
-            </a:r>
-          </a:p>
-        </p:txBody>
-      </p:sp>
+              <a:t>  Complete source code, multi-runtime backends, and documentation publicly available.</a:t>
+            </a:r>
+          </a:p>
+        </p:txBody>
+      </p:sp>
+      <p:sp>
+        <p:nvSpPr>
+          <p:cNvPr id="6" name="Rounded Rectangle 5"/>
+          <p:cNvSpPr/>
+          <p:nvPr/>
+        </p:nvSpPr>
+        <p:spPr>
+          <a:xfrm>
+            <a:off x="9326880" y="1463040"/>
+            <a:ext cx="2103120" cy="4663440"/>
+          </a:xfrm>
+          <a:prstGeom prst="roundRect">
+            <a:avLst/>
+          </a:prstGeom>
+          <a:solidFill>
+            <a:srgbClr val="F8FAFC"/>
+          </a:solidFill>
+          <a:ln w="19050">
+            <a:solidFill>
+              <a:srgbClr val="2563EB"/>
+            </a:solidFill>
+          </a:ln>
+        </p:spPr>
+        <p:style>
+          <a:lnRef idx="1">
+            <a:schemeClr val="accent1"/>
+          </a:lnRef>
+          <a:fillRef idx="3">
+            <a:schemeClr val="accent1"/>
+          </a:fillRef>
+          <a:effectRef idx="2">
+            <a:schemeClr val="accent1"/>
+          </a:effectRef>
+          <a:fontRef idx="minor">
+            <a:schemeClr val="lt1"/>
+          </a:fontRef>
+        </p:style>
+        <p:txBody>
+          <a:bodyPr rtlCol="0" anchor="ctr" wrap="square" lIns="109728" tIns="164592"/>
+          <a:lstStyle/>
+          <a:p>
+            <a:pPr algn="ctr">
+              <a:defRPr sz="1100" b="1">
+                <a:solidFill>
+                  <a:srgbClr val="2563EB"/>
+                </a:solidFill>
+              </a:defRPr>
+            </a:pPr>
+            <a:r>
+              <a:t>TEST LIVE DEMO</a:t>
+            </a:r>
+          </a:p>
+          <a:p>
+            <a:pPr algn="ctr">
+              <a:spcBef>
+                <a:spcPts val="200"/>
+              </a:spcBef>
+              <a:defRPr sz="800">
+                <a:solidFill>
+                  <a:srgbClr val="64748B"/>
+                </a:solidFill>
+              </a:defRPr>
+            </a:pPr>
+            <a:r>
+              <a:t>Scan with your phone:</a:t>
+            </a:r>
+          </a:p>
+          <a:p>
+            <a:pPr algn="ctr">
+              <a:spcBef>
+                <a:spcPts val="14000"/>
+              </a:spcBef>
+              <a:defRPr sz="950" b="1">
+                <a:solidFill>
+                  <a:srgbClr val="0F172A"/>
+                </a:solidFill>
+              </a:defRPr>
+            </a:pPr>
+            <a:r>
+              <a:t>Live Web App</a:t>
+            </a:r>
+          </a:p>
+          <a:p>
+            <a:pPr algn="ctr">
+              <a:defRPr sz="750">
+                <a:solidFill>
+                  <a:srgbClr val="2563EB"/>
+                </a:solidFill>
+              </a:defRPr>
+            </a:pPr>
+            <a:r>
+              <a:t>github.io/break_even_point</a:t>
+            </a:r>
+          </a:p>
+          <a:p>
+            <a:pPr algn="ctr">
+              <a:spcBef>
+                <a:spcPts val="800"/>
+              </a:spcBef>
+              <a:defRPr sz="800">
+                <a:solidFill>
+                  <a:srgbClr val="64748B"/>
+                </a:solidFill>
+              </a:defRPr>
+            </a:pPr>
+            <a:r>
+              <a:t>GitHub Repository:</a:t>
+            </a:r>
+          </a:p>
+          <a:p>
+            <a:pPr algn="ctr">
+              <a:defRPr sz="750" b="1">
+                <a:solidFill>
+                  <a:srgbClr val="0F172A"/>
+                </a:solidFill>
+              </a:defRPr>
+            </a:pPr>
+            <a:r>
+              <a:t>arjun2007arush2011-max</a:t>
+            </a:r>
+            <a:br/>
+            <a:r>
+              <a:t>/break_even_point</a:t>
+            </a:r>
+          </a:p>
+        </p:txBody>
+      </p:sp>
+      <p:pic>
+        <p:nvPicPr>
+          <p:cNvPr id="7" name="Picture 6" descr="qrcode_live.png"/>
+          <p:cNvPicPr>
+            <a:picLocks noChangeAspect="1"/>
+          </p:cNvPicPr>
+          <p:nvPr/>
+        </p:nvPicPr>
+        <p:blipFill>
+          <a:blip r:embed="rId2"/>
+          <a:stretch>
+            <a:fillRect/>
+          </a:stretch>
+        </p:blipFill>
+        <p:spPr>
+          <a:xfrm>
+            <a:off x="9555480" y="2148840"/>
+            <a:ext cx="1645920" cy="1645920"/>
+          </a:xfrm>
+          <a:prstGeom prst="rect">
+            <a:avLst/>
+          </a:prstGeom>
+        </p:spPr>
+      </p:pic>
     </p:spTree>
   </p:cSld>
   <p:clrMapOvr>

</xml_diff>

<commit_message>
Add 6 pre-loaded industry templates with 1-click quick-load pills and toast notifications
</commit_message>
<xml_diff>
--- a/Break-Even-Project-Presentation.pptx
+++ b/Break-Even-Project-Presentation.pptx
@@ -5384,6 +5384,36 @@
               </a:defRPr>
             </a:pPr>
             <a:r>
+              <a:t>Pre-Loaded Industry Presets:</a:t>
+            </a:r>
+          </a:p>
+          <a:p>
+            <a:pPr>
+              <a:spcBef>
+                <a:spcPts val="100"/>
+              </a:spcBef>
+              <a:defRPr sz="950">
+                <a:solidFill>
+                  <a:srgbClr val="64748B"/>
+                </a:solidFill>
+              </a:defRPr>
+            </a:pPr>
+            <a:r>
+              <a:t>  1-click templates for Cafe, SaaS, E-Commerce, Manufacturing, Clinic, and Agency.</a:t>
+            </a:r>
+          </a:p>
+          <a:p>
+            <a:pPr>
+              <a:spcBef>
+                <a:spcPts val="600"/>
+              </a:spcBef>
+              <a:defRPr sz="1050" b="1">
+                <a:solidFill>
+                  <a:srgbClr val="0F172A"/>
+                </a:solidFill>
+              </a:defRPr>
+            </a:pPr>
+            <a:r>
               <a:t>5-Tier Sensitivity Matrix Table:</a:t>
             </a:r>
           </a:p>
@@ -5459,37 +5489,7 @@
               </a:defRPr>
             </a:pPr>
             <a:r>
-              <a:t>  Dedicated @media print layout produces clean, investor-ready PDF summaries with corporate letterheads.</a:t>
-            </a:r>
-          </a:p>
-          <a:p>
-            <a:pPr>
-              <a:spcBef>
-                <a:spcPts val="600"/>
-              </a:spcBef>
-              <a:defRPr sz="1050" b="1">
-                <a:solidFill>
-                  <a:srgbClr val="0F172A"/>
-                </a:solidFill>
-              </a:defRPr>
-            </a:pPr>
-            <a:r>
-              <a:t>Decision Support Warnings:</a:t>
-            </a:r>
-          </a:p>
-          <a:p>
-            <a:pPr>
-              <a:spcBef>
-                <a:spcPts val="100"/>
-              </a:spcBef>
-              <a:defRPr sz="950">
-                <a:solidFill>
-                  <a:srgbClr val="64748B"/>
-                </a:solidFill>
-              </a:defRPr>
-            </a:pPr>
-            <a:r>
-              <a:t>  Alerts decision-makers when fixed costs exceed safe coverage thresholds.</a:t>
+              <a:t>  Dedicated @media print layout with letterhead and scannable mobile QR code.</a:t>
             </a:r>
           </a:p>
         </p:txBody>

</xml_diff>